<commit_message>
docs: update sales playbook pptx with latest version
Previous version remains available at 43cf251.

Co-Authored-By: Claude Fable 5 <noreply@anthropic.com>
</commit_message>
<xml_diff>
--- a/sales/Dispango-sales-playbook.pptx
+++ b/sales/Dispango-sales-playbook.pptx
@@ -4,19 +4,20 @@
   <p:sldMasterIdLst>
     <p:sldMasterId id="2147483648" r:id="rId1"/>
   </p:sldMasterIdLst>
+  <p:notesMasterIdLst>
+    <p:notesMasterId r:id="rId11"/>
+  </p:notesMasterIdLst>
   <p:sldIdLst>
-    <p:sldId id="256" r:id="rId2"/>
-    <p:sldId id="257" r:id="rId3"/>
-    <p:sldId id="258" r:id="rId4"/>
-    <p:sldId id="259" r:id="rId5"/>
-    <p:sldId id="260" r:id="rId6"/>
-    <p:sldId id="261" r:id="rId7"/>
-    <p:sldId id="262" r:id="rId8"/>
-    <p:sldId id="263" r:id="rId9"/>
+    <p:sldId id="283" r:id="rId2"/>
+    <p:sldId id="284" r:id="rId3"/>
+    <p:sldId id="285" r:id="rId4"/>
+    <p:sldId id="287" r:id="rId5"/>
+    <p:sldId id="288" r:id="rId6"/>
+    <p:sldId id="289" r:id="rId7"/>
+    <p:sldId id="290" r:id="rId8"/>
+    <p:sldId id="291" r:id="rId9"/>
+    <p:sldId id="292" r:id="rId10"/>
   </p:sldIdLst>
-  <p:notesMasterIdLst>
-    <p:notesMasterId r:id="rId10"/>
-  </p:notesMasterIdLst>
   <p:sldSz cx="7772400" cy="10058400"/>
   <p:notesSz cx="10058400" cy="7772400"/>
   <p:defaultTextStyle>
@@ -111,6 +112,11 @@
       </a:defRPr>
     </a:lvl9pPr>
   </p:defaultTextStyle>
+  <p:extLst>
+    <p:ext uri="{EFAFB233-063F-42B5-8137-9DF3F51BA10A}">
+      <p15:sldGuideLst xmlns:p15="http://schemas.microsoft.com/office/powerpoint/2012/main"/>
+    </p:ext>
+  </p:extLst>
 </p:presentation>
 </file>
 
@@ -136,234 +142,10 @@
           <a:chExt cx="0" cy="0"/>
         </a:xfrm>
       </p:grpSpPr>
-      <p:sp>
-        <p:nvSpPr>
-          <p:cNvPr id="2" name="Header Placeholder 1"/>
-          <p:cNvSpPr>
-            <a:spLocks noGrp="1"/>
-          </p:cNvSpPr>
-          <p:nvPr>
-            <p:ph type="hdr" sz="quarter"/>
-          </p:nvPr>
-        </p:nvSpPr>
-        <p:spPr>
-          <a:xfrm>
-            <a:off x="0" y="0"/>
-            <a:ext cx="2971800" cy="458788"/>
-          </a:xfrm>
-          <a:prstGeom prst="rect">
-            <a:avLst/>
-          </a:prstGeom>
-        </p:spPr>
-        <p:txBody>
-          <a:bodyPr vert="horz" lIns="91440" tIns="45720" rIns="91440" bIns="45720" rtlCol="0"/>
-          <a:lstStyle>
-            <a:lvl1pPr algn="l">
-              <a:defRPr sz="1200"/>
-            </a:lvl1pPr>
-          </a:lstStyle>
-          <a:p>
-            <a:endParaRPr lang="en-US"/>
-          </a:p>
-        </p:txBody>
-      </p:sp>
-      <p:sp>
-        <p:nvSpPr>
-          <p:cNvPr id="3" name="Date Placeholder 2"/>
-          <p:cNvSpPr>
-            <a:spLocks noGrp="1"/>
-          </p:cNvSpPr>
-          <p:nvPr>
-            <p:ph type="dt" idx="1"/>
-          </p:nvPr>
-        </p:nvSpPr>
-        <p:spPr>
-          <a:xfrm>
-            <a:off x="3884613" y="0"/>
-            <a:ext cx="2971800" cy="458788"/>
-          </a:xfrm>
-          <a:prstGeom prst="rect">
-            <a:avLst/>
-          </a:prstGeom>
-        </p:spPr>
-        <p:txBody>
-          <a:bodyPr vert="horz" lIns="91440" tIns="45720" rIns="91440" bIns="45720" rtlCol="0"/>
-          <a:lstStyle>
-            <a:lvl1pPr algn="r">
-              <a:defRPr sz="1200"/>
-            </a:lvl1pPr>
-          </a:lstStyle>
-          <a:p>
-            <a:fld id="{5282F153-3F37-0F45-9E97-73ACFA13230C}" type="datetimeFigureOut">
-              <a:rPr lang="en-US"/>
-              <a:t>7/23/19</a:t>
-            </a:fld>
-            <a:endParaRPr lang="en-US"/>
-          </a:p>
-        </p:txBody>
-      </p:sp>
-      <p:sp>
-        <p:nvSpPr>
-          <p:cNvPr id="4" name="Slide Image Placeholder 3"/>
-          <p:cNvSpPr>
-            <a:spLocks noGrp="1" noRot="1" noChangeAspect="1"/>
-          </p:cNvSpPr>
-          <p:nvPr>
-            <p:ph type="sldImg" idx="2"/>
-          </p:nvPr>
-        </p:nvSpPr>
-        <p:spPr>
-          <a:xfrm>
-            <a:off x="685800" y="1143000"/>
-            <a:ext cx="5486400" cy="3086100"/>
-          </a:xfrm>
-          <a:prstGeom prst="rect">
-            <a:avLst/>
-          </a:prstGeom>
-          <a:noFill/>
-          <a:ln w="12700">
-            <a:solidFill>
-              <a:prstClr val="black"/>
-            </a:solidFill>
-          </a:ln>
-        </p:spPr>
-        <p:txBody>
-          <a:bodyPr vert="horz" lIns="91440" tIns="45720" rIns="91440" bIns="45720" rtlCol="0" anchor="ctr"/>
-          <a:lstStyle/>
-          <a:p>
-            <a:endParaRPr lang="en-US"/>
-          </a:p>
-        </p:txBody>
-      </p:sp>
-      <p:sp>
-        <p:nvSpPr>
-          <p:cNvPr id="5" name="Notes Placeholder 4"/>
-          <p:cNvSpPr>
-            <a:spLocks noGrp="1"/>
-          </p:cNvSpPr>
-          <p:nvPr>
-            <p:ph type="body" sz="quarter" idx="3"/>
-          </p:nvPr>
-        </p:nvSpPr>
-        <p:spPr>
-          <a:xfrm>
-            <a:off x="685800" y="4400550"/>
-            <a:ext cx="5486400" cy="3600450"/>
-          </a:xfrm>
-          <a:prstGeom prst="rect">
-            <a:avLst/>
-          </a:prstGeom>
-        </p:spPr>
-        <p:txBody>
-          <a:bodyPr vert="horz" lIns="91440" tIns="45720" rIns="91440" bIns="45720" rtlCol="0"/>
-          <a:lstStyle/>
-          <a:p>
-            <a:pPr lvl="0"/>
-            <a:r>
-              <a:rPr lang="en-US"/>
-              <a:t>Click to edit Master text styles</a:t>
-            </a:r>
-          </a:p>
-          <a:p>
-            <a:pPr lvl="1"/>
-            <a:r>
-              <a:rPr lang="en-US"/>
-              <a:t>Second level</a:t>
-            </a:r>
-          </a:p>
-          <a:p>
-            <a:pPr lvl="2"/>
-            <a:r>
-              <a:rPr lang="en-US"/>
-              <a:t>Third level</a:t>
-            </a:r>
-          </a:p>
-          <a:p>
-            <a:pPr lvl="3"/>
-            <a:r>
-              <a:rPr lang="en-US"/>
-              <a:t>Fourth level</a:t>
-            </a:r>
-          </a:p>
-          <a:p>
-            <a:pPr lvl="4"/>
-            <a:r>
-              <a:rPr lang="en-US"/>
-              <a:t>Fifth level</a:t>
-            </a:r>
-          </a:p>
-        </p:txBody>
-      </p:sp>
-      <p:sp>
-        <p:nvSpPr>
-          <p:cNvPr id="6" name="Footer Placeholder 5"/>
-          <p:cNvSpPr>
-            <a:spLocks noGrp="1"/>
-          </p:cNvSpPr>
-          <p:nvPr>
-            <p:ph type="ftr" sz="quarter" idx="4"/>
-          </p:nvPr>
-        </p:nvSpPr>
-        <p:spPr>
-          <a:xfrm>
-            <a:off x="0" y="8685213"/>
-            <a:ext cx="2971800" cy="458787"/>
-          </a:xfrm>
-          <a:prstGeom prst="rect">
-            <a:avLst/>
-          </a:prstGeom>
-        </p:spPr>
-        <p:txBody>
-          <a:bodyPr vert="horz" lIns="91440" tIns="45720" rIns="91440" bIns="45720" rtlCol="0" anchor="b"/>
-          <a:lstStyle>
-            <a:lvl1pPr algn="l">
-              <a:defRPr sz="1200"/>
-            </a:lvl1pPr>
-          </a:lstStyle>
-          <a:p>
-            <a:endParaRPr lang="en-US"/>
-          </a:p>
-        </p:txBody>
-      </p:sp>
-      <p:sp>
-        <p:nvSpPr>
-          <p:cNvPr id="7" name="Slide Number Placeholder 6"/>
-          <p:cNvSpPr>
-            <a:spLocks noGrp="1"/>
-          </p:cNvSpPr>
-          <p:nvPr>
-            <p:ph type="sldNum" sz="quarter" idx="5"/>
-          </p:nvPr>
-        </p:nvSpPr>
-        <p:spPr>
-          <a:xfrm>
-            <a:off x="3884613" y="8685213"/>
-            <a:ext cx="2971800" cy="458787"/>
-          </a:xfrm>
-          <a:prstGeom prst="rect">
-            <a:avLst/>
-          </a:prstGeom>
-        </p:spPr>
-        <p:txBody>
-          <a:bodyPr vert="horz" lIns="91440" tIns="45720" rIns="91440" bIns="45720" rtlCol="0" anchor="b"/>
-          <a:lstStyle>
-            <a:lvl1pPr algn="r">
-              <a:defRPr sz="1200"/>
-            </a:lvl1pPr>
-          </a:lstStyle>
-          <a:p>
-            <a:fld id="{CE5E9CC1-C706-0F49-92D6-E571CC5EEA8F}" type="slidenum">
-              <a:rPr lang="en-US"/>
-              <a:t>‹#›</a:t>
-            </a:fld>
-            <a:endParaRPr lang="en-US"/>
-          </a:p>
-        </p:txBody>
-      </p:sp>
     </p:spTree>
     <p:extLst>
       <p:ext uri="{BB962C8B-B14F-4D97-AF65-F5344CB8AC3E}">
-        <p14:creationId xmlns:p14="http://schemas.microsoft.com/office/powerpoint/2010/main" val="1024086991"/>
+        <p14:creationId xmlns:p14="http://schemas.microsoft.com/office/powerpoint/2010/main" val="956016476"/>
       </p:ext>
     </p:extLst>
   </p:cSld>
@@ -507,10 +289,6 @@
           <a:bodyPr/>
           <a:lstStyle/>
           <a:p>
-            <a:r>
-              <a:rPr lang="en-US" dirty="0"/>
-              <a:t/>
-            </a:r>
             <a:endParaRPr lang="en-US" dirty="0"/>
           </a:p>
         </p:txBody>
@@ -595,10 +373,6 @@
           <a:bodyPr/>
           <a:lstStyle/>
           <a:p>
-            <a:r>
-              <a:rPr lang="en-US" dirty="0"/>
-              <a:t/>
-            </a:r>
             <a:endParaRPr lang="en-US" dirty="0"/>
           </a:p>
         </p:txBody>
@@ -683,10 +457,6 @@
           <a:bodyPr/>
           <a:lstStyle/>
           <a:p>
-            <a:r>
-              <a:rPr lang="en-US" dirty="0"/>
-              <a:t/>
-            </a:r>
             <a:endParaRPr lang="en-US" dirty="0"/>
           </a:p>
         </p:txBody>
@@ -771,10 +541,6 @@
           <a:bodyPr/>
           <a:lstStyle/>
           <a:p>
-            <a:r>
-              <a:rPr lang="en-US" dirty="0"/>
-              <a:t/>
-            </a:r>
             <a:endParaRPr lang="en-US" dirty="0"/>
           </a:p>
         </p:txBody>
@@ -859,10 +625,6 @@
           <a:bodyPr/>
           <a:lstStyle/>
           <a:p>
-            <a:r>
-              <a:rPr lang="en-US" dirty="0"/>
-              <a:t/>
-            </a:r>
             <a:endParaRPr lang="en-US" dirty="0"/>
           </a:p>
         </p:txBody>
@@ -947,10 +709,6 @@
           <a:bodyPr/>
           <a:lstStyle/>
           <a:p>
-            <a:r>
-              <a:rPr lang="en-US" dirty="0"/>
-              <a:t/>
-            </a:r>
             <a:endParaRPr lang="en-US" dirty="0"/>
           </a:p>
         </p:txBody>
@@ -1035,10 +793,6 @@
           <a:bodyPr/>
           <a:lstStyle/>
           <a:p>
-            <a:r>
-              <a:rPr lang="en-US" dirty="0"/>
-              <a:t/>
-            </a:r>
             <a:endParaRPr lang="en-US" dirty="0"/>
           </a:p>
         </p:txBody>
@@ -1123,10 +877,6 @@
           <a:bodyPr/>
           <a:lstStyle/>
           <a:p>
-            <a:r>
-              <a:rPr lang="en-US" dirty="0"/>
-              <a:t/>
-            </a:r>
             <a:endParaRPr lang="en-US" dirty="0"/>
           </a:p>
         </p:txBody>
@@ -1149,6 +899,90 @@
             <a:fld id="{F7021451-1387-4CA6-816F-3879F97B5CBC}" type="slidenum">
               <a:rPr lang="en-US"/>
               <a:t>8</a:t>
+            </a:fld>
+            <a:endParaRPr lang="en-US"/>
+          </a:p>
+        </p:txBody>
+      </p:sp>
+    </p:spTree>
+    <p:extLst>
+      <p:ext uri="{BB962C8B-B14F-4D97-AF65-F5344CB8AC3E}">
+        <p14:creationId xmlns:p14="http://schemas.microsoft.com/office/powerpoint/2010/main" val="1024086991"/>
+      </p:ext>
+    </p:extLst>
+  </p:cSld>
+  <p:clrMapOvr>
+    <a:masterClrMapping/>
+  </p:clrMapOvr>
+</p:notes>
+</file>
+
+<file path=ppt/notesSlides/notesSlide9.xml><?xml version="1.0" encoding="utf-8"?>
+<p:notes xmlns:a="http://schemas.openxmlformats.org/drawingml/2006/main" xmlns:r="http://schemas.openxmlformats.org/officeDocument/2006/relationships" xmlns:p="http://schemas.openxmlformats.org/presentationml/2006/main">
+  <p:cSld>
+    <p:spTree>
+      <p:nvGrpSpPr>
+        <p:cNvPr id="1" name=""/>
+        <p:cNvGrpSpPr/>
+        <p:nvPr/>
+      </p:nvGrpSpPr>
+      <p:grpSpPr>
+        <a:xfrm>
+          <a:off x="0" y="0"/>
+          <a:ext cx="0" cy="0"/>
+          <a:chOff x="0" y="0"/>
+          <a:chExt cx="0" cy="0"/>
+        </a:xfrm>
+      </p:grpSpPr>
+      <p:sp>
+        <p:nvSpPr>
+          <p:cNvPr id="2" name="Slide Image Placeholder 1"/>
+          <p:cNvSpPr>
+            <a:spLocks noGrp="1" noRot="1" noChangeAspect="1"/>
+          </p:cNvSpPr>
+          <p:nvPr>
+            <p:ph type="sldImg"/>
+          </p:nvPr>
+        </p:nvSpPr>
+        <p:spPr/>
+      </p:sp>
+      <p:sp>
+        <p:nvSpPr>
+          <p:cNvPr id="3" name="Notes Placeholder 2"/>
+          <p:cNvSpPr>
+            <a:spLocks noGrp="1"/>
+          </p:cNvSpPr>
+          <p:nvPr>
+            <p:ph type="body" idx="1"/>
+          </p:nvPr>
+        </p:nvSpPr>
+        <p:spPr/>
+        <p:txBody>
+          <a:bodyPr/>
+          <a:lstStyle/>
+          <a:p>
+            <a:endParaRPr lang="en-US" dirty="0"/>
+          </a:p>
+        </p:txBody>
+      </p:sp>
+      <p:sp>
+        <p:nvSpPr>
+          <p:cNvPr id="4" name="Slide Number Placeholder 3"/>
+          <p:cNvSpPr>
+            <a:spLocks noGrp="1"/>
+          </p:cNvSpPr>
+          <p:nvPr>
+            <p:ph type="sldNum" sz="quarter" idx="10"/>
+          </p:nvPr>
+        </p:nvSpPr>
+        <p:spPr/>
+        <p:txBody>
+          <a:bodyPr/>
+          <a:lstStyle/>
+          <a:p>
+            <a:fld id="{F7021451-1387-4CA6-816F-3879F97B5CBC}" type="slidenum">
+              <a:rPr lang="en-US"/>
+              <a:t>9</a:t>
             </a:fld>
             <a:endParaRPr lang="en-US"/>
           </a:p>
@@ -1200,6 +1034,11 @@
 <file path=ppt/slideMasters/slideMaster1.xml><?xml version="1.0" encoding="utf-8"?>
 <p:sldMaster xmlns:a="http://schemas.openxmlformats.org/drawingml/2006/main" xmlns:r="http://schemas.openxmlformats.org/officeDocument/2006/relationships" xmlns:p="http://schemas.openxmlformats.org/presentationml/2006/main">
   <p:cSld>
+    <p:bg>
+      <p:bgRef idx="1001">
+        <a:schemeClr val="bg1"/>
+      </p:bgRef>
+    </p:bg>
     <p:spTree>
       <p:nvGrpSpPr>
         <p:cNvPr id="1" name=""/>
@@ -1482,6 +1321,7 @@
         <a:solidFill>
           <a:srgbClr val="0C1726"/>
         </a:solidFill>
+        <a:effectLst/>
       </p:bgPr>
     </p:bg>
     <p:spTree>
@@ -1500,14 +1340,14 @@
       </p:grpSpPr>
       <p:pic>
         <p:nvPicPr>
-          <p:cNvPr id="2" name="Image 0" descr="preencoded.png">    </p:cNvPr>
+          <p:cNvPr id="2" name="Image 0" descr="preencoded.png"/>
           <p:cNvPicPr>
             <a:picLocks noChangeAspect="1"/>
           </p:cNvPicPr>
           <p:nvPr/>
         </p:nvPicPr>
         <p:blipFill>
-          <a:blip r:embed="rId1"/>
+          <a:blip r:embed="rId3"/>
           <a:stretch>
             <a:fillRect/>
           </a:stretch>
@@ -1543,7 +1383,7 @@
           <a:bodyPr wrap="square" lIns="0" tIns="0" rIns="0" bIns="0" rtlCol="0" anchor="ctr"/>
           <a:lstStyle/>
           <a:p>
-            <a:pPr indent="0" marL="0">
+            <a:pPr marL="0" indent="0">
               <a:buNone/>
             </a:pPr>
             <a:r>
@@ -1582,7 +1422,7 @@
           <a:bodyPr wrap="square" lIns="0" tIns="0" rIns="0" bIns="0" rtlCol="0" anchor="ctr"/>
           <a:lstStyle/>
           <a:p>
-            <a:pPr indent="0" marL="0">
+            <a:pPr marL="0" indent="0">
               <a:buNone/>
             </a:pPr>
             <a:r>
@@ -1621,7 +1461,7 @@
           <a:bodyPr wrap="square" lIns="0" tIns="0" rIns="0" bIns="0" rtlCol="0" anchor="ctr"/>
           <a:lstStyle/>
           <a:p>
-            <a:pPr indent="0" marL="0">
+            <a:pPr marL="0" indent="0">
               <a:lnSpc>
                 <a:spcPct val="125000"/>
               </a:lnSpc>
@@ -1636,7 +1476,7 @@
                 <a:ea typeface="Arial" pitchFamily="34" charset="-122"/>
                 <a:cs typeface="Arial" pitchFamily="34" charset="-120"/>
               </a:rPr>
-              <a:t>How we turn locksmiths into customers — find them, call them, follow up, close, and get them live.</a:t>
+              <a:t>How we turn service contractors into customers: find them, call them, run the demo, close, and get them live.</a:t>
             </a:r>
             <a:endParaRPr lang="en-US" sz="1400" dirty="0"/>
           </a:p>
@@ -1661,6 +1501,13 @@
           </a:solidFill>
           <a:ln/>
         </p:spPr>
+        <p:txBody>
+          <a:bodyPr/>
+          <a:lstStyle/>
+          <a:p>
+            <a:endParaRPr lang="en-US"/>
+          </a:p>
+        </p:txBody>
       </p:sp>
       <p:sp>
         <p:nvSpPr>
@@ -1683,7 +1530,7 @@
           <a:bodyPr wrap="square" lIns="0" tIns="0" rIns="0" bIns="0" rtlCol="0" anchor="ctr"/>
           <a:lstStyle/>
           <a:p>
-            <a:pPr algn="ctr" indent="0" marL="0">
+            <a:pPr marL="0" indent="0" algn="ctr">
               <a:buNone/>
             </a:pPr>
             <a:r>
@@ -1722,7 +1569,7 @@
           <a:bodyPr wrap="square" lIns="0" tIns="0" rIns="0" bIns="0" rtlCol="0" anchor="ctr"/>
           <a:lstStyle/>
           <a:p>
-            <a:pPr indent="0" marL="0">
+            <a:pPr marL="0" indent="0">
               <a:buNone/>
             </a:pPr>
             <a:r>
@@ -1759,6 +1606,13 @@
           </a:solidFill>
           <a:ln/>
         </p:spPr>
+        <p:txBody>
+          <a:bodyPr/>
+          <a:lstStyle/>
+          <a:p>
+            <a:endParaRPr lang="en-US"/>
+          </a:p>
+        </p:txBody>
       </p:sp>
       <p:sp>
         <p:nvSpPr>
@@ -1781,7 +1635,7 @@
           <a:bodyPr wrap="square" lIns="0" tIns="0" rIns="0" bIns="0" rtlCol="0" anchor="ctr"/>
           <a:lstStyle/>
           <a:p>
-            <a:pPr algn="ctr" indent="0" marL="0">
+            <a:pPr marL="0" indent="0" algn="ctr">
               <a:buNone/>
             </a:pPr>
             <a:r>
@@ -1820,7 +1674,7 @@
           <a:bodyPr wrap="square" lIns="0" tIns="0" rIns="0" bIns="0" rtlCol="0" anchor="ctr"/>
           <a:lstStyle/>
           <a:p>
-            <a:pPr indent="0" marL="0">
+            <a:pPr marL="0" indent="0">
               <a:buNone/>
             </a:pPr>
             <a:r>
@@ -1832,7 +1686,7 @@
                 <a:ea typeface="Arial" pitchFamily="34" charset="-122"/>
                 <a:cs typeface="Arial" pitchFamily="34" charset="-120"/>
               </a:rPr>
-              <a:t>Cold call</a:t>
+              <a:t>Cold Call</a:t>
             </a:r>
             <a:endParaRPr lang="en-US" sz="1500" dirty="0"/>
           </a:p>
@@ -1857,6 +1711,13 @@
           </a:solidFill>
           <a:ln/>
         </p:spPr>
+        <p:txBody>
+          <a:bodyPr/>
+          <a:lstStyle/>
+          <a:p>
+            <a:endParaRPr lang="en-US"/>
+          </a:p>
+        </p:txBody>
       </p:sp>
       <p:sp>
         <p:nvSpPr>
@@ -1879,7 +1740,7 @@
           <a:bodyPr wrap="square" lIns="0" tIns="0" rIns="0" bIns="0" rtlCol="0" anchor="ctr"/>
           <a:lstStyle/>
           <a:p>
-            <a:pPr algn="ctr" indent="0" marL="0">
+            <a:pPr marL="0" indent="0" algn="ctr">
               <a:buNone/>
             </a:pPr>
             <a:r>
@@ -1918,7 +1779,7 @@
           <a:bodyPr wrap="square" lIns="0" tIns="0" rIns="0" bIns="0" rtlCol="0" anchor="ctr"/>
           <a:lstStyle/>
           <a:p>
-            <a:pPr indent="0" marL="0">
+            <a:pPr marL="0" indent="0">
               <a:buNone/>
             </a:pPr>
             <a:r>
@@ -1930,7 +1791,7 @@
                 <a:ea typeface="Arial" pitchFamily="34" charset="-122"/>
                 <a:cs typeface="Arial" pitchFamily="34" charset="-120"/>
               </a:rPr>
-              <a:t>Follow up</a:t>
+              <a:t>Demo &amp; Trial</a:t>
             </a:r>
             <a:endParaRPr lang="en-US" sz="1500" dirty="0"/>
           </a:p>
@@ -1955,6 +1816,13 @@
           </a:solidFill>
           <a:ln/>
         </p:spPr>
+        <p:txBody>
+          <a:bodyPr/>
+          <a:lstStyle/>
+          <a:p>
+            <a:endParaRPr lang="en-US"/>
+          </a:p>
+        </p:txBody>
       </p:sp>
       <p:sp>
         <p:nvSpPr>
@@ -1977,7 +1845,7 @@
           <a:bodyPr wrap="square" lIns="0" tIns="0" rIns="0" bIns="0" rtlCol="0" anchor="ctr"/>
           <a:lstStyle/>
           <a:p>
-            <a:pPr algn="ctr" indent="0" marL="0">
+            <a:pPr marL="0" indent="0" algn="ctr">
               <a:buNone/>
             </a:pPr>
             <a:r>
@@ -2016,7 +1884,7 @@
           <a:bodyPr wrap="square" lIns="0" tIns="0" rIns="0" bIns="0" rtlCol="0" anchor="ctr"/>
           <a:lstStyle/>
           <a:p>
-            <a:pPr indent="0" marL="0">
+            <a:pPr marL="0" indent="0">
               <a:buNone/>
             </a:pPr>
             <a:r>
@@ -2053,6 +1921,13 @@
           </a:solidFill>
           <a:ln/>
         </p:spPr>
+        <p:txBody>
+          <a:bodyPr/>
+          <a:lstStyle/>
+          <a:p>
+            <a:endParaRPr lang="en-US"/>
+          </a:p>
+        </p:txBody>
       </p:sp>
       <p:sp>
         <p:nvSpPr>
@@ -2075,7 +1950,7 @@
           <a:bodyPr wrap="square" lIns="0" tIns="0" rIns="0" bIns="0" rtlCol="0" anchor="ctr"/>
           <a:lstStyle/>
           <a:p>
-            <a:pPr algn="ctr" indent="0" marL="0">
+            <a:pPr marL="0" indent="0" algn="ctr">
               <a:buNone/>
             </a:pPr>
             <a:r>
@@ -2114,7 +1989,7 @@
           <a:bodyPr wrap="square" lIns="0" tIns="0" rIns="0" bIns="0" rtlCol="0" anchor="ctr"/>
           <a:lstStyle/>
           <a:p>
-            <a:pPr indent="0" marL="0">
+            <a:pPr marL="0" indent="0">
               <a:buNone/>
             </a:pPr>
             <a:r>
@@ -2153,7 +2028,7 @@
           <a:bodyPr wrap="square" lIns="0" tIns="0" rIns="0" bIns="0" rtlCol="0" anchor="ctr"/>
           <a:lstStyle/>
           <a:p>
-            <a:pPr indent="0" marL="0">
+            <a:pPr marL="0" indent="0">
               <a:buNone/>
             </a:pPr>
             <a:r>
@@ -2172,6 +2047,11 @@
         </p:txBody>
       </p:sp>
     </p:spTree>
+    <p:extLst>
+      <p:ext uri="{BB962C8B-B14F-4D97-AF65-F5344CB8AC3E}">
+        <p14:creationId xmlns:p14="http://schemas.microsoft.com/office/powerpoint/2010/main" val="1907781122"/>
+      </p:ext>
+    </p:extLst>
   </p:cSld>
   <p:clrMapOvr>
     <a:masterClrMapping/>
@@ -2187,6 +2067,7 @@
         <a:solidFill>
           <a:srgbClr val="FFFFFF"/>
         </a:solidFill>
+        <a:effectLst/>
       </p:bgPr>
     </p:bg>
     <p:spTree>
@@ -2205,14 +2086,14 @@
       </p:grpSpPr>
       <p:pic>
         <p:nvPicPr>
-          <p:cNvPr id="2" name="Image 0" descr="preencoded.png">    </p:cNvPr>
+          <p:cNvPr id="2" name="Image 0" descr="preencoded.png"/>
           <p:cNvPicPr>
             <a:picLocks noChangeAspect="1"/>
           </p:cNvPicPr>
           <p:nvPr/>
         </p:nvPicPr>
         <p:blipFill>
-          <a:blip r:embed="rId1"/>
+          <a:blip r:embed="rId3"/>
           <a:stretch>
             <a:fillRect/>
           </a:stretch>
@@ -2248,7 +2129,7 @@
           <a:bodyPr wrap="square" lIns="0" tIns="0" rIns="0" bIns="0" rtlCol="0" anchor="ctr"/>
           <a:lstStyle/>
           <a:p>
-            <a:pPr indent="0" marL="0">
+            <a:pPr marL="0" indent="0">
               <a:buNone/>
             </a:pPr>
             <a:r>
@@ -2287,7 +2168,7 @@
           <a:bodyPr wrap="square" lIns="0" tIns="0" rIns="0" bIns="0" rtlCol="0" anchor="ctr"/>
           <a:lstStyle/>
           <a:p>
-            <a:pPr algn="r" indent="0" marL="0">
+            <a:pPr marL="0" indent="0" algn="r">
               <a:buNone/>
             </a:pPr>
             <a:r>
@@ -2324,6 +2205,13 @@
           </a:solidFill>
           <a:ln/>
         </p:spPr>
+        <p:txBody>
+          <a:bodyPr/>
+          <a:lstStyle/>
+          <a:p>
+            <a:endParaRPr lang="en-US"/>
+          </a:p>
+        </p:txBody>
       </p:sp>
       <p:sp>
         <p:nvSpPr>
@@ -2346,7 +2234,7 @@
           <a:bodyPr wrap="square" lIns="0" tIns="0" rIns="0" bIns="0" rtlCol="0" anchor="ctr"/>
           <a:lstStyle/>
           <a:p>
-            <a:pPr indent="0" marL="0">
+            <a:pPr marL="0" indent="0">
               <a:buNone/>
             </a:pPr>
             <a:r>
@@ -2385,7 +2273,7 @@
           <a:bodyPr wrap="square" lIns="0" tIns="0" rIns="0" bIns="0" rtlCol="0" anchor="ctr"/>
           <a:lstStyle/>
           <a:p>
-            <a:pPr indent="0" marL="0">
+            <a:pPr marL="0" indent="0">
               <a:buNone/>
             </a:pPr>
             <a:r>
@@ -2422,6 +2310,13 @@
           </a:solidFill>
           <a:ln/>
         </p:spPr>
+        <p:txBody>
+          <a:bodyPr/>
+          <a:lstStyle/>
+          <a:p>
+            <a:endParaRPr lang="en-US"/>
+          </a:p>
+        </p:txBody>
       </p:sp>
       <p:sp>
         <p:nvSpPr>
@@ -2444,7 +2339,7 @@
           <a:bodyPr wrap="square" lIns="0" tIns="0" rIns="0" bIns="0" rtlCol="0" anchor="ctr"/>
           <a:lstStyle/>
           <a:p>
-            <a:pPr algn="ctr" indent="0" marL="0">
+            <a:pPr marL="0" indent="0" algn="ctr">
               <a:buNone/>
             </a:pPr>
             <a:r>
@@ -2483,7 +2378,7 @@
           <a:bodyPr wrap="square" lIns="0" tIns="0" rIns="0" bIns="0" rtlCol="0" anchor="ctr"/>
           <a:lstStyle/>
           <a:p>
-            <a:pPr algn="ctr" indent="0" marL="0">
+            <a:pPr marL="0" indent="0" algn="ctr">
               <a:buNone/>
             </a:pPr>
             <a:r>
@@ -2520,6 +2415,13 @@
           </a:solidFill>
           <a:ln/>
         </p:spPr>
+        <p:txBody>
+          <a:bodyPr/>
+          <a:lstStyle/>
+          <a:p>
+            <a:endParaRPr lang="en-US"/>
+          </a:p>
+        </p:txBody>
       </p:sp>
       <p:sp>
         <p:nvSpPr>
@@ -2540,6 +2442,13 @@
           </a:solidFill>
           <a:ln/>
         </p:spPr>
+        <p:txBody>
+          <a:bodyPr/>
+          <a:lstStyle/>
+          <a:p>
+            <a:endParaRPr lang="en-US"/>
+          </a:p>
+        </p:txBody>
       </p:sp>
       <p:sp>
         <p:nvSpPr>
@@ -2562,7 +2471,7 @@
           <a:bodyPr wrap="square" lIns="0" tIns="0" rIns="0" bIns="0" rtlCol="0" anchor="ctr"/>
           <a:lstStyle/>
           <a:p>
-            <a:pPr algn="ctr" indent="0" marL="0">
+            <a:pPr marL="0" indent="0" algn="ctr">
               <a:buNone/>
             </a:pPr>
             <a:r>
@@ -2601,7 +2510,7 @@
           <a:bodyPr wrap="square" lIns="0" tIns="0" rIns="0" bIns="0" rtlCol="0" anchor="ctr"/>
           <a:lstStyle/>
           <a:p>
-            <a:pPr algn="ctr" indent="0" marL="0">
+            <a:pPr marL="0" indent="0" algn="ctr">
               <a:buNone/>
             </a:pPr>
             <a:r>
@@ -2613,7 +2522,7 @@
                 <a:ea typeface="Arial" pitchFamily="34" charset="-122"/>
                 <a:cs typeface="Arial" pitchFamily="34" charset="-120"/>
               </a:rPr>
-              <a:t>Cold call</a:t>
+              <a:t>Cold Call</a:t>
             </a:r>
             <a:endParaRPr lang="en-US" sz="1100" dirty="0"/>
           </a:p>
@@ -2638,6 +2547,13 @@
           </a:solidFill>
           <a:ln/>
         </p:spPr>
+        <p:txBody>
+          <a:bodyPr/>
+          <a:lstStyle/>
+          <a:p>
+            <a:endParaRPr lang="en-US"/>
+          </a:p>
+        </p:txBody>
       </p:sp>
       <p:sp>
         <p:nvSpPr>
@@ -2658,6 +2574,13 @@
           </a:solidFill>
           <a:ln/>
         </p:spPr>
+        <p:txBody>
+          <a:bodyPr/>
+          <a:lstStyle/>
+          <a:p>
+            <a:endParaRPr lang="en-US"/>
+          </a:p>
+        </p:txBody>
       </p:sp>
       <p:sp>
         <p:nvSpPr>
@@ -2680,7 +2603,7 @@
           <a:bodyPr wrap="square" lIns="0" tIns="0" rIns="0" bIns="0" rtlCol="0" anchor="ctr"/>
           <a:lstStyle/>
           <a:p>
-            <a:pPr algn="ctr" indent="0" marL="0">
+            <a:pPr marL="0" indent="0" algn="ctr">
               <a:buNone/>
             </a:pPr>
             <a:r>
@@ -2719,7 +2642,7 @@
           <a:bodyPr wrap="square" lIns="0" tIns="0" rIns="0" bIns="0" rtlCol="0" anchor="ctr"/>
           <a:lstStyle/>
           <a:p>
-            <a:pPr algn="ctr" indent="0" marL="0">
+            <a:pPr marL="0" indent="0" algn="ctr">
               <a:buNone/>
             </a:pPr>
             <a:r>
@@ -2731,7 +2654,7 @@
                 <a:ea typeface="Arial" pitchFamily="34" charset="-122"/>
                 <a:cs typeface="Arial" pitchFamily="34" charset="-120"/>
               </a:rPr>
-              <a:t>Follow up</a:t>
+              <a:t>Demo &amp; Trial</a:t>
             </a:r>
             <a:endParaRPr lang="en-US" sz="1100" dirty="0"/>
           </a:p>
@@ -2756,6 +2679,13 @@
           </a:solidFill>
           <a:ln/>
         </p:spPr>
+        <p:txBody>
+          <a:bodyPr/>
+          <a:lstStyle/>
+          <a:p>
+            <a:endParaRPr lang="en-US"/>
+          </a:p>
+        </p:txBody>
       </p:sp>
       <p:sp>
         <p:nvSpPr>
@@ -2776,6 +2706,13 @@
           </a:solidFill>
           <a:ln/>
         </p:spPr>
+        <p:txBody>
+          <a:bodyPr/>
+          <a:lstStyle/>
+          <a:p>
+            <a:endParaRPr lang="en-US"/>
+          </a:p>
+        </p:txBody>
       </p:sp>
       <p:sp>
         <p:nvSpPr>
@@ -2798,7 +2735,7 @@
           <a:bodyPr wrap="square" lIns="0" tIns="0" rIns="0" bIns="0" rtlCol="0" anchor="ctr"/>
           <a:lstStyle/>
           <a:p>
-            <a:pPr algn="ctr" indent="0" marL="0">
+            <a:pPr marL="0" indent="0" algn="ctr">
               <a:buNone/>
             </a:pPr>
             <a:r>
@@ -2837,7 +2774,7 @@
           <a:bodyPr wrap="square" lIns="0" tIns="0" rIns="0" bIns="0" rtlCol="0" anchor="ctr"/>
           <a:lstStyle/>
           <a:p>
-            <a:pPr algn="ctr" indent="0" marL="0">
+            <a:pPr marL="0" indent="0" algn="ctr">
               <a:buNone/>
             </a:pPr>
             <a:r>
@@ -2874,6 +2811,13 @@
           </a:solidFill>
           <a:ln/>
         </p:spPr>
+        <p:txBody>
+          <a:bodyPr/>
+          <a:lstStyle/>
+          <a:p>
+            <a:endParaRPr lang="en-US"/>
+          </a:p>
+        </p:txBody>
       </p:sp>
       <p:sp>
         <p:nvSpPr>
@@ -2894,6 +2838,13 @@
           </a:solidFill>
           <a:ln/>
         </p:spPr>
+        <p:txBody>
+          <a:bodyPr/>
+          <a:lstStyle/>
+          <a:p>
+            <a:endParaRPr lang="en-US"/>
+          </a:p>
+        </p:txBody>
       </p:sp>
       <p:sp>
         <p:nvSpPr>
@@ -2916,7 +2867,7 @@
           <a:bodyPr wrap="square" lIns="0" tIns="0" rIns="0" bIns="0" rtlCol="0" anchor="ctr"/>
           <a:lstStyle/>
           <a:p>
-            <a:pPr algn="ctr" indent="0" marL="0">
+            <a:pPr marL="0" indent="0" algn="ctr">
               <a:buNone/>
             </a:pPr>
             <a:r>
@@ -2955,7 +2906,7 @@
           <a:bodyPr wrap="square" lIns="0" tIns="0" rIns="0" bIns="0" rtlCol="0" anchor="ctr"/>
           <a:lstStyle/>
           <a:p>
-            <a:pPr algn="ctr" indent="0" marL="0">
+            <a:pPr marL="0" indent="0" algn="ctr">
               <a:buNone/>
             </a:pPr>
             <a:r>
@@ -2994,7 +2945,7 @@
           <a:bodyPr wrap="square" lIns="0" tIns="0" rIns="0" bIns="0" rtlCol="0" anchor="ctr"/>
           <a:lstStyle/>
           <a:p>
-            <a:pPr indent="0" marL="0">
+            <a:pPr marL="0" indent="0">
               <a:buNone/>
             </a:pPr>
             <a:r>
@@ -3049,7 +3000,7 @@
                 <a:ea typeface="Arial" pitchFamily="34" charset="-122"/>
                 <a:cs typeface="Arial" pitchFamily="34" charset="-120"/>
               </a:rPr>
-              <a:t>One goal per stage — always advance to the next.</a:t>
+              <a:t>One goal per stage: always advance to the next.</a:t>
             </a:r>
             <a:endParaRPr lang="en-US" sz="1100" dirty="0"/>
           </a:p>
@@ -3160,7 +3111,7 @@
           <a:bodyPr wrap="square" lIns="0" tIns="0" rIns="0" bIns="0" rtlCol="0" anchor="ctr"/>
           <a:lstStyle/>
           <a:p>
-            <a:pPr indent="0" marL="0">
+            <a:pPr marL="0" indent="0">
               <a:buNone/>
             </a:pPr>
             <a:r>
@@ -3215,7 +3166,7 @@
                 <a:ea typeface="Arial" pitchFamily="34" charset="-122"/>
                 <a:cs typeface="Arial" pitchFamily="34" charset="-120"/>
               </a:rPr>
-              <a:t>Identify — the /locksmith-outreach skill + outreach/contacted.csv</a:t>
+              <a:t>Identify: the outreach tool + outreach/contacted.csv</a:t>
             </a:r>
             <a:endParaRPr lang="en-US" sz="1100" dirty="0"/>
           </a:p>
@@ -3236,7 +3187,7 @@
                 <a:ea typeface="Arial" pitchFamily="34" charset="-122"/>
                 <a:cs typeface="Arial" pitchFamily="34" charset="-120"/>
               </a:rPr>
-              <a:t>Book — Calendly</a:t>
+              <a:t>Demo &amp; Trial: Zoom + the Dispango demo number</a:t>
             </a:r>
             <a:endParaRPr lang="en-US" sz="1100" dirty="0"/>
           </a:p>
@@ -3257,7 +3208,7 @@
                 <a:ea typeface="Arial" pitchFamily="34" charset="-122"/>
                 <a:cs typeface="Arial" pitchFamily="34" charset="-120"/>
               </a:rPr>
-              <a:t>Close — the demo deck + one-page brochure</a:t>
+              <a:t>Follow-up: the call recording + the lead-text screenshot</a:t>
             </a:r>
             <a:endParaRPr lang="en-US" sz="1100" dirty="0"/>
           </a:p>
@@ -3278,7 +3229,7 @@
                 <a:ea typeface="Arial" pitchFamily="34" charset="-122"/>
                 <a:cs typeface="Arial" pitchFamily="34" charset="-120"/>
               </a:rPr>
-              <a:t>Onboard — the admin tool (admin-ui → admin API)</a:t>
+              <a:t>Trials &amp; onboarding: the admin tool (admin-ui → admin API)</a:t>
             </a:r>
             <a:endParaRPr lang="en-US" sz="1100" dirty="0"/>
           </a:p>
@@ -3299,13 +3250,18 @@
                 <a:ea typeface="Arial" pitchFamily="34" charset="-122"/>
                 <a:cs typeface="Arial" pitchFamily="34" charset="-120"/>
               </a:rPr>
-              <a:t>Legitimacy — the dispango.com website</a:t>
+              <a:t>Legitimacy: the dispango.com website</a:t>
             </a:r>
             <a:endParaRPr lang="en-US" sz="1100" dirty="0"/>
           </a:p>
         </p:txBody>
       </p:sp>
     </p:spTree>
+    <p:extLst>
+      <p:ext uri="{BB962C8B-B14F-4D97-AF65-F5344CB8AC3E}">
+        <p14:creationId xmlns:p14="http://schemas.microsoft.com/office/powerpoint/2010/main" val="3004219726"/>
+      </p:ext>
+    </p:extLst>
   </p:cSld>
   <p:clrMapOvr>
     <a:masterClrMapping/>
@@ -3321,6 +3277,7 @@
         <a:solidFill>
           <a:srgbClr val="FFFFFF"/>
         </a:solidFill>
+        <a:effectLst/>
       </p:bgPr>
     </p:bg>
     <p:spTree>
@@ -3339,14 +3296,14 @@
       </p:grpSpPr>
       <p:pic>
         <p:nvPicPr>
-          <p:cNvPr id="2" name="Image 0" descr="preencoded.png">    </p:cNvPr>
+          <p:cNvPr id="2" name="Image 0" descr="preencoded.png"/>
           <p:cNvPicPr>
             <a:picLocks noChangeAspect="1"/>
           </p:cNvPicPr>
           <p:nvPr/>
         </p:nvPicPr>
         <p:blipFill>
-          <a:blip r:embed="rId1"/>
+          <a:blip r:embed="rId3"/>
           <a:stretch>
             <a:fillRect/>
           </a:stretch>
@@ -3382,7 +3339,7 @@
           <a:bodyPr wrap="square" lIns="0" tIns="0" rIns="0" bIns="0" rtlCol="0" anchor="ctr"/>
           <a:lstStyle/>
           <a:p>
-            <a:pPr indent="0" marL="0">
+            <a:pPr marL="0" indent="0">
               <a:buNone/>
             </a:pPr>
             <a:r>
@@ -3421,7 +3378,7 @@
           <a:bodyPr wrap="square" lIns="0" tIns="0" rIns="0" bIns="0" rtlCol="0" anchor="ctr"/>
           <a:lstStyle/>
           <a:p>
-            <a:pPr algn="r" indent="0" marL="0">
+            <a:pPr marL="0" indent="0" algn="r">
               <a:buNone/>
             </a:pPr>
             <a:r>
@@ -3458,6 +3415,13 @@
           </a:solidFill>
           <a:ln/>
         </p:spPr>
+        <p:txBody>
+          <a:bodyPr/>
+          <a:lstStyle/>
+          <a:p>
+            <a:endParaRPr lang="en-US"/>
+          </a:p>
+        </p:txBody>
       </p:sp>
       <p:sp>
         <p:nvSpPr>
@@ -3480,7 +3444,7 @@
           <a:bodyPr wrap="square" lIns="0" tIns="0" rIns="0" bIns="0" rtlCol="0" anchor="ctr"/>
           <a:lstStyle/>
           <a:p>
-            <a:pPr indent="0" marL="0">
+            <a:pPr marL="0" indent="0">
               <a:buNone/>
             </a:pPr>
             <a:r>
@@ -3494,9 +3458,6 @@
               </a:rPr>
               <a:t>01   </a:t>
             </a:r>
-            <a:pPr indent="0" marL="0">
-              <a:buNone/>
-            </a:pPr>
             <a:r>
               <a:rPr lang="en-US" sz="2600" b="1" dirty="0">
                 <a:solidFill>
@@ -3538,6 +3499,13 @@
             <a:prstDash val="solid"/>
           </a:ln>
         </p:spPr>
+        <p:txBody>
+          <a:bodyPr/>
+          <a:lstStyle/>
+          <a:p>
+            <a:endParaRPr lang="en-US"/>
+          </a:p>
+        </p:txBody>
       </p:sp>
       <p:sp>
         <p:nvSpPr>
@@ -3560,7 +3528,7 @@
           <a:bodyPr wrap="square" lIns="0" tIns="0" rIns="0" bIns="0" rtlCol="0" anchor="ctr"/>
           <a:lstStyle/>
           <a:p>
-            <a:pPr indent="0" marL="0">
+            <a:pPr marL="0" indent="0">
               <a:buNone/>
             </a:pPr>
             <a:r>
@@ -3574,9 +3542,6 @@
               </a:rPr>
               <a:t>GOAL   </a:t>
             </a:r>
-            <a:pPr indent="0" marL="0">
-              <a:buNone/>
-            </a:pPr>
             <a:r>
               <a:rPr lang="en-US" sz="1200" dirty="0">
                 <a:solidFill>
@@ -3586,7 +3551,7 @@
                 <a:ea typeface="Arial" pitchFamily="34" charset="-122"/>
                 <a:cs typeface="Arial" pitchFamily="34" charset="-120"/>
               </a:rPr>
-              <a:t>Build a steady list of locksmith shops worth calling.</a:t>
+              <a:t>Build a steady list of service businesses worth calling locksmiths, home-service contractors, rental offices.</a:t>
             </a:r>
             <a:endParaRPr lang="en-US" sz="1000" dirty="0"/>
           </a:p>
@@ -3613,11 +3578,11 @@
           <a:bodyPr wrap="square" lIns="0" tIns="0" rIns="0" bIns="0" rtlCol="0" anchor="ctr"/>
           <a:lstStyle/>
           <a:p>
-            <a:pPr indent="0" marL="0">
+            <a:pPr marL="0" indent="0">
               <a:buNone/>
             </a:pPr>
             <a:r>
-              <a:rPr lang="en-US" sz="1100" b="1" spc="100" kern="0" dirty="0">
+              <a:rPr lang="en-US" sz="1100" b="1" kern="0" spc="100" dirty="0">
                 <a:solidFill>
                   <a:srgbClr val="0C1726"/>
                 </a:solidFill>
@@ -3658,7 +3623,7 @@
               </a:spcAft>
               <a:buSzPct val="100000"/>
               <a:buFont typeface="+mj-lt"/>
-              <a:buAutoNum type="arabicPeriod" startAt="1"/>
+              <a:buAutoNum type="arabicPeriod"/>
             </a:pPr>
             <a:r>
               <a:rPr lang="en-US" sz="1050" dirty="0">
@@ -3669,7 +3634,7 @@
                 <a:ea typeface="Arial" pitchFamily="34" charset="-122"/>
                 <a:cs typeface="Arial" pitchFamily="34" charset="-120"/>
               </a:rPr>
-              <a:t>Pick one city or region — start local and Canadian.</a:t>
+              <a:t>Pick one city or region; start local and Canadian.</a:t>
             </a:r>
             <a:endParaRPr lang="en-US" sz="1050" dirty="0"/>
           </a:p>
@@ -3680,7 +3645,7 @@
               </a:spcAft>
               <a:buSzPct val="100000"/>
               <a:buFont typeface="+mj-lt"/>
-              <a:buAutoNum type="arabicPeriod" startAt="1"/>
+              <a:buAutoNum type="arabicPeriod"/>
             </a:pPr>
             <a:r>
               <a:rPr lang="en-US" sz="1050" dirty="0">
@@ -3691,7 +3656,7 @@
                 <a:ea typeface="Arial" pitchFamily="34" charset="-122"/>
                 <a:cs typeface="Arial" pitchFamily="34" charset="-120"/>
               </a:rPr>
-              <a:t>Mine Google Maps + directories for shop names (search alone misses locals).</a:t>
+              <a:t>Mine Google Maps + directories for business names (search alone misses locals).</a:t>
             </a:r>
             <a:endParaRPr lang="en-US" sz="1050" dirty="0"/>
           </a:p>
@@ -3702,7 +3667,7 @@
               </a:spcAft>
               <a:buSzPct val="100000"/>
               <a:buFont typeface="+mj-lt"/>
-              <a:buAutoNum type="arabicPeriod" startAt="1"/>
+              <a:buAutoNum type="arabicPeriod"/>
             </a:pPr>
             <a:r>
               <a:rPr lang="en-US" sz="1050" dirty="0">
@@ -3713,7 +3678,7 @@
                 <a:ea typeface="Arial" pitchFamily="34" charset="-122"/>
                 <a:cs typeface="Arial" pitchFamily="34" charset="-120"/>
               </a:rPr>
-              <a:t>Visit each shop's own site; grab phone, published email, hours, services.</a:t>
+              <a:t>Visit each business's own site; grab phone, published email, hours, services.</a:t>
             </a:r>
             <a:endParaRPr lang="en-US" sz="1050" dirty="0"/>
           </a:p>
@@ -3724,7 +3689,7 @@
               </a:spcAft>
               <a:buSzPct val="100000"/>
               <a:buFont typeface="+mj-lt"/>
-              <a:buAutoNum type="arabicPeriod" startAt="1"/>
+              <a:buAutoNum type="arabicPeriod"/>
             </a:pPr>
             <a:r>
               <a:rPr lang="en-US" sz="1050" dirty="0">
@@ -3735,7 +3700,7 @@
                 <a:ea typeface="Arial" pitchFamily="34" charset="-122"/>
                 <a:cs typeface="Arial" pitchFamily="34" charset="-120"/>
               </a:rPr>
-              <a:t>Log to the sheet; dedup by domain and email.</a:t>
+              <a:t>Log to outreach/contacted.csv; dedup by domain and email.</a:t>
             </a:r>
             <a:endParaRPr lang="en-US" sz="1050" dirty="0"/>
           </a:p>
@@ -3746,7 +3711,7 @@
               </a:spcAft>
               <a:buSzPct val="100000"/>
               <a:buFont typeface="+mj-lt"/>
-              <a:buAutoNum type="arabicPeriod" startAt="1"/>
+              <a:buAutoNum type="arabicPeriod"/>
             </a:pPr>
             <a:r>
               <a:rPr lang="en-US" sz="1050" dirty="0">
@@ -3757,7 +3722,7 @@
                 <a:ea typeface="Arial" pitchFamily="34" charset="-122"/>
                 <a:cs typeface="Arial" pitchFamily="34" charset="-120"/>
               </a:rPr>
-              <a:t>Prioritize 24/7, emergency, mobile, owner-run shops.</a:t>
+              <a:t>Prioritize 24/7, emergency, appointment-driven, owner-run businesses.</a:t>
             </a:r>
             <a:endParaRPr lang="en-US" sz="1050" dirty="0"/>
           </a:p>
@@ -3784,11 +3749,11 @@
           <a:bodyPr wrap="square" lIns="0" tIns="0" rIns="0" bIns="0" rtlCol="0" anchor="ctr"/>
           <a:lstStyle/>
           <a:p>
-            <a:pPr indent="0" marL="0">
+            <a:pPr marL="0" indent="0">
               <a:buNone/>
             </a:pPr>
             <a:r>
-              <a:rPr lang="en-US" sz="1100" b="1" spc="100" kern="0" dirty="0">
+              <a:rPr lang="en-US" sz="1100" b="1" kern="0" spc="100" dirty="0">
                 <a:solidFill>
                   <a:srgbClr val="0C1726"/>
                 </a:solidFill>
@@ -3839,7 +3804,7 @@
                 <a:ea typeface="Arial" pitchFamily="34" charset="-122"/>
                 <a:cs typeface="Arial" pitchFamily="34" charset="-120"/>
               </a:rPr>
-              <a:t>Use the /locksmith-outreach skill to find shops and draft emails.</a:t>
+              <a:t>Use the /locksmith-outreach tool to find prospects and draft emails.</a:t>
             </a:r>
             <a:endParaRPr lang="en-US" sz="1050" dirty="0"/>
           </a:p>
@@ -3860,7 +3825,7 @@
                 <a:ea typeface="Arial" pitchFamily="34" charset="-122"/>
                 <a:cs typeface="Arial" pitchFamily="34" charset="-120"/>
               </a:rPr>
-              <a:t>CASL: only use a conspicuously published email — never guess info@.</a:t>
+              <a:t>Use the conspicuously published email only, never guess info@.</a:t>
             </a:r>
             <a:endParaRPr lang="en-US" sz="1050" dirty="0"/>
           </a:p>
@@ -3881,7 +3846,7 @@
                 <a:ea typeface="Arial" pitchFamily="34" charset="-122"/>
                 <a:cs typeface="Arial" pitchFamily="34" charset="-120"/>
               </a:rPr>
-              <a:t>Note one hook per shop (their after-hours claims, reviews).</a:t>
+              <a:t>Note one hook per prospect (after-hours claims, booking pages, reviews).</a:t>
             </a:r>
             <a:endParaRPr lang="en-US" sz="1050" dirty="0"/>
           </a:p>
@@ -3902,7 +3867,28 @@
                 <a:ea typeface="Arial" pitchFamily="34" charset="-122"/>
                 <a:cs typeface="Arial" pitchFamily="34" charset="-120"/>
               </a:rPr>
-              <a:t>Build a batch before you start dialing — volume matters.</a:t>
+              <a:t>Build a batch before you start dialing, because volume matters.</a:t>
+            </a:r>
+            <a:endParaRPr lang="en-US" sz="1050" dirty="0"/>
+          </a:p>
+          <a:p>
+            <a:pPr marL="342900" indent="-342900">
+              <a:spcAft>
+                <a:spcPts val="900"/>
+              </a:spcAft>
+              <a:buSzPct val="100000"/>
+              <a:buChar char="•"/>
+            </a:pPr>
+            <a:r>
+              <a:rPr lang="en-US" sz="1050" dirty="0">
+                <a:solidFill>
+                  <a:srgbClr val="44505F"/>
+                </a:solidFill>
+                <a:latin typeface="Arial" pitchFamily="34" charset="0"/>
+                <a:ea typeface="Arial" pitchFamily="34" charset="-122"/>
+                <a:cs typeface="Arial" pitchFamily="34" charset="-120"/>
+              </a:rPr>
+              <a:t>Rental offices are a strong second vertical: the agent books apartment viewings.</a:t>
             </a:r>
             <a:endParaRPr lang="en-US" sz="1050" dirty="0"/>
           </a:p>
@@ -3929,17 +3915,24 @@
           </a:solidFill>
           <a:ln/>
         </p:spPr>
+        <p:txBody>
+          <a:bodyPr/>
+          <a:lstStyle/>
+          <a:p>
+            <a:endParaRPr lang="en-US"/>
+          </a:p>
+        </p:txBody>
       </p:sp>
       <p:pic>
         <p:nvPicPr>
-          <p:cNvPr id="14" name="Image 1" descr="preencoded.png">    </p:cNvPr>
+          <p:cNvPr id="14" name="Image 1" descr="preencoded.png"/>
           <p:cNvPicPr>
             <a:picLocks noChangeAspect="1"/>
           </p:cNvPicPr>
           <p:nvPr/>
         </p:nvPicPr>
         <p:blipFill>
-          <a:blip r:embed="rId2"/>
+          <a:blip r:embed="rId3"/>
           <a:stretch>
             <a:fillRect/>
           </a:stretch>
@@ -3975,7 +3968,7 @@
           <a:bodyPr wrap="square" lIns="0" tIns="0" rIns="0" bIns="0" rtlCol="0" anchor="ctr"/>
           <a:lstStyle/>
           <a:p>
-            <a:pPr indent="0" marL="0">
+            <a:pPr marL="0" indent="0">
               <a:buNone/>
             </a:pPr>
             <a:r>
@@ -4014,7 +4007,7 @@
           <a:bodyPr wrap="square" lIns="0" tIns="0" rIns="0" bIns="0" rtlCol="0" anchor="ctr"/>
           <a:lstStyle/>
           <a:p>
-            <a:pPr indent="0" marL="0">
+            <a:pPr marL="0" indent="0">
               <a:lnSpc>
                 <a:spcPct val="120000"/>
               </a:lnSpc>
@@ -4029,13 +4022,18 @@
                 <a:ea typeface="Arial" pitchFamily="34" charset="-122"/>
                 <a:cs typeface="Arial" pitchFamily="34" charset="-120"/>
               </a:rPr>
-              <a:t>/locksmith-outreach finds shops by city, grabs their published email, and creates CASL-compliant Gmail drafts. The dedup ledger is outreach/contacted.csv — reruns never double-contact.</a:t>
+              <a:t>/locksmith-outreach finds shops by city, grabs their published email, and creates ready-to-send Gmail drafts. The dedup ledger is outreach/contacted.csv; reruns check the ledger first.</a:t>
             </a:r>
             <a:endParaRPr lang="en-US" sz="1050" dirty="0"/>
           </a:p>
         </p:txBody>
       </p:sp>
     </p:spTree>
+    <p:extLst>
+      <p:ext uri="{BB962C8B-B14F-4D97-AF65-F5344CB8AC3E}">
+        <p14:creationId xmlns:p14="http://schemas.microsoft.com/office/powerpoint/2010/main" val="977664205"/>
+      </p:ext>
+    </p:extLst>
   </p:cSld>
   <p:clrMapOvr>
     <a:masterClrMapping/>
@@ -4051,6 +4049,7 @@
         <a:solidFill>
           <a:srgbClr val="FFFFFF"/>
         </a:solidFill>
+        <a:effectLst/>
       </p:bgPr>
     </p:bg>
     <p:spTree>
@@ -4069,14 +4068,14 @@
       </p:grpSpPr>
       <p:pic>
         <p:nvPicPr>
-          <p:cNvPr id="2" name="Image 0" descr="preencoded.png">    </p:cNvPr>
+          <p:cNvPr id="2" name="Image 0" descr="preencoded.png"/>
           <p:cNvPicPr>
             <a:picLocks noChangeAspect="1"/>
           </p:cNvPicPr>
           <p:nvPr/>
         </p:nvPicPr>
         <p:blipFill>
-          <a:blip r:embed="rId1"/>
+          <a:blip r:embed="rId3"/>
           <a:stretch>
             <a:fillRect/>
           </a:stretch>
@@ -4112,7 +4111,7 @@
           <a:bodyPr wrap="square" lIns="0" tIns="0" rIns="0" bIns="0" rtlCol="0" anchor="ctr"/>
           <a:lstStyle/>
           <a:p>
-            <a:pPr indent="0" marL="0">
+            <a:pPr marL="0" indent="0">
               <a:buNone/>
             </a:pPr>
             <a:r>
@@ -4151,7 +4150,7 @@
           <a:bodyPr wrap="square" lIns="0" tIns="0" rIns="0" bIns="0" rtlCol="0" anchor="ctr"/>
           <a:lstStyle/>
           <a:p>
-            <a:pPr algn="r" indent="0" marL="0">
+            <a:pPr marL="0" indent="0" algn="r">
               <a:buNone/>
             </a:pPr>
             <a:r>
@@ -4188,6 +4187,13 @@
           </a:solidFill>
           <a:ln/>
         </p:spPr>
+        <p:txBody>
+          <a:bodyPr/>
+          <a:lstStyle/>
+          <a:p>
+            <a:endParaRPr lang="en-US"/>
+          </a:p>
+        </p:txBody>
       </p:sp>
       <p:sp>
         <p:nvSpPr>
@@ -4210,7 +4216,7 @@
           <a:bodyPr wrap="square" lIns="0" tIns="0" rIns="0" bIns="0" rtlCol="0" anchor="ctr"/>
           <a:lstStyle/>
           <a:p>
-            <a:pPr indent="0" marL="0">
+            <a:pPr marL="0" indent="0">
               <a:buNone/>
             </a:pPr>
             <a:r>
@@ -4224,9 +4230,6 @@
               </a:rPr>
               <a:t>02   </a:t>
             </a:r>
-            <a:pPr indent="0" marL="0">
-              <a:buNone/>
-            </a:pPr>
             <a:r>
               <a:rPr lang="en-US" sz="2600" b="1" dirty="0">
                 <a:solidFill>
@@ -4236,7 +4239,7 @@
                 <a:ea typeface="Arial" pitchFamily="34" charset="-122"/>
                 <a:cs typeface="Arial" pitchFamily="34" charset="-120"/>
               </a:rPr>
-              <a:t>Cold call</a:t>
+              <a:t>Cold Call</a:t>
             </a:r>
             <a:endParaRPr lang="en-US" sz="2600" dirty="0"/>
           </a:p>
@@ -4268,6 +4271,13 @@
             <a:prstDash val="solid"/>
           </a:ln>
         </p:spPr>
+        <p:txBody>
+          <a:bodyPr/>
+          <a:lstStyle/>
+          <a:p>
+            <a:endParaRPr lang="en-US"/>
+          </a:p>
+        </p:txBody>
       </p:sp>
       <p:sp>
         <p:nvSpPr>
@@ -4290,7 +4300,7 @@
           <a:bodyPr wrap="square" lIns="0" tIns="0" rIns="0" bIns="0" rtlCol="0" anchor="ctr"/>
           <a:lstStyle/>
           <a:p>
-            <a:pPr indent="0" marL="0">
+            <a:pPr marL="0" indent="0">
               <a:buNone/>
             </a:pPr>
             <a:r>
@@ -4302,21 +4312,7 @@
                 <a:ea typeface="Arial" pitchFamily="34" charset="-122"/>
                 <a:cs typeface="Arial" pitchFamily="34" charset="-120"/>
               </a:rPr>
-              <a:t>GOAL   </a:t>
-            </a:r>
-            <a:pPr indent="0" marL="0">
-              <a:buNone/>
-            </a:pPr>
-            <a:r>
-              <a:rPr lang="en-US" sz="1200" dirty="0">
-                <a:solidFill>
-                  <a:srgbClr val="0C1726"/>
-                </a:solidFill>
-                <a:latin typeface="Arial" pitchFamily="34" charset="0"/>
-                <a:ea typeface="Arial" pitchFamily="34" charset="-122"/>
-                <a:cs typeface="Arial" pitchFamily="34" charset="-120"/>
-              </a:rPr>
-              <a:t>Book a 15-minute demo. Nothing more.</a:t>
+              <a:t>Get a Zoom demo booked, ideally the same day, and nothing else.</a:t>
             </a:r>
             <a:endParaRPr lang="en-US" sz="1000" dirty="0"/>
           </a:p>
@@ -4343,11 +4339,11 @@
           <a:bodyPr wrap="square" lIns="0" tIns="0" rIns="0" bIns="0" rtlCol="0" anchor="ctr"/>
           <a:lstStyle/>
           <a:p>
-            <a:pPr indent="0" marL="0">
+            <a:pPr marL="0" indent="0">
               <a:buNone/>
             </a:pPr>
             <a:r>
-              <a:rPr lang="en-US" sz="1100" b="1" spc="100" kern="0" dirty="0">
+              <a:rPr lang="en-US" sz="1100" b="1" kern="0" spc="100" dirty="0">
                 <a:solidFill>
                   <a:srgbClr val="0C1726"/>
                 </a:solidFill>
@@ -4388,7 +4384,7 @@
               </a:spcAft>
               <a:buSzPct val="100000"/>
               <a:buFont typeface="+mj-lt"/>
-              <a:buAutoNum type="arabicPeriod" startAt="1"/>
+              <a:buAutoNum type="arabicPeriod"/>
             </a:pPr>
             <a:r>
               <a:rPr lang="en-US" sz="1050" dirty="0">
@@ -4399,7 +4395,7 @@
                 <a:ea typeface="Arial" pitchFamily="34" charset="-122"/>
                 <a:cs typeface="Arial" pitchFamily="34" charset="-120"/>
               </a:rPr>
-              <a:t>Call during work hours; avoid the obvious emergency rush.</a:t>
+              <a:t>Keep it under 10 minutes; the volume game is won here.</a:t>
             </a:r>
             <a:endParaRPr lang="en-US" sz="1050" dirty="0"/>
           </a:p>
@@ -4410,7 +4406,7 @@
               </a:spcAft>
               <a:buSzPct val="100000"/>
               <a:buFont typeface="+mj-lt"/>
-              <a:buAutoNum type="arabicPeriod" startAt="1"/>
+              <a:buAutoNum type="arabicPeriod"/>
             </a:pPr>
             <a:r>
               <a:rPr lang="en-US" sz="1050" dirty="0">
@@ -4421,7 +4417,7 @@
                 <a:ea typeface="Arial" pitchFamily="34" charset="-122"/>
                 <a:cs typeface="Arial" pitchFamily="34" charset="-120"/>
               </a:rPr>
-              <a:t>Open with your name and the pain you solve, not the product.</a:t>
+              <a:t>Open with the pain question, then listen: “When you’re on a job or it’s after hours and a call comes in, what happens to it right now?”</a:t>
             </a:r>
             <a:endParaRPr lang="en-US" sz="1050" dirty="0"/>
           </a:p>
@@ -4432,7 +4428,7 @@
               </a:spcAft>
               <a:buSzPct val="100000"/>
               <a:buFont typeface="+mj-lt"/>
-              <a:buAutoNum type="arabicPeriod" startAt="1"/>
+              <a:buAutoNum type="arabicPeriod"/>
             </a:pPr>
             <a:r>
               <a:rPr lang="en-US" sz="1050" dirty="0">
@@ -4443,7 +4439,7 @@
                 <a:ea typeface="Arial" pitchFamily="34" charset="-122"/>
                 <a:cs typeface="Arial" pitchFamily="34" charset="-120"/>
               </a:rPr>
-              <a:t>Hook: 'When someone's locked out at 2am, do they leave a voicemail?'</a:t>
+              <a:t>One-liner: an AI agent answers when you can’t, captures the job details, and texts you the lead, 24/7.</a:t>
             </a:r>
             <a:endParaRPr lang="en-US" sz="1050" dirty="0"/>
           </a:p>
@@ -4454,7 +4450,7 @@
               </a:spcAft>
               <a:buSzPct val="100000"/>
               <a:buFont typeface="+mj-lt"/>
-              <a:buAutoNum type="arabicPeriod" startAt="1"/>
+              <a:buAutoNum type="arabicPeriod"/>
             </a:pPr>
             <a:r>
               <a:rPr lang="en-US" sz="1050" dirty="0">
@@ -4465,7 +4461,7 @@
                 <a:ea typeface="Arial" pitchFamily="34" charset="-122"/>
                 <a:cs typeface="Arial" pitchFamily="34" charset="-120"/>
               </a:rPr>
-              <a:t>One line: AI answers, captures the job, texts you the lead — 24/7.</a:t>
+              <a:t>Tease the Zoom as value, not a pitch: “Hop on a quick Zoom with me. I’ll show you a few ways contractors are using AI to catch more jobs, and you’ll test ours live from your own phone.”</a:t>
             </a:r>
             <a:endParaRPr lang="en-US" sz="1050" dirty="0"/>
           </a:p>
@@ -4476,7 +4472,7 @@
               </a:spcAft>
               <a:buSzPct val="100000"/>
               <a:buFont typeface="+mj-lt"/>
-              <a:buAutoNum type="arabicPeriod" startAt="1"/>
+              <a:buAutoNum type="arabicPeriod"/>
             </a:pPr>
             <a:r>
               <a:rPr lang="en-US" sz="1050" dirty="0">
@@ -4487,7 +4483,29 @@
                 <a:ea typeface="Arial" pitchFamily="34" charset="-122"/>
                 <a:cs typeface="Arial" pitchFamily="34" charset="-120"/>
               </a:rPr>
-              <a:t>Ask for the demo and book it live on Calendly.</a:t>
+              <a:t>Book the Zoom live on the call: offer two concrete times (same day first, next morning second), send the invite while still on the phone, and confirm they received it before hanging up. The calendar link is only a fallback if they truly can’t commit to a time.</a:t>
+            </a:r>
+            <a:endParaRPr lang="en-US" sz="1050" dirty="0"/>
+          </a:p>
+          <a:p>
+            <a:pPr marL="342900" indent="-342900">
+              <a:spcAft>
+                <a:spcPts val="900"/>
+              </a:spcAft>
+              <a:buSzPct val="100000"/>
+              <a:buFont typeface="+mj-lt"/>
+              <a:buAutoNum type="arabicPeriod"/>
+            </a:pPr>
+            <a:r>
+              <a:rPr lang="en-US" sz="1050" dirty="0">
+                <a:solidFill>
+                  <a:srgbClr val="44505F"/>
+                </a:solidFill>
+                <a:latin typeface="Arial" pitchFamily="34" charset="0"/>
+                <a:ea typeface="Arial" pitchFamily="34" charset="-122"/>
+                <a:cs typeface="Arial" pitchFamily="34" charset="-120"/>
+              </a:rPr>
+              <a:t>Right after hanging up, text them the demo number and the invite: “Call this anytime. It’s what your customers would hear.”</a:t>
             </a:r>
             <a:endParaRPr lang="en-US" sz="1050" dirty="0"/>
           </a:p>
@@ -4514,11 +4532,11 @@
           <a:bodyPr wrap="square" lIns="0" tIns="0" rIns="0" bIns="0" rtlCol="0" anchor="ctr"/>
           <a:lstStyle/>
           <a:p>
-            <a:pPr indent="0" marL="0">
+            <a:pPr marL="0" indent="0">
               <a:buNone/>
             </a:pPr>
             <a:r>
-              <a:rPr lang="en-US" sz="1100" b="1" spc="100" kern="0" dirty="0">
+              <a:rPr lang="en-US" sz="1100" b="1" kern="0" spc="100" dirty="0">
                 <a:solidFill>
                   <a:srgbClr val="0C1726"/>
                 </a:solidFill>
@@ -4569,7 +4587,7 @@
                 <a:ea typeface="Arial" pitchFamily="34" charset="-122"/>
                 <a:cs typeface="Arial" pitchFamily="34" charset="-120"/>
               </a:rPr>
-              <a:t>The call's only goal is the demo — don't over-explain.</a:t>
+              <a:t>Log every outcome: booked / call back / not interested / no answer.</a:t>
             </a:r>
             <a:endParaRPr lang="en-US" sz="1050" dirty="0"/>
           </a:p>
@@ -4590,7 +4608,7 @@
                 <a:ea typeface="Arial" pitchFamily="34" charset="-122"/>
                 <a:cs typeface="Arial" pitchFamily="34" charset="-120"/>
               </a:rPr>
-              <a:t>Lead with their pain; features come in the demo.</a:t>
+              <a:t>After three no-answer attempts, move them to the follow-up track.</a:t>
             </a:r>
             <a:endParaRPr lang="en-US" sz="1050" dirty="0"/>
           </a:p>
@@ -4611,17 +4629,17 @@
                 <a:ea typeface="Arial" pitchFamily="34" charset="-122"/>
                 <a:cs typeface="Arial" pitchFamily="34" charset="-120"/>
               </a:rPr>
-              <a:t>Have the Calendly link open and book on the call.</a:t>
+              <a:t>Show rate drops with every day of delay: same day beats tomorrow beats next week.</a:t>
             </a:r>
             <a:endParaRPr lang="en-US" sz="1050" dirty="0"/>
           </a:p>
           <a:p>
-            <a:pPr marL="342900" indent="-342900">
+            <a:pPr marL="0" indent="0">
               <a:spcAft>
                 <a:spcPts val="900"/>
               </a:spcAft>
               <a:buSzPct val="100000"/>
-              <a:buChar char="•"/>
+              <a:buNone/>
             </a:pPr>
             <a:r>
               <a:rPr lang="en-US" sz="1050" dirty="0">
@@ -4632,7 +4650,7 @@
                 <a:ea typeface="Arial" pitchFamily="34" charset="-122"/>
                 <a:cs typeface="Arial" pitchFamily="34" charset="-120"/>
               </a:rPr>
-              <a:t>Log the outcome: booked / call back / not interested / no answer.</a:t>
+              <a:t>Stage done = Zoom booked with a confirmed time, or 3 call attempts logged.</a:t>
             </a:r>
             <a:endParaRPr lang="en-US" sz="1050" dirty="0"/>
           </a:p>
@@ -4659,17 +4677,24 @@
           </a:solidFill>
           <a:ln/>
         </p:spPr>
+        <p:txBody>
+          <a:bodyPr/>
+          <a:lstStyle/>
+          <a:p>
+            <a:endParaRPr lang="en-US"/>
+          </a:p>
+        </p:txBody>
       </p:sp>
       <p:pic>
         <p:nvPicPr>
-          <p:cNvPr id="14" name="Image 1" descr="preencoded.png">    </p:cNvPr>
+          <p:cNvPr id="14" name="Image 1" descr="preencoded.png"/>
           <p:cNvPicPr>
             <a:picLocks noChangeAspect="1"/>
           </p:cNvPicPr>
           <p:nvPr/>
         </p:nvPicPr>
         <p:blipFill>
-          <a:blip r:embed="rId2"/>
+          <a:blip r:embed="rId3"/>
           <a:stretch>
             <a:fillRect/>
           </a:stretch>
@@ -4705,7 +4730,7 @@
           <a:bodyPr wrap="square" lIns="0" tIns="0" rIns="0" bIns="0" rtlCol="0" anchor="ctr"/>
           <a:lstStyle/>
           <a:p>
-            <a:pPr indent="0" marL="0">
+            <a:pPr marL="0" indent="0">
               <a:buNone/>
             </a:pPr>
             <a:r>
@@ -4744,7 +4769,7 @@
           <a:bodyPr wrap="square" lIns="0" tIns="0" rIns="0" bIns="0" rtlCol="0" anchor="ctr"/>
           <a:lstStyle/>
           <a:p>
-            <a:pPr indent="0" marL="0">
+            <a:pPr marL="0" indent="0">
               <a:lnSpc>
                 <a:spcPct val="120000"/>
               </a:lnSpc>
@@ -4759,13 +4784,18 @@
                 <a:ea typeface="Arial" pitchFamily="34" charset="-122"/>
                 <a:cs typeface="Arial" pitchFamily="34" charset="-120"/>
               </a:rPr>
-              <a:t>“Hi [name], it's [you] with Dispango. Quick one — when you're on a job or it's after hours and a call comes in, what happens to it right now?”  …  “That's exactly what we fix. Can I show you in 15 minutes how it'd answer your number — does Thursday or Friday work?”</a:t>
+              <a:t>“Hi [name], it’s [you] with Dispango. Quick one: when you’re on a job or it’s after hours and a call comes in, what happens to it right now?” … “That’s exactly what we fix. Hop on a quick Zoom and you’ll test it from your own phone. I’ve got 4:00 today or 9:00 tomorrow. Which works? I’ll send the invite now.”</a:t>
             </a:r>
             <a:endParaRPr lang="en-US" sz="1050" dirty="0"/>
           </a:p>
         </p:txBody>
       </p:sp>
     </p:spTree>
+    <p:extLst>
+      <p:ext uri="{BB962C8B-B14F-4D97-AF65-F5344CB8AC3E}">
+        <p14:creationId xmlns:p14="http://schemas.microsoft.com/office/powerpoint/2010/main" val="1586856499"/>
+      </p:ext>
+    </p:extLst>
   </p:cSld>
   <p:clrMapOvr>
     <a:masterClrMapping/>
@@ -4781,6 +4811,7 @@
         <a:solidFill>
           <a:srgbClr val="FFFFFF"/>
         </a:solidFill>
+        <a:effectLst/>
       </p:bgPr>
     </p:bg>
     <p:spTree>
@@ -4799,14 +4830,14 @@
       </p:grpSpPr>
       <p:pic>
         <p:nvPicPr>
-          <p:cNvPr id="2" name="Image 0" descr="preencoded.png">    </p:cNvPr>
+          <p:cNvPr id="2" name="Image 0" descr="preencoded.png"/>
           <p:cNvPicPr>
             <a:picLocks noChangeAspect="1"/>
           </p:cNvPicPr>
           <p:nvPr/>
         </p:nvPicPr>
         <p:blipFill>
-          <a:blip r:embed="rId1"/>
+          <a:blip r:embed="rId3"/>
           <a:stretch>
             <a:fillRect/>
           </a:stretch>
@@ -4842,7 +4873,7 @@
           <a:bodyPr wrap="square" lIns="0" tIns="0" rIns="0" bIns="0" rtlCol="0" anchor="ctr"/>
           <a:lstStyle/>
           <a:p>
-            <a:pPr indent="0" marL="0">
+            <a:pPr marL="0" indent="0">
               <a:buNone/>
             </a:pPr>
             <a:r>
@@ -4881,7 +4912,7 @@
           <a:bodyPr wrap="square" lIns="0" tIns="0" rIns="0" bIns="0" rtlCol="0" anchor="ctr"/>
           <a:lstStyle/>
           <a:p>
-            <a:pPr algn="r" indent="0" marL="0">
+            <a:pPr marL="0" indent="0" algn="r">
               <a:buNone/>
             </a:pPr>
             <a:r>
@@ -4918,6 +4949,13 @@
           </a:solidFill>
           <a:ln/>
         </p:spPr>
+        <p:txBody>
+          <a:bodyPr/>
+          <a:lstStyle/>
+          <a:p>
+            <a:endParaRPr lang="en-US"/>
+          </a:p>
+        </p:txBody>
       </p:sp>
       <p:sp>
         <p:nvSpPr>
@@ -4940,7 +4978,7 @@
           <a:bodyPr wrap="square" lIns="0" tIns="0" rIns="0" bIns="0" rtlCol="0" anchor="ctr"/>
           <a:lstStyle/>
           <a:p>
-            <a:pPr indent="0" marL="0">
+            <a:pPr marL="0" indent="0">
               <a:buNone/>
             </a:pPr>
             <a:r>
@@ -4954,9 +4992,6 @@
               </a:rPr>
               <a:t>03   </a:t>
             </a:r>
-            <a:pPr indent="0" marL="0">
-              <a:buNone/>
-            </a:pPr>
             <a:r>
               <a:rPr lang="en-US" sz="2600" b="1" dirty="0">
                 <a:solidFill>
@@ -4966,7 +5001,7 @@
                 <a:ea typeface="Arial" pitchFamily="34" charset="-122"/>
                 <a:cs typeface="Arial" pitchFamily="34" charset="-120"/>
               </a:rPr>
-              <a:t>Follow up (missed call)</a:t>
+              <a:t>Demo &amp; Trial</a:t>
             </a:r>
             <a:endParaRPr lang="en-US" sz="2600" dirty="0"/>
           </a:p>
@@ -4998,6 +5033,13 @@
             <a:prstDash val="solid"/>
           </a:ln>
         </p:spPr>
+        <p:txBody>
+          <a:bodyPr/>
+          <a:lstStyle/>
+          <a:p>
+            <a:endParaRPr lang="en-US"/>
+          </a:p>
+        </p:txBody>
       </p:sp>
       <p:sp>
         <p:nvSpPr>
@@ -5020,7 +5062,7 @@
           <a:bodyPr wrap="square" lIns="0" tIns="0" rIns="0" bIns="0" rtlCol="0" anchor="ctr"/>
           <a:lstStyle/>
           <a:p>
-            <a:pPr indent="0" marL="0">
+            <a:pPr marL="0" indent="0">
               <a:buNone/>
             </a:pPr>
             <a:r>
@@ -5032,21 +5074,7 @@
                 <a:ea typeface="Arial" pitchFamily="34" charset="-122"/>
                 <a:cs typeface="Arial" pitchFamily="34" charset="-120"/>
               </a:rPr>
-              <a:t>GOAL   </a:t>
-            </a:r>
-            <a:pPr indent="0" marL="0">
-              <a:buNone/>
-            </a:pPr>
-            <a:r>
-              <a:rPr lang="en-US" sz="1200" dirty="0">
-                <a:solidFill>
-                  <a:srgbClr val="0C1726"/>
-                </a:solidFill>
-                <a:latin typeface="Arial" pitchFamily="34" charset="0"/>
-                <a:ea typeface="Arial" pitchFamily="34" charset="-122"/>
-                <a:cs typeface="Arial" pitchFamily="34" charset="-120"/>
-              </a:rPr>
-              <a:t>Reconnect when the cold call didn't land.</a:t>
+              <a:t>Deliver real value on Zoom, let them test the agent live, and start a one-week free trial.</a:t>
             </a:r>
             <a:endParaRPr lang="en-US" sz="1000" dirty="0"/>
           </a:p>
@@ -5073,11 +5101,11 @@
           <a:bodyPr wrap="square" lIns="0" tIns="0" rIns="0" bIns="0" rtlCol="0" anchor="ctr"/>
           <a:lstStyle/>
           <a:p>
-            <a:pPr indent="0" marL="0">
+            <a:pPr marL="0" indent="0">
               <a:buNone/>
             </a:pPr>
             <a:r>
-              <a:rPr lang="en-US" sz="1100" b="1" spc="100" kern="0" dirty="0">
+              <a:rPr lang="en-US" sz="1100" b="1" kern="0" spc="100" dirty="0">
                 <a:solidFill>
                   <a:srgbClr val="0C1726"/>
                 </a:solidFill>
@@ -5118,7 +5146,7 @@
               </a:spcAft>
               <a:buSzPct val="100000"/>
               <a:buFont typeface="+mj-lt"/>
-              <a:buAutoNum type="arabicPeriod" startAt="1"/>
+              <a:buAutoNum type="arabicPeriod"/>
             </a:pPr>
             <a:r>
               <a:rPr lang="en-US" sz="1050" dirty="0">
@@ -5129,7 +5157,7 @@
                 <a:ea typeface="Arial" pitchFamily="34" charset="-122"/>
                 <a:cs typeface="Arial" pitchFamily="34" charset="-120"/>
               </a:rPr>
-              <a:t>Same day: a short voicemail — who you are, 'I'll text you the details.'</a:t>
+              <a:t>Before the call, set the demo agent’s lead-text destination to the prospect’s cell number in the admin tool.</a:t>
             </a:r>
             <a:endParaRPr lang="en-US" sz="1050" dirty="0"/>
           </a:p>
@@ -5140,7 +5168,7 @@
               </a:spcAft>
               <a:buSzPct val="100000"/>
               <a:buFont typeface="+mj-lt"/>
-              <a:buAutoNum type="arabicPeriod" startAt="1"/>
+              <a:buAutoNum type="arabicPeriod"/>
             </a:pPr>
             <a:r>
               <a:rPr lang="en-US" sz="1050" dirty="0">
@@ -5151,7 +5179,7 @@
                 <a:ea typeface="Arial" pitchFamily="34" charset="-122"/>
                 <a:cs typeface="Arial" pitchFamily="34" charset="-120"/>
               </a:rPr>
-              <a:t>Right after: SMS or email with the one-liner, Calendly link, and brochure.</a:t>
+              <a:t>Open with 5 minutes of pure value: how contractors are using AI to win more jobs, from missed-call capture and after-hours booking to rental offices auto-booking apartment viewings. Teach, don’t pitch.</a:t>
             </a:r>
             <a:endParaRPr lang="en-US" sz="1050" dirty="0"/>
           </a:p>
@@ -5162,7 +5190,7 @@
               </a:spcAft>
               <a:buSzPct val="100000"/>
               <a:buFont typeface="+mj-lt"/>
-              <a:buAutoNum type="arabicPeriod" startAt="1"/>
+              <a:buAutoNum type="arabicPeriod"/>
             </a:pPr>
             <a:r>
               <a:rPr lang="en-US" sz="1050" dirty="0">
@@ -5173,7 +5201,7 @@
                 <a:ea typeface="Arial" pitchFamily="34" charset="-122"/>
                 <a:cs typeface="Arial" pitchFamily="34" charset="-120"/>
               </a:rPr>
-              <a:t>Day 2-3: second touch, a new angle (a stat or the lead-text example).</a:t>
+              <a:t>Replay their pain from the cold call, in their own words.</a:t>
             </a:r>
             <a:endParaRPr lang="en-US" sz="1050" dirty="0"/>
           </a:p>
@@ -5184,7 +5212,7 @@
               </a:spcAft>
               <a:buSzPct val="100000"/>
               <a:buFont typeface="+mj-lt"/>
-              <a:buAutoNum type="arabicPeriod" startAt="1"/>
+              <a:buAutoNum type="arabicPeriod"/>
             </a:pPr>
             <a:r>
               <a:rPr lang="en-US" sz="1050" dirty="0">
@@ -5195,7 +5223,7 @@
                 <a:ea typeface="Arial" pitchFamily="34" charset="-122"/>
                 <a:cs typeface="Arial" pitchFamily="34" charset="-120"/>
               </a:rPr>
-              <a:t>Day 5-7: the breakup — 'should I close your file?'</a:t>
+              <a:t>The live test: they call the demo number from their cell while on Zoom, playing the customer. When they hang up, the structured lead text arrives on their own phone within seconds. Let that moment breathe.</a:t>
             </a:r>
             <a:endParaRPr lang="en-US" sz="1050" dirty="0"/>
           </a:p>
@@ -5206,7 +5234,7 @@
               </a:spcAft>
               <a:buSzPct val="100000"/>
               <a:buFont typeface="+mj-lt"/>
-              <a:buAutoNum type="arabicPeriod" startAt="1"/>
+              <a:buAutoNum type="arabicPeriod"/>
             </a:pPr>
             <a:r>
               <a:rPr lang="en-US" sz="1050" dirty="0">
@@ -5217,7 +5245,29 @@
                 <a:ea typeface="Arial" pitchFamily="34" charset="-122"/>
                 <a:cs typeface="Arial" pitchFamily="34" charset="-120"/>
               </a:rPr>
-              <a:t>Stop after 3-4 touches; mark the status.</a:t>
+              <a:t>Offer the trial: one week free, they forward busy and no-answer calls, they keep every lead captured, with no strings attached.</a:t>
+            </a:r>
+            <a:endParaRPr lang="en-US" sz="1050" dirty="0"/>
+          </a:p>
+          <a:p>
+            <a:pPr marL="342900" indent="-342900">
+              <a:spcAft>
+                <a:spcPts val="900"/>
+              </a:spcAft>
+              <a:buSzPct val="100000"/>
+              <a:buFont typeface="+mj-lt"/>
+              <a:buAutoNum type="arabicPeriod"/>
+            </a:pPr>
+            <a:r>
+              <a:rPr lang="en-US" sz="1050" dirty="0">
+                <a:solidFill>
+                  <a:srgbClr val="44505F"/>
+                </a:solidFill>
+                <a:latin typeface="Arial" pitchFamily="34" charset="0"/>
+                <a:ea typeface="Arial" pitchFamily="34" charset="-122"/>
+                <a:cs typeface="Arial" pitchFamily="34" charset="-120"/>
+              </a:rPr>
+              <a:t>Start the trial before the Zoom ends if possible: set up call forwarding together and place one test call to confirm it works.</a:t>
             </a:r>
             <a:endParaRPr lang="en-US" sz="1050" dirty="0"/>
           </a:p>
@@ -5244,11 +5294,11 @@
           <a:bodyPr wrap="square" lIns="0" tIns="0" rIns="0" bIns="0" rtlCol="0" anchor="ctr"/>
           <a:lstStyle/>
           <a:p>
-            <a:pPr indent="0" marL="0">
+            <a:pPr marL="0" indent="0">
               <a:buNone/>
             </a:pPr>
             <a:r>
-              <a:rPr lang="en-US" sz="1100" b="1" spc="100" kern="0" dirty="0">
+              <a:rPr lang="en-US" sz="1100" b="1" kern="0" spc="100" dirty="0">
                 <a:solidFill>
                   <a:srgbClr val="0C1726"/>
                 </a:solidFill>
@@ -5299,7 +5349,7 @@
                 <a:ea typeface="Arial" pitchFamily="34" charset="-122"/>
                 <a:cs typeface="Arial" pitchFamily="34" charset="-120"/>
               </a:rPr>
-              <a:t>Reference the missed call ('tried you earlier today').</a:t>
+              <a:t>The value section makes the meeting worth their time, even if they never buy.</a:t>
             </a:r>
             <a:endParaRPr lang="en-US" sz="1050" dirty="0"/>
           </a:p>
@@ -5320,7 +5370,7 @@
                 <a:ea typeface="Arial" pitchFamily="34" charset="-122"/>
                 <a:cs typeface="Arial" pitchFamily="34" charset="-120"/>
               </a:rPr>
-              <a:t>Attach the one-page brochure PDF.</a:t>
+              <a:t>The trial is also qualification: if their phone never rings, the product isn’t for them, and that’s fine.</a:t>
             </a:r>
             <a:endParaRPr lang="en-US" sz="1050" dirty="0"/>
           </a:p>
@@ -5341,17 +5391,17 @@
                 <a:ea typeface="Arial" pitchFamily="34" charset="-122"/>
                 <a:cs typeface="Arial" pitchFamily="34" charset="-120"/>
               </a:rPr>
-              <a:t>Every email carries the CASL footer; honor opt-outs immediately.</a:t>
+              <a:t>A trial that starts same-day converts better than one that starts next week.</a:t>
             </a:r>
             <a:endParaRPr lang="en-US" sz="1050" dirty="0"/>
           </a:p>
           <a:p>
-            <a:pPr marL="342900" indent="-342900">
+            <a:pPr marL="0" indent="0">
               <a:spcAft>
                 <a:spcPts val="900"/>
               </a:spcAft>
               <a:buSzPct val="100000"/>
-              <a:buChar char="•"/>
+              <a:buNone/>
             </a:pPr>
             <a:r>
               <a:rPr lang="en-US" sz="1050" dirty="0">
@@ -5362,7 +5412,7 @@
                 <a:ea typeface="Arial" pitchFamily="34" charset="-122"/>
                 <a:cs typeface="Arial" pitchFamily="34" charset="-120"/>
               </a:rPr>
-              <a:t>Space the touches — persistent, not spammy.</a:t>
+              <a:t>Stage done = trial live, forwarding confirmed with a test call.</a:t>
             </a:r>
             <a:endParaRPr lang="en-US" sz="1050" dirty="0"/>
           </a:p>
@@ -5389,17 +5439,24 @@
           </a:solidFill>
           <a:ln/>
         </p:spPr>
+        <p:txBody>
+          <a:bodyPr/>
+          <a:lstStyle/>
+          <a:p>
+            <a:endParaRPr lang="en-US"/>
+          </a:p>
+        </p:txBody>
       </p:sp>
       <p:pic>
         <p:nvPicPr>
-          <p:cNvPr id="14" name="Image 1" descr="preencoded.png">    </p:cNvPr>
+          <p:cNvPr id="14" name="Image 1" descr="preencoded.png"/>
           <p:cNvPicPr>
             <a:picLocks noChangeAspect="1"/>
           </p:cNvPicPr>
           <p:nvPr/>
         </p:nvPicPr>
         <p:blipFill>
-          <a:blip r:embed="rId2"/>
+          <a:blip r:embed="rId3"/>
           <a:stretch>
             <a:fillRect/>
           </a:stretch>
@@ -5435,7 +5492,7 @@
           <a:bodyPr wrap="square" lIns="0" tIns="0" rIns="0" bIns="0" rtlCol="0" anchor="ctr"/>
           <a:lstStyle/>
           <a:p>
-            <a:pPr indent="0" marL="0">
+            <a:pPr marL="0" indent="0">
               <a:buNone/>
             </a:pPr>
             <a:r>
@@ -5447,7 +5504,7 @@
                 <a:ea typeface="Arial" pitchFamily="34" charset="-122"/>
                 <a:cs typeface="Arial" pitchFamily="34" charset="-120"/>
               </a:rPr>
-              <a:t>Assets</a:t>
+              <a:t>Trial offer</a:t>
             </a:r>
             <a:endParaRPr lang="en-US" sz="1100" dirty="0"/>
           </a:p>
@@ -5474,7 +5531,7 @@
           <a:bodyPr wrap="square" lIns="0" tIns="0" rIns="0" bIns="0" rtlCol="0" anchor="ctr"/>
           <a:lstStyle/>
           <a:p>
-            <a:pPr indent="0" marL="0">
+            <a:pPr marL="0" indent="0">
               <a:lnSpc>
                 <a:spcPct val="120000"/>
               </a:lnSpc>
@@ -5489,13 +5546,18 @@
                 <a:ea typeface="Arial" pitchFamily="34" charset="-122"/>
                 <a:cs typeface="Arial" pitchFamily="34" charset="-120"/>
               </a:rPr>
-              <a:t>Attach sales/Dispango-brochure.pdf and send the Calendly link. Every commercial email must include the CASL footer: sender identity, a physical mailing address, and a working unsubscribe.</a:t>
+              <a:t>“One week free. You forward your busy and no-answer calls, the agent answers what you can’t, and you keep every lead it captures. There are no strings: if it never rings, you’ve lost nothing.”</a:t>
             </a:r>
             <a:endParaRPr lang="en-US" sz="1050" dirty="0"/>
           </a:p>
         </p:txBody>
       </p:sp>
     </p:spTree>
+    <p:extLst>
+      <p:ext uri="{BB962C8B-B14F-4D97-AF65-F5344CB8AC3E}">
+        <p14:creationId xmlns:p14="http://schemas.microsoft.com/office/powerpoint/2010/main" val="3468401476"/>
+      </p:ext>
+    </p:extLst>
   </p:cSld>
   <p:clrMapOvr>
     <a:masterClrMapping/>
@@ -5505,12 +5567,13 @@
 
 <file path=ppt/slides/slide6.xml><?xml version="1.0" encoding="utf-8"?>
 <p:sld xmlns:a="http://schemas.openxmlformats.org/drawingml/2006/main" xmlns:r="http://schemas.openxmlformats.org/officeDocument/2006/relationships" xmlns:p="http://schemas.openxmlformats.org/presentationml/2006/main">
-  <p:cSld name="Slide 6">
+  <p:cSld name="Slide 5">
     <p:bg>
       <p:bgPr>
         <a:solidFill>
           <a:srgbClr val="FFFFFF"/>
         </a:solidFill>
+        <a:effectLst/>
       </p:bgPr>
     </p:bg>
     <p:spTree>
@@ -5529,14 +5592,14 @@
       </p:grpSpPr>
       <p:pic>
         <p:nvPicPr>
-          <p:cNvPr id="2" name="Image 0" descr="preencoded.png">    </p:cNvPr>
+          <p:cNvPr id="2" name="Image 0" descr="preencoded.png"/>
           <p:cNvPicPr>
             <a:picLocks noChangeAspect="1"/>
           </p:cNvPicPr>
           <p:nvPr/>
         </p:nvPicPr>
         <p:blipFill>
-          <a:blip r:embed="rId1"/>
+          <a:blip r:embed="rId3"/>
           <a:stretch>
             <a:fillRect/>
           </a:stretch>
@@ -5572,7 +5635,7 @@
           <a:bodyPr wrap="square" lIns="0" tIns="0" rIns="0" bIns="0" rtlCol="0" anchor="ctr"/>
           <a:lstStyle/>
           <a:p>
-            <a:pPr indent="0" marL="0">
+            <a:pPr marL="0" indent="0">
               <a:buNone/>
             </a:pPr>
             <a:r>
@@ -5611,7 +5674,7 @@
           <a:bodyPr wrap="square" lIns="0" tIns="0" rIns="0" bIns="0" rtlCol="0" anchor="ctr"/>
           <a:lstStyle/>
           <a:p>
-            <a:pPr algn="r" indent="0" marL="0">
+            <a:pPr marL="0" indent="0" algn="r">
               <a:buNone/>
             </a:pPr>
             <a:r>
@@ -5623,7 +5686,7 @@
                 <a:ea typeface="Arial" pitchFamily="34" charset="-122"/>
                 <a:cs typeface="Arial" pitchFamily="34" charset="-120"/>
               </a:rPr>
-              <a:t>Stage 4 of 5</a:t>
+              <a:t>Between stages</a:t>
             </a:r>
             <a:endParaRPr lang="en-US" sz="1000" dirty="0"/>
           </a:p>
@@ -5648,6 +5711,13 @@
           </a:solidFill>
           <a:ln/>
         </p:spPr>
+        <p:txBody>
+          <a:bodyPr/>
+          <a:lstStyle/>
+          <a:p>
+            <a:endParaRPr lang="en-US"/>
+          </a:p>
+        </p:txBody>
       </p:sp>
       <p:sp>
         <p:nvSpPr>
@@ -5670,7 +5740,7 @@
           <a:bodyPr wrap="square" lIns="0" tIns="0" rIns="0" bIns="0" rtlCol="0" anchor="ctr"/>
           <a:lstStyle/>
           <a:p>
-            <a:pPr indent="0" marL="0">
+            <a:pPr marL="0" indent="0">
               <a:buNone/>
             </a:pPr>
             <a:r>
@@ -5682,21 +5752,7 @@
                 <a:ea typeface="Arial" pitchFamily="34" charset="-122"/>
                 <a:cs typeface="Arial" pitchFamily="34" charset="-120"/>
               </a:rPr>
-              <a:t>04   </a:t>
-            </a:r>
-            <a:pPr indent="0" marL="0">
-              <a:buNone/>
-            </a:pPr>
-            <a:r>
-              <a:rPr lang="en-US" sz="2600" b="1" dirty="0">
-                <a:solidFill>
-                  <a:srgbClr val="0C1726"/>
-                </a:solidFill>
-                <a:latin typeface="Arial" pitchFamily="34" charset="0"/>
-                <a:ea typeface="Arial" pitchFamily="34" charset="-122"/>
-                <a:cs typeface="Arial" pitchFamily="34" charset="-120"/>
-              </a:rPr>
-              <a:t>Close</a:t>
+              <a:t>Follow-up: the motion between stages</a:t>
             </a:r>
             <a:endParaRPr lang="en-US" sz="2600" dirty="0"/>
           </a:p>
@@ -5728,6 +5784,13 @@
             <a:prstDash val="solid"/>
           </a:ln>
         </p:spPr>
+        <p:txBody>
+          <a:bodyPr/>
+          <a:lstStyle/>
+          <a:p>
+            <a:endParaRPr lang="en-US"/>
+          </a:p>
+        </p:txBody>
       </p:sp>
       <p:sp>
         <p:nvSpPr>
@@ -5750,7 +5813,7 @@
           <a:bodyPr wrap="square" lIns="0" tIns="0" rIns="0" bIns="0" rtlCol="0" anchor="ctr"/>
           <a:lstStyle/>
           <a:p>
-            <a:pPr indent="0" marL="0">
+            <a:pPr marL="0" indent="0">
               <a:buNone/>
             </a:pPr>
             <a:r>
@@ -5762,21 +5825,7 @@
                 <a:ea typeface="Arial" pitchFamily="34" charset="-122"/>
                 <a:cs typeface="Arial" pitchFamily="34" charset="-120"/>
               </a:rPr>
-              <a:t>GOAL   </a:t>
-            </a:r>
-            <a:pPr indent="0" marL="0">
-              <a:buNone/>
-            </a:pPr>
-            <a:r>
-              <a:rPr lang="en-US" sz="1200" dirty="0">
-                <a:solidFill>
-                  <a:srgbClr val="0C1726"/>
-                </a:solidFill>
-                <a:latin typeface="Arial" pitchFamily="34" charset="0"/>
-                <a:ea typeface="Arial" pitchFamily="34" charset="-122"/>
-                <a:cs typeface="Arial" pitchFamily="34" charset="-120"/>
-              </a:rPr>
-              <a:t>Turn the demo into a yes.</a:t>
+              <a:t>This is not a stage. Run it whenever a prospect stalls (didn’t answer, didn’t book, didn’t show, went quiet during trial): 3–4 touches over about a week.</a:t>
             </a:r>
             <a:endParaRPr lang="en-US" sz="1000" dirty="0"/>
           </a:p>
@@ -5803,11 +5852,11 @@
           <a:bodyPr wrap="square" lIns="0" tIns="0" rIns="0" bIns="0" rtlCol="0" anchor="ctr"/>
           <a:lstStyle/>
           <a:p>
-            <a:pPr indent="0" marL="0">
+            <a:pPr marL="0" indent="0">
               <a:buNone/>
             </a:pPr>
             <a:r>
-              <a:rPr lang="en-US" sz="1100" b="1" spc="100" kern="0" dirty="0">
+              <a:rPr lang="en-US" sz="1100" b="1" kern="0" spc="100" dirty="0">
                 <a:solidFill>
                   <a:srgbClr val="0C1726"/>
                 </a:solidFill>
@@ -5848,7 +5897,7 @@
               </a:spcAft>
               <a:buSzPct val="100000"/>
               <a:buFont typeface="+mj-lt"/>
-              <a:buAutoNum type="arabicPeriod" startAt="1"/>
+              <a:buAutoNum type="arabicPeriod"/>
             </a:pPr>
             <a:r>
               <a:rPr lang="en-US" sz="1050" dirty="0">
@@ -5859,7 +5908,7 @@
                 <a:ea typeface="Arial" pitchFamily="34" charset="-122"/>
                 <a:cs typeface="Arial" pitchFamily="34" charset="-120"/>
               </a:rPr>
-              <a:t>Run the demo deck; tailor it to the pain they named.</a:t>
+              <a:t>Same day: a short voicemail plus a text with the demo number and a 30-second recording of the agent handling a real call.</a:t>
             </a:r>
             <a:endParaRPr lang="en-US" sz="1050" dirty="0"/>
           </a:p>
@@ -5870,7 +5919,7 @@
               </a:spcAft>
               <a:buSzPct val="100000"/>
               <a:buFont typeface="+mj-lt"/>
-              <a:buAutoNum type="arabicPeriod" startAt="1"/>
+              <a:buAutoNum type="arabicPeriod"/>
             </a:pPr>
             <a:r>
               <a:rPr lang="en-US" sz="1050" dirty="0">
@@ -5881,7 +5930,7 @@
                 <a:ea typeface="Arial" pitchFamily="34" charset="-122"/>
                 <a:cs typeface="Arial" pitchFamily="34" charset="-120"/>
               </a:rPr>
-              <a:t>Show the lead-text example — that's the 'aha'.</a:t>
+              <a:t>Day 2–3: send proof, a screenshot of a lead text with one line of math on what a missed job costs.</a:t>
             </a:r>
             <a:endParaRPr lang="en-US" sz="1050" dirty="0"/>
           </a:p>
@@ -5892,7 +5941,7 @@
               </a:spcAft>
               <a:buSzPct val="100000"/>
               <a:buFont typeface="+mj-lt"/>
-              <a:buAutoNum type="arabicPeriod" startAt="1"/>
+              <a:buAutoNum type="arabicPeriod"/>
             </a:pPr>
             <a:r>
               <a:rPr lang="en-US" sz="1050" dirty="0">
@@ -5903,7 +5952,7 @@
                 <a:ea typeface="Arial" pitchFamily="34" charset="-122"/>
                 <a:cs typeface="Arial" pitchFamily="34" charset="-120"/>
               </a:rPr>
-              <a:t>State pricing simply; anchor on the value, not the cost.</a:t>
+              <a:t>Day 4–5: a pattern interrupt, something human and playful that triggers a reply. Try a skeleton meme captioned “me waiting to show you the demo”, or “[Name], still want to stop missing calls or should I close your file?”</a:t>
             </a:r>
             <a:endParaRPr lang="en-US" sz="1050" dirty="0"/>
           </a:p>
@@ -5914,7 +5963,7 @@
               </a:spcAft>
               <a:buSzPct val="100000"/>
               <a:buFont typeface="+mj-lt"/>
-              <a:buAutoNum type="arabicPeriod" startAt="1"/>
+              <a:buAutoNum type="arabicPeriod"/>
             </a:pPr>
             <a:r>
               <a:rPr lang="en-US" sz="1050" dirty="0">
@@ -5925,51 +5974,7 @@
                 <a:ea typeface="Arial" pitchFamily="34" charset="-122"/>
                 <a:cs typeface="Arial" pitchFamily="34" charset="-120"/>
               </a:rPr>
-              <a:t>Offer a trial demo on their own number.</a:t>
-            </a:r>
-            <a:endParaRPr lang="en-US" sz="1050" dirty="0"/>
-          </a:p>
-          <a:p>
-            <a:pPr marL="342900" indent="-342900">
-              <a:spcAft>
-                <a:spcPts val="900"/>
-              </a:spcAft>
-              <a:buSzPct val="100000"/>
-              <a:buFont typeface="+mj-lt"/>
-              <a:buAutoNum type="arabicPeriod" startAt="1"/>
-            </a:pPr>
-            <a:r>
-              <a:rPr lang="en-US" sz="1050" dirty="0">
-                <a:solidFill>
-                  <a:srgbClr val="44505F"/>
-                </a:solidFill>
-                <a:latin typeface="Arial" pitchFamily="34" charset="0"/>
-                <a:ea typeface="Arial" pitchFamily="34" charset="-122"/>
-                <a:cs typeface="Arial" pitchFamily="34" charset="-120"/>
-              </a:rPr>
-              <a:t>Ask for the close: 'Want me to set you up today?'</a:t>
-            </a:r>
-            <a:endParaRPr lang="en-US" sz="1050" dirty="0"/>
-          </a:p>
-          <a:p>
-            <a:pPr marL="342900" indent="-342900">
-              <a:spcAft>
-                <a:spcPts val="900"/>
-              </a:spcAft>
-              <a:buSzPct val="100000"/>
-              <a:buFont typeface="+mj-lt"/>
-              <a:buAutoNum type="arabicPeriod" startAt="1"/>
-            </a:pPr>
-            <a:r>
-              <a:rPr lang="en-US" sz="1050" dirty="0">
-                <a:solidFill>
-                  <a:srgbClr val="44505F"/>
-                </a:solidFill>
-                <a:latin typeface="Arial" pitchFamily="34" charset="0"/>
-                <a:ea typeface="Arial" pitchFamily="34" charset="-122"/>
-                <a:cs typeface="Arial" pitchFamily="34" charset="-120"/>
-              </a:rPr>
-              <a:t>Lock the onboarding step before you hang up.</a:t>
+              <a:t>The breakup: mark the status and stop.</a:t>
             </a:r>
             <a:endParaRPr lang="en-US" sz="1050" dirty="0"/>
           </a:p>
@@ -5996,11 +6001,11 @@
           <a:bodyPr wrap="square" lIns="0" tIns="0" rIns="0" bIns="0" rtlCol="0" anchor="ctr"/>
           <a:lstStyle/>
           <a:p>
-            <a:pPr indent="0" marL="0">
+            <a:pPr marL="0" indent="0">
               <a:buNone/>
             </a:pPr>
             <a:r>
-              <a:rPr lang="en-US" sz="1100" b="1" spc="100" kern="0" dirty="0">
+              <a:rPr lang="en-US" sz="1100" b="1" kern="0" spc="100" dirty="0">
                 <a:solidFill>
                   <a:srgbClr val="0C1726"/>
                 </a:solidFill>
@@ -6051,7 +6056,7 @@
                 <a:ea typeface="Arial" pitchFamily="34" charset="-122"/>
                 <a:cs typeface="Arial" pitchFamily="34" charset="-120"/>
               </a:rPr>
-              <a:t>Don't discount on reflex — sell the cost of a missed job.</a:t>
+              <a:t>Creativity earns replies that professionalism alone does not.</a:t>
             </a:r>
             <a:endParaRPr lang="en-US" sz="1050" dirty="0"/>
           </a:p>
@@ -6072,7 +6077,7 @@
                 <a:ea typeface="Arial" pitchFamily="34" charset="-122"/>
                 <a:cs typeface="Arial" pitchFamily="34" charset="-120"/>
               </a:rPr>
-              <a:t>'Sounds like a robot?' — it's a natural voice; most don't notice.</a:t>
+              <a:t>Always reference where they left off.</a:t>
             </a:r>
             <a:endParaRPr lang="en-US" sz="1050" dirty="0"/>
           </a:p>
@@ -6093,28 +6098,7 @@
                 <a:ea typeface="Arial" pitchFamily="34" charset="-122"/>
                 <a:cs typeface="Arial" pitchFamily="34" charset="-120"/>
               </a:rPr>
-              <a:t>'I answer my own calls' — it only steps in when you can't.</a:t>
-            </a:r>
-            <a:endParaRPr lang="en-US" sz="1050" dirty="0"/>
-          </a:p>
-          <a:p>
-            <a:pPr marL="342900" indent="-342900">
-              <a:spcAft>
-                <a:spcPts val="900"/>
-              </a:spcAft>
-              <a:buSzPct val="100000"/>
-              <a:buChar char="•"/>
-            </a:pPr>
-            <a:r>
-              <a:rPr lang="en-US" sz="1050" dirty="0">
-                <a:solidFill>
-                  <a:srgbClr val="44505F"/>
-                </a:solidFill>
-                <a:latin typeface="Arial" pitchFamily="34" charset="0"/>
-                <a:ea typeface="Arial" pitchFamily="34" charset="-122"/>
-                <a:cs typeface="Arial" pitchFamily="34" charset="-120"/>
-              </a:rPr>
-              <a:t>'Too complicated?' — we set it up; you're live in a day.</a:t>
+              <a:t>No-shows get an instant “still good for today?” text and one re-book attempt before entering this sequence.</a:t>
             </a:r>
             <a:endParaRPr lang="en-US" sz="1050" dirty="0"/>
           </a:p>
@@ -6141,17 +6125,24 @@
           </a:solidFill>
           <a:ln/>
         </p:spPr>
+        <p:txBody>
+          <a:bodyPr/>
+          <a:lstStyle/>
+          <a:p>
+            <a:endParaRPr lang="en-US"/>
+          </a:p>
+        </p:txBody>
       </p:sp>
       <p:pic>
         <p:nvPicPr>
-          <p:cNvPr id="14" name="Image 1" descr="preencoded.png">    </p:cNvPr>
+          <p:cNvPr id="14" name="Image 1" descr="preencoded.png"/>
           <p:cNvPicPr>
             <a:picLocks noChangeAspect="1"/>
           </p:cNvPicPr>
           <p:nvPr/>
         </p:nvPicPr>
         <p:blipFill>
-          <a:blip r:embed="rId2"/>
+          <a:blip r:embed="rId3"/>
           <a:stretch>
             <a:fillRect/>
           </a:stretch>
@@ -6187,7 +6178,7 @@
           <a:bodyPr wrap="square" lIns="0" tIns="0" rIns="0" bIns="0" rtlCol="0" anchor="ctr"/>
           <a:lstStyle/>
           <a:p>
-            <a:pPr indent="0" marL="0">
+            <a:pPr marL="0" indent="0">
               <a:buNone/>
             </a:pPr>
             <a:r>
@@ -6199,7 +6190,7 @@
                 <a:ea typeface="Arial" pitchFamily="34" charset="-122"/>
                 <a:cs typeface="Arial" pitchFamily="34" charset="-120"/>
               </a:rPr>
-              <a:t>Value anchor</a:t>
+              <a:t>Assets</a:t>
             </a:r>
             <a:endParaRPr lang="en-US" sz="1100" dirty="0"/>
           </a:p>
@@ -6226,14 +6217,14 @@
           <a:bodyPr wrap="square" lIns="0" tIns="0" rIns="0" bIns="0" rtlCol="0" anchor="ctr"/>
           <a:lstStyle/>
           <a:p>
-            <a:pPr indent="0" marL="0">
+            <a:pPr marL="0" indent="0">
               <a:lnSpc>
                 <a:spcPct val="120000"/>
               </a:lnSpc>
               <a:buNone/>
             </a:pPr>
             <a:r>
-              <a:rPr lang="en-US" sz="1050" i="1" dirty="0">
+              <a:rPr lang="en-US" sz="1050" dirty="0">
                 <a:solidFill>
                   <a:srgbClr val="FFFFFF"/>
                 </a:solidFill>
@@ -6241,13 +6232,18 @@
                 <a:ea typeface="Arial" pitchFamily="34" charset="-122"/>
                 <a:cs typeface="Arial" pitchFamily="34" charset="-120"/>
               </a:rPr>
-              <a:t>“One after-hours lockout is usually $150-$250. The plan pays for itself the first job you'd otherwise have missed.”  Then stop talking and let them react.</a:t>
+              <a:t>The two proof artifacts, the 30-second call recording and the lead-text screenshot, live in the sales folder. Attach the recording to touch 1 and the screenshot to touch 2.</a:t>
             </a:r>
             <a:endParaRPr lang="en-US" sz="1050" dirty="0"/>
           </a:p>
         </p:txBody>
       </p:sp>
     </p:spTree>
+    <p:extLst>
+      <p:ext uri="{BB962C8B-B14F-4D97-AF65-F5344CB8AC3E}">
+        <p14:creationId xmlns:p14="http://schemas.microsoft.com/office/powerpoint/2010/main" val="2185497993"/>
+      </p:ext>
+    </p:extLst>
   </p:cSld>
   <p:clrMapOvr>
     <a:masterClrMapping/>
@@ -6257,12 +6253,13 @@
 
 <file path=ppt/slides/slide7.xml><?xml version="1.0" encoding="utf-8"?>
 <p:sld xmlns:a="http://schemas.openxmlformats.org/drawingml/2006/main" xmlns:r="http://schemas.openxmlformats.org/officeDocument/2006/relationships" xmlns:p="http://schemas.openxmlformats.org/presentationml/2006/main">
-  <p:cSld name="Slide 7">
+  <p:cSld name="Slide 6">
     <p:bg>
       <p:bgPr>
         <a:solidFill>
           <a:srgbClr val="FFFFFF"/>
         </a:solidFill>
+        <a:effectLst/>
       </p:bgPr>
     </p:bg>
     <p:spTree>
@@ -6281,14 +6278,14 @@
       </p:grpSpPr>
       <p:pic>
         <p:nvPicPr>
-          <p:cNvPr id="2" name="Image 0" descr="preencoded.png">    </p:cNvPr>
+          <p:cNvPr id="2" name="Image 0" descr="preencoded.png"/>
           <p:cNvPicPr>
             <a:picLocks noChangeAspect="1"/>
           </p:cNvPicPr>
           <p:nvPr/>
         </p:nvPicPr>
         <p:blipFill>
-          <a:blip r:embed="rId1"/>
+          <a:blip r:embed="rId3"/>
           <a:stretch>
             <a:fillRect/>
           </a:stretch>
@@ -6324,7 +6321,7 @@
           <a:bodyPr wrap="square" lIns="0" tIns="0" rIns="0" bIns="0" rtlCol="0" anchor="ctr"/>
           <a:lstStyle/>
           <a:p>
-            <a:pPr indent="0" marL="0">
+            <a:pPr marL="0" indent="0">
               <a:buNone/>
             </a:pPr>
             <a:r>
@@ -6363,7 +6360,7 @@
           <a:bodyPr wrap="square" lIns="0" tIns="0" rIns="0" bIns="0" rtlCol="0" anchor="ctr"/>
           <a:lstStyle/>
           <a:p>
-            <a:pPr algn="r" indent="0" marL="0">
+            <a:pPr marL="0" indent="0" algn="r">
               <a:buNone/>
             </a:pPr>
             <a:r>
@@ -6375,7 +6372,7 @@
                 <a:ea typeface="Arial" pitchFamily="34" charset="-122"/>
                 <a:cs typeface="Arial" pitchFamily="34" charset="-120"/>
               </a:rPr>
-              <a:t>Stage 5 of 5</a:t>
+              <a:t>Stage 4 of 5</a:t>
             </a:r>
             <a:endParaRPr lang="en-US" sz="1000" dirty="0"/>
           </a:p>
@@ -6400,6 +6397,13 @@
           </a:solidFill>
           <a:ln/>
         </p:spPr>
+        <p:txBody>
+          <a:bodyPr/>
+          <a:lstStyle/>
+          <a:p>
+            <a:endParaRPr lang="en-US"/>
+          </a:p>
+        </p:txBody>
       </p:sp>
       <p:sp>
         <p:nvSpPr>
@@ -6422,7 +6426,7 @@
           <a:bodyPr wrap="square" lIns="0" tIns="0" rIns="0" bIns="0" rtlCol="0" anchor="ctr"/>
           <a:lstStyle/>
           <a:p>
-            <a:pPr indent="0" marL="0">
+            <a:pPr marL="0" indent="0">
               <a:buNone/>
             </a:pPr>
             <a:r>
@@ -6434,11 +6438,8 @@
                 <a:ea typeface="Arial" pitchFamily="34" charset="-122"/>
                 <a:cs typeface="Arial" pitchFamily="34" charset="-120"/>
               </a:rPr>
-              <a:t>05   </a:t>
-            </a:r>
-            <a:pPr indent="0" marL="0">
-              <a:buNone/>
-            </a:pPr>
+              <a:t>04   </a:t>
+            </a:r>
             <a:r>
               <a:rPr lang="en-US" sz="2600" b="1" dirty="0">
                 <a:solidFill>
@@ -6448,7 +6449,7 @@
                 <a:ea typeface="Arial" pitchFamily="34" charset="-122"/>
                 <a:cs typeface="Arial" pitchFamily="34" charset="-120"/>
               </a:rPr>
-              <a:t>Onboard</a:t>
+              <a:t>Close</a:t>
             </a:r>
             <a:endParaRPr lang="en-US" sz="2600" dirty="0"/>
           </a:p>
@@ -6480,6 +6481,13 @@
             <a:prstDash val="solid"/>
           </a:ln>
         </p:spPr>
+        <p:txBody>
+          <a:bodyPr/>
+          <a:lstStyle/>
+          <a:p>
+            <a:endParaRPr lang="en-US"/>
+          </a:p>
+        </p:txBody>
       </p:sp>
       <p:sp>
         <p:nvSpPr>
@@ -6502,7 +6510,7 @@
           <a:bodyPr wrap="square" lIns="0" tIns="0" rIns="0" bIns="0" rtlCol="0" anchor="ctr"/>
           <a:lstStyle/>
           <a:p>
-            <a:pPr indent="0" marL="0">
+            <a:pPr marL="0" indent="0">
               <a:buNone/>
             </a:pPr>
             <a:r>
@@ -6514,21 +6522,7 @@
                 <a:ea typeface="Arial" pitchFamily="34" charset="-122"/>
                 <a:cs typeface="Arial" pitchFamily="34" charset="-120"/>
               </a:rPr>
-              <a:t>GOAL   </a:t>
-            </a:r>
-            <a:pPr indent="0" marL="0">
-              <a:buNone/>
-            </a:pPr>
-            <a:r>
-              <a:rPr lang="en-US" sz="1200" dirty="0">
-                <a:solidFill>
-                  <a:srgbClr val="0C1726"/>
-                </a:solidFill>
-                <a:latin typeface="Arial" pitchFamily="34" charset="0"/>
-                <a:ea typeface="Arial" pitchFamily="34" charset="-122"/>
-                <a:cs typeface="Arial" pitchFamily="34" charset="-120"/>
-              </a:rPr>
-              <a:t>Get them live and getting leads the same day.</a:t>
+              <a:t>Turn trial data into a paying customer.</a:t>
             </a:r>
             <a:endParaRPr lang="en-US" sz="1000" dirty="0"/>
           </a:p>
@@ -6555,11 +6549,11 @@
           <a:bodyPr wrap="square" lIns="0" tIns="0" rIns="0" bIns="0" rtlCol="0" anchor="ctr"/>
           <a:lstStyle/>
           <a:p>
-            <a:pPr indent="0" marL="0">
+            <a:pPr marL="0" indent="0">
               <a:buNone/>
             </a:pPr>
             <a:r>
-              <a:rPr lang="en-US" sz="1100" b="1" spc="100" kern="0" dirty="0">
+              <a:rPr lang="en-US" sz="1100" b="1" kern="0" spc="100" dirty="0">
                 <a:solidFill>
                   <a:srgbClr val="0C1726"/>
                 </a:solidFill>
@@ -6600,7 +6594,7 @@
               </a:spcAft>
               <a:buSzPct val="100000"/>
               <a:buFont typeface="+mj-lt"/>
-              <a:buAutoNum type="arabicPeriod" startAt="1"/>
+              <a:buAutoNum type="arabicPeriod"/>
             </a:pPr>
             <a:r>
               <a:rPr lang="en-US" sz="1050" dirty="0">
@@ -6611,7 +6605,7 @@
                 <a:ea typeface="Arial" pitchFamily="34" charset="-122"/>
                 <a:cs typeface="Arial" pitchFamily="34" charset="-120"/>
               </a:rPr>
-              <a:t>Collect: business and agent name, inbound number, dispatch phone, hours.</a:t>
+              <a:t>Review the trial together: how many calls the agent caught, at what hours, with the actual lead texts as evidence.</a:t>
             </a:r>
             <a:endParaRPr lang="en-US" sz="1050" dirty="0"/>
           </a:p>
@@ -6622,7 +6616,7 @@
               </a:spcAft>
               <a:buSzPct val="100000"/>
               <a:buFont typeface="+mj-lt"/>
-              <a:buAutoNum type="arabicPeriod" startAt="1"/>
+              <a:buAutoNum type="arabicPeriod"/>
             </a:pPr>
             <a:r>
               <a:rPr lang="en-US" sz="1050" dirty="0">
@@ -6633,7 +6627,7 @@
                 <a:ea typeface="Arial" pitchFamily="34" charset="-122"/>
                 <a:cs typeface="Arial" pitchFamily="34" charset="-120"/>
               </a:rPr>
-              <a:t>Create the client in the admin tool (it validates the number).</a:t>
+              <a:t>Do the math out loud: what one of those jobs is worth against the monthly price.</a:t>
             </a:r>
             <a:endParaRPr lang="en-US" sz="1050" dirty="0"/>
           </a:p>
@@ -6644,7 +6638,7 @@
               </a:spcAft>
               <a:buSzPct val="100000"/>
               <a:buFont typeface="+mj-lt"/>
-              <a:buAutoNum type="arabicPeriod" startAt="1"/>
+              <a:buAutoNum type="arabicPeriod"/>
             </a:pPr>
             <a:r>
               <a:rPr lang="en-US" sz="1050" dirty="0">
@@ -6655,7 +6649,7 @@
                 <a:ea typeface="Arial" pitchFamily="34" charset="-122"/>
                 <a:cs typeface="Arial" pitchFamily="34" charset="-120"/>
               </a:rPr>
-              <a:t>Hit 'Send test SMS' to confirm the dispatch phone receives texts.</a:t>
+              <a:t>Ask for it plainly: “Want to keep it on?”</a:t>
             </a:r>
             <a:endParaRPr lang="en-US" sz="1050" dirty="0"/>
           </a:p>
@@ -6666,7 +6660,7 @@
               </a:spcAft>
               <a:buSzPct val="100000"/>
               <a:buFont typeface="+mj-lt"/>
-              <a:buAutoNum type="arabicPeriod" startAt="1"/>
+              <a:buAutoNum type="arabicPeriod"/>
             </a:pPr>
             <a:r>
               <a:rPr lang="en-US" sz="1050" dirty="0">
@@ -6677,7 +6671,7 @@
                 <a:ea typeface="Arial" pitchFamily="34" charset="-122"/>
                 <a:cs typeface="Arial" pitchFamily="34" charset="-120"/>
               </a:rPr>
-              <a:t>Have them forward busy/no-answer calls to the Dispango number.</a:t>
+              <a:t>Send the agreement and take payment on the same call.</a:t>
             </a:r>
             <a:endParaRPr lang="en-US" sz="1050" dirty="0"/>
           </a:p>
@@ -6688,7 +6682,7 @@
               </a:spcAft>
               <a:buSzPct val="100000"/>
               <a:buFont typeface="+mj-lt"/>
-              <a:buAutoNum type="arabicPeriod" startAt="1"/>
+              <a:buAutoNum type="arabicPeriod"/>
             </a:pPr>
             <a:r>
               <a:rPr lang="en-US" sz="1050" dirty="0">
@@ -6699,29 +6693,7 @@
                 <a:ea typeface="Arial" pitchFamily="34" charset="-122"/>
                 <a:cs typeface="Arial" pitchFamily="34" charset="-120"/>
               </a:rPr>
-              <a:t>Place a test call; confirm the lead text arrives.</a:t>
-            </a:r>
-            <a:endParaRPr lang="en-US" sz="1050" dirty="0"/>
-          </a:p>
-          <a:p>
-            <a:pPr marL="342900" indent="-342900">
-              <a:spcAft>
-                <a:spcPts val="900"/>
-              </a:spcAft>
-              <a:buSzPct val="100000"/>
-              <a:buFont typeface="+mj-lt"/>
-              <a:buAutoNum type="arabicPeriod" startAt="1"/>
-            </a:pPr>
-            <a:r>
-              <a:rPr lang="en-US" sz="1050" dirty="0">
-                <a:solidFill>
-                  <a:srgbClr val="44505F"/>
-                </a:solidFill>
-                <a:latin typeface="Arial" pitchFamily="34" charset="0"/>
-                <a:ea typeface="Arial" pitchFamily="34" charset="-122"/>
-                <a:cs typeface="Arial" pitchFamily="34" charset="-120"/>
-              </a:rPr>
-              <a:t>Confirm go-live; book a check-in for day 3-5.</a:t>
+              <a:t>If the trial caught nothing, be honest: the product isn’t a fit right now. Part on good terms and leave the door open. That protects our time and our reputation.</a:t>
             </a:r>
             <a:endParaRPr lang="en-US" sz="1050" dirty="0"/>
           </a:p>
@@ -6748,11 +6720,11 @@
           <a:bodyPr wrap="square" lIns="0" tIns="0" rIns="0" bIns="0" rtlCol="0" anchor="ctr"/>
           <a:lstStyle/>
           <a:p>
-            <a:pPr indent="0" marL="0">
+            <a:pPr marL="0" indent="0">
               <a:buNone/>
             </a:pPr>
             <a:r>
-              <a:rPr lang="en-US" sz="1100" b="1" spc="100" kern="0" dirty="0">
+              <a:rPr lang="en-US" sz="1100" b="1" kern="0" spc="100" dirty="0">
                 <a:solidFill>
                   <a:srgbClr val="0C1726"/>
                 </a:solidFill>
@@ -6803,7 +6775,7 @@
                 <a:ea typeface="Arial" pitchFamily="34" charset="-122"/>
                 <a:cs typeface="Arial" pitchFamily="34" charset="-120"/>
               </a:rPr>
-              <a:t>Use the admin UI — never raw SQL (it broke prod twice).</a:t>
+              <a:t>The trial did the selling, so the close is arithmetic, not persuasion.</a:t>
             </a:r>
             <a:endParaRPr lang="en-US" sz="1050" dirty="0"/>
           </a:p>
@@ -6824,7 +6796,7 @@
                 <a:ea typeface="Arial" pitchFamily="34" charset="-122"/>
                 <a:cs typeface="Arial" pitchFamily="34" charset="-120"/>
               </a:rPr>
-              <a:t>Phones in E.164 (+1…); business/agent name feed the greeting.</a:t>
+              <a:t>Don’t discount on reflex; sell the cost of the missed job.</a:t>
             </a:r>
             <a:endParaRPr lang="en-US" sz="1050" dirty="0"/>
           </a:p>
@@ -6845,17 +6817,17 @@
                 <a:ea typeface="Arial" pitchFamily="34" charset="-122"/>
                 <a:cs typeface="Arial" pitchFamily="34" charset="-120"/>
               </a:rPr>
-              <a:t>Their number doesn't change — only call forwarding does.</a:t>
+              <a:t>A customer who gets no value churns anyway. Disqualifying is a win.</a:t>
             </a:r>
             <a:endParaRPr lang="en-US" sz="1050" dirty="0"/>
           </a:p>
           <a:p>
-            <a:pPr marL="342900" indent="-342900">
+            <a:pPr marL="0" indent="0">
               <a:spcAft>
                 <a:spcPts val="900"/>
               </a:spcAft>
               <a:buSzPct val="100000"/>
-              <a:buChar char="•"/>
+              <a:buNone/>
             </a:pPr>
             <a:r>
               <a:rPr lang="en-US" sz="1050" dirty="0">
@@ -6866,7 +6838,7 @@
                 <a:ea typeface="Arial" pitchFamily="34" charset="-122"/>
                 <a:cs typeface="Arial" pitchFamily="34" charset="-120"/>
               </a:rPr>
-              <a:t>Verify a real test call before you call it done.</a:t>
+              <a:t>Stage done = agreement signed and payment active.</a:t>
             </a:r>
             <a:endParaRPr lang="en-US" sz="1050" dirty="0"/>
           </a:p>
@@ -6893,17 +6865,24 @@
           </a:solidFill>
           <a:ln/>
         </p:spPr>
+        <p:txBody>
+          <a:bodyPr/>
+          <a:lstStyle/>
+          <a:p>
+            <a:endParaRPr lang="en-US"/>
+          </a:p>
+        </p:txBody>
       </p:sp>
       <p:pic>
         <p:nvPicPr>
-          <p:cNvPr id="14" name="Image 1" descr="preencoded.png">    </p:cNvPr>
+          <p:cNvPr id="14" name="Image 1" descr="preencoded.png"/>
           <p:cNvPicPr>
             <a:picLocks noChangeAspect="1"/>
           </p:cNvPicPr>
           <p:nvPr/>
         </p:nvPicPr>
         <p:blipFill>
-          <a:blip r:embed="rId2"/>
+          <a:blip r:embed="rId3"/>
           <a:stretch>
             <a:fillRect/>
           </a:stretch>
@@ -6939,7 +6918,7 @@
           <a:bodyPr wrap="square" lIns="0" tIns="0" rIns="0" bIns="0" rtlCol="0" anchor="ctr"/>
           <a:lstStyle/>
           <a:p>
-            <a:pPr indent="0" marL="0">
+            <a:pPr marL="0" indent="0">
               <a:buNone/>
             </a:pPr>
             <a:r>
@@ -6951,7 +6930,7 @@
                 <a:ea typeface="Arial" pitchFamily="34" charset="-122"/>
                 <a:cs typeface="Arial" pitchFamily="34" charset="-120"/>
               </a:rPr>
-              <a:t>Tool</a:t>
+              <a:t>Value anchor</a:t>
             </a:r>
             <a:endParaRPr lang="en-US" sz="1100" dirty="0"/>
           </a:p>
@@ -6978,14 +6957,14 @@
           <a:bodyPr wrap="square" lIns="0" tIns="0" rIns="0" bIns="0" rtlCol="0" anchor="ctr"/>
           <a:lstStyle/>
           <a:p>
-            <a:pPr indent="0" marL="0">
+            <a:pPr marL="0" indent="0">
               <a:lnSpc>
                 <a:spcPct val="120000"/>
               </a:lnSpc>
               <a:buNone/>
             </a:pPr>
             <a:r>
-              <a:rPr lang="en-US" sz="1050" dirty="0">
+              <a:rPr lang="en-US" sz="1050" i="1" dirty="0">
                 <a:solidFill>
                   <a:srgbClr val="FFFFFF"/>
                 </a:solidFill>
@@ -6993,13 +6972,18 @@
                 <a:ea typeface="Arial" pitchFamily="34" charset="-122"/>
                 <a:cs typeface="Arial" pitchFamily="34" charset="-120"/>
               </a:rPr>
-              <a:t>The admin tool (admin-ui page → admin API): create the client, send a test SMS, toggle active. Onboarding done = a correct clients row plus call forwarding set on their line.</a:t>
+              <a:t>Review what the trial actually caught, then price against one missed job. Stop talking and let them react.</a:t>
             </a:r>
             <a:endParaRPr lang="en-US" sz="1050" dirty="0"/>
           </a:p>
         </p:txBody>
       </p:sp>
     </p:spTree>
+    <p:extLst>
+      <p:ext uri="{BB962C8B-B14F-4D97-AF65-F5344CB8AC3E}">
+        <p14:creationId xmlns:p14="http://schemas.microsoft.com/office/powerpoint/2010/main" val="3837671093"/>
+      </p:ext>
+    </p:extLst>
   </p:cSld>
   <p:clrMapOvr>
     <a:masterClrMapping/>
@@ -7009,12 +6993,13 @@
 
 <file path=ppt/slides/slide8.xml><?xml version="1.0" encoding="utf-8"?>
 <p:sld xmlns:a="http://schemas.openxmlformats.org/drawingml/2006/main" xmlns:r="http://schemas.openxmlformats.org/officeDocument/2006/relationships" xmlns:p="http://schemas.openxmlformats.org/presentationml/2006/main">
-  <p:cSld name="Slide 8">
+  <p:cSld name="Slide 7">
     <p:bg>
       <p:bgPr>
         <a:solidFill>
           <a:srgbClr val="FFFFFF"/>
         </a:solidFill>
+        <a:effectLst/>
       </p:bgPr>
     </p:bg>
     <p:spTree>
@@ -7033,14 +7018,14 @@
       </p:grpSpPr>
       <p:pic>
         <p:nvPicPr>
-          <p:cNvPr id="2" name="Image 0" descr="preencoded.png">    </p:cNvPr>
+          <p:cNvPr id="2" name="Image 0" descr="preencoded.png"/>
           <p:cNvPicPr>
             <a:picLocks noChangeAspect="1"/>
           </p:cNvPicPr>
           <p:nvPr/>
         </p:nvPicPr>
         <p:blipFill>
-          <a:blip r:embed="rId1"/>
+          <a:blip r:embed="rId3"/>
           <a:stretch>
             <a:fillRect/>
           </a:stretch>
@@ -7076,7 +7061,7 @@
           <a:bodyPr wrap="square" lIns="0" tIns="0" rIns="0" bIns="0" rtlCol="0" anchor="ctr"/>
           <a:lstStyle/>
           <a:p>
-            <a:pPr indent="0" marL="0">
+            <a:pPr marL="0" indent="0">
               <a:buNone/>
             </a:pPr>
             <a:r>
@@ -7115,7 +7100,7 @@
           <a:bodyPr wrap="square" lIns="0" tIns="0" rIns="0" bIns="0" rtlCol="0" anchor="ctr"/>
           <a:lstStyle/>
           <a:p>
-            <a:pPr algn="r" indent="0" marL="0">
+            <a:pPr marL="0" indent="0" algn="r">
               <a:buNone/>
             </a:pPr>
             <a:r>
@@ -7127,7 +7112,7 @@
                 <a:ea typeface="Arial" pitchFamily="34" charset="-122"/>
                 <a:cs typeface="Arial" pitchFamily="34" charset="-120"/>
               </a:rPr>
-              <a:t>Cadence &amp; metrics</a:t>
+              <a:t>Stage 5 of 5</a:t>
             </a:r>
             <a:endParaRPr lang="en-US" sz="1000" dirty="0"/>
           </a:p>
@@ -7152,6 +7137,13 @@
           </a:solidFill>
           <a:ln/>
         </p:spPr>
+        <p:txBody>
+          <a:bodyPr/>
+          <a:lstStyle/>
+          <a:p>
+            <a:endParaRPr lang="en-US"/>
+          </a:p>
+        </p:txBody>
       </p:sp>
       <p:sp>
         <p:nvSpPr>
@@ -7174,19 +7166,30 @@
           <a:bodyPr wrap="square" lIns="0" tIns="0" rIns="0" bIns="0" rtlCol="0" anchor="ctr"/>
           <a:lstStyle/>
           <a:p>
-            <a:pPr indent="0" marL="0">
+            <a:pPr marL="0" indent="0">
               <a:buNone/>
             </a:pPr>
             <a:r>
               <a:rPr lang="en-US" sz="2600" b="1" dirty="0">
                 <a:solidFill>
+                  <a:srgbClr val="2F6BED"/>
+                </a:solidFill>
+                <a:latin typeface="Arial" pitchFamily="34" charset="0"/>
+                <a:ea typeface="Arial" pitchFamily="34" charset="-122"/>
+                <a:cs typeface="Arial" pitchFamily="34" charset="-120"/>
+              </a:rPr>
+              <a:t>05   </a:t>
+            </a:r>
+            <a:r>
+              <a:rPr lang="en-US" sz="2600" b="1" dirty="0">
+                <a:solidFill>
                   <a:srgbClr val="0C1726"/>
                 </a:solidFill>
                 <a:latin typeface="Arial" pitchFamily="34" charset="0"/>
                 <a:ea typeface="Arial" pitchFamily="34" charset="-122"/>
                 <a:cs typeface="Arial" pitchFamily="34" charset="-120"/>
               </a:rPr>
-              <a:t>Run it on a rhythm</a:t>
+              <a:t>Onboard</a:t>
             </a:r>
             <a:endParaRPr lang="en-US" sz="2600" dirty="0"/>
           </a:p>
@@ -7200,12 +7203,12 @@
         </p:nvSpPr>
         <p:spPr>
           <a:xfrm>
-            <a:off x="548640" y="1783080"/>
-            <a:ext cx="3246120" cy="3108960"/>
+            <a:off x="548640" y="1737360"/>
+            <a:ext cx="6675120" cy="731520"/>
           </a:xfrm>
           <a:prstGeom prst="roundRect">
             <a:avLst>
-              <a:gd name="adj" fmla="val 3529"/>
+              <a:gd name="adj" fmla="val 12500"/>
             </a:avLst>
           </a:prstGeom>
           <a:solidFill>
@@ -7218,6 +7221,13 @@
             <a:prstDash val="solid"/>
           </a:ln>
         </p:spPr>
+        <p:txBody>
+          <a:bodyPr/>
+          <a:lstStyle/>
+          <a:p>
+            <a:endParaRPr lang="en-US"/>
+          </a:p>
+        </p:txBody>
       </p:sp>
       <p:sp>
         <p:nvSpPr>
@@ -7227,8 +7237,8 @@
         </p:nvSpPr>
         <p:spPr>
           <a:xfrm>
-            <a:off x="822960" y="2011680"/>
-            <a:ext cx="2743200" cy="365760"/>
+            <a:off x="804672" y="1737360"/>
+            <a:ext cx="6163056" cy="731520"/>
           </a:xfrm>
           <a:prstGeom prst="rect">
             <a:avLst/>
@@ -7240,11 +7250,50 @@
           <a:bodyPr wrap="square" lIns="0" tIns="0" rIns="0" bIns="0" rtlCol="0" anchor="ctr"/>
           <a:lstStyle/>
           <a:p>
-            <a:pPr indent="0" marL="0">
+            <a:pPr marL="0" indent="0">
               <a:buNone/>
             </a:pPr>
             <a:r>
-              <a:rPr lang="en-US" sz="1400" b="1" dirty="0">
+              <a:rPr lang="en-US" sz="1000" b="1" dirty="0">
+                <a:solidFill>
+                  <a:srgbClr val="2F6BED"/>
+                </a:solidFill>
+                <a:latin typeface="Arial" pitchFamily="34" charset="0"/>
+                <a:ea typeface="Arial" pitchFamily="34" charset="-122"/>
+                <a:cs typeface="Arial" pitchFamily="34" charset="-120"/>
+              </a:rPr>
+              <a:t>Their system is live, their concerns are answered, and they know how to reach us.</a:t>
+            </a:r>
+            <a:endParaRPr lang="en-US" sz="1000" dirty="0"/>
+          </a:p>
+        </p:txBody>
+      </p:sp>
+      <p:sp>
+        <p:nvSpPr>
+          <p:cNvPr id="9" name="Text 6"/>
+          <p:cNvSpPr/>
+          <p:nvPr/>
+        </p:nvSpPr>
+        <p:spPr>
+          <a:xfrm>
+            <a:off x="548640" y="2743200"/>
+            <a:ext cx="3200400" cy="274320"/>
+          </a:xfrm>
+          <a:prstGeom prst="rect">
+            <a:avLst/>
+          </a:prstGeom>
+          <a:noFill/>
+          <a:ln/>
+        </p:spPr>
+        <p:txBody>
+          <a:bodyPr wrap="square" lIns="0" tIns="0" rIns="0" bIns="0" rtlCol="0" anchor="ctr"/>
+          <a:lstStyle/>
+          <a:p>
+            <a:pPr marL="0" indent="0">
+              <a:buNone/>
+            </a:pPr>
+            <a:r>
+              <a:rPr lang="en-US" sz="1100" b="1" kern="0" spc="100" dirty="0">
                 <a:solidFill>
                   <a:srgbClr val="0C1726"/>
                 </a:solidFill>
@@ -7252,22 +7301,22 @@
                 <a:ea typeface="Arial" pitchFamily="34" charset="-122"/>
                 <a:cs typeface="Arial" pitchFamily="34" charset="-120"/>
               </a:rPr>
-              <a:t>Weekly rhythm</a:t>
-            </a:r>
-            <a:endParaRPr lang="en-US" sz="1400" dirty="0"/>
-          </a:p>
-        </p:txBody>
-      </p:sp>
-      <p:sp>
-        <p:nvSpPr>
-          <p:cNvPr id="9" name="Text 6"/>
-          <p:cNvSpPr/>
-          <p:nvPr/>
-        </p:nvSpPr>
-        <p:spPr>
-          <a:xfrm>
-            <a:off x="822960" y="2468880"/>
-            <a:ext cx="2697480" cy="2286000"/>
+              <a:t>DO THIS</a:t>
+            </a:r>
+            <a:endParaRPr lang="en-US" sz="1100" dirty="0"/>
+          </a:p>
+        </p:txBody>
+      </p:sp>
+      <p:sp>
+        <p:nvSpPr>
+          <p:cNvPr id="10" name="Text 7"/>
+          <p:cNvSpPr/>
+          <p:nvPr/>
+        </p:nvSpPr>
+        <p:spPr>
+          <a:xfrm>
+            <a:off x="548640" y="3127248"/>
+            <a:ext cx="3200400" cy="4023360"/>
           </a:xfrm>
           <a:prstGeom prst="rect">
             <a:avLst/>
@@ -7281,13 +7330,206 @@
           <a:p>
             <a:pPr marL="342900" indent="-342900">
               <a:spcAft>
-                <a:spcPts val="1000"/>
+                <a:spcPts val="900"/>
+              </a:spcAft>
+              <a:buSzPct val="100000"/>
+              <a:buFont typeface="+mj-lt"/>
+              <a:buAutoNum type="arabicPeriod"/>
+            </a:pPr>
+            <a:r>
+              <a:rPr lang="en-US" sz="1050" dirty="0">
+                <a:solidFill>
+                  <a:srgbClr val="44505F"/>
+                </a:solidFill>
+                <a:latin typeface="Arial" pitchFamily="34" charset="0"/>
+                <a:ea typeface="Arial" pitchFamily="34" charset="-122"/>
+                <a:cs typeface="Arial" pitchFamily="34" charset="-120"/>
+              </a:rPr>
+              <a:t>Confirm the production setup: the business and agent names, inbound number, dispatch phone, and hours, all entered in the admin tool.</a:t>
+            </a:r>
+            <a:endParaRPr lang="en-US" sz="1050" dirty="0"/>
+          </a:p>
+          <a:p>
+            <a:pPr marL="342900" indent="-342900">
+              <a:spcAft>
+                <a:spcPts val="900"/>
+              </a:spcAft>
+              <a:buSzPct val="100000"/>
+              <a:buFont typeface="+mj-lt"/>
+              <a:buAutoNum type="arabicPeriod"/>
+            </a:pPr>
+            <a:r>
+              <a:rPr lang="en-US" sz="1050" dirty="0">
+                <a:solidFill>
+                  <a:srgbClr val="44505F"/>
+                </a:solidFill>
+                <a:latin typeface="Arial" pitchFamily="34" charset="0"/>
+                <a:ea typeface="Arial" pitchFamily="34" charset="-122"/>
+                <a:cs typeface="Arial" pitchFamily="34" charset="-120"/>
+              </a:rPr>
+              <a:t>Confirm call forwarding is set on their line, then place a real test call and confirm the lead text arrives.</a:t>
+            </a:r>
+            <a:endParaRPr lang="en-US" sz="1050" dirty="0"/>
+          </a:p>
+          <a:p>
+            <a:pPr marL="342900" indent="-342900">
+              <a:spcAft>
+                <a:spcPts val="900"/>
+              </a:spcAft>
+              <a:buSzPct val="100000"/>
+              <a:buFont typeface="+mj-lt"/>
+              <a:buAutoNum type="arabicPeriod"/>
+            </a:pPr>
+            <a:r>
+              <a:rPr lang="en-US" sz="1050" dirty="0">
+                <a:solidFill>
+                  <a:srgbClr val="44505F"/>
+                </a:solidFill>
+                <a:latin typeface="Arial" pitchFamily="34" charset="0"/>
+                <a:ea typeface="Arial" pitchFamily="34" charset="-122"/>
+                <a:cs typeface="Arial" pitchFamily="34" charset="-120"/>
+              </a:rPr>
+              <a:t>Walk them through their part: what the agent does, what they do when a lead text arrives, and how to reach us when something feels off.</a:t>
+            </a:r>
+            <a:endParaRPr lang="en-US" sz="1050" dirty="0"/>
+          </a:p>
+          <a:p>
+            <a:pPr marL="342900" indent="-342900">
+              <a:spcAft>
+                <a:spcPts val="900"/>
+              </a:spcAft>
+              <a:buSzPct val="100000"/>
+              <a:buFont typeface="+mj-lt"/>
+              <a:buAutoNum type="arabicPeriod"/>
+            </a:pPr>
+            <a:r>
+              <a:rPr lang="en-US" sz="1050" dirty="0">
+                <a:solidFill>
+                  <a:srgbClr val="44505F"/>
+                </a:solidFill>
+                <a:latin typeface="Arial" pitchFamily="34" charset="0"/>
+                <a:ea typeface="Arial" pitchFamily="34" charset="-122"/>
+                <a:cs typeface="Arial" pitchFamily="34" charset="-120"/>
+              </a:rPr>
+              <a:t>Address every open concern before ending the call.</a:t>
+            </a:r>
+            <a:endParaRPr lang="en-US" sz="1050" dirty="0"/>
+          </a:p>
+          <a:p>
+            <a:pPr marL="342900" indent="-342900">
+              <a:spcAft>
+                <a:spcPts val="900"/>
+              </a:spcAft>
+              <a:buSzPct val="100000"/>
+              <a:buFont typeface="+mj-lt"/>
+              <a:buAutoNum type="arabicPeriod"/>
+            </a:pPr>
+            <a:r>
+              <a:rPr lang="en-US" sz="1050" dirty="0">
+                <a:solidFill>
+                  <a:srgbClr val="44505F"/>
+                </a:solidFill>
+                <a:latin typeface="Arial" pitchFamily="34" charset="0"/>
+                <a:ea typeface="Arial" pitchFamily="34" charset="-122"/>
+                <a:cs typeface="Arial" pitchFamily="34" charset="-120"/>
+              </a:rPr>
+              <a:t>Book a check-in for day 3-5.</a:t>
+            </a:r>
+            <a:endParaRPr lang="en-US" sz="1050" dirty="0"/>
+          </a:p>
+          <a:p>
+            <a:pPr marL="342900" indent="-342900">
+              <a:spcAft>
+                <a:spcPts val="900"/>
+              </a:spcAft>
+              <a:buSzPct val="100000"/>
+              <a:buFont typeface="+mj-lt"/>
+              <a:buAutoNum type="arabicPeriod"/>
+            </a:pPr>
+            <a:r>
+              <a:rPr lang="en-US" sz="1050" dirty="0">
+                <a:solidFill>
+                  <a:srgbClr val="44505F"/>
+                </a:solidFill>
+                <a:latin typeface="Arial" pitchFamily="34" charset="0"/>
+                <a:ea typeface="Arial" pitchFamily="34" charset="-122"/>
+                <a:cs typeface="Arial" pitchFamily="34" charset="-120"/>
+              </a:rPr>
+              <a:t>At the check-in, confirm leads are landing and make the referral ask: “Who else do you know running a shop like yours?”</a:t>
+            </a:r>
+            <a:endParaRPr lang="en-US" sz="1050" dirty="0"/>
+          </a:p>
+        </p:txBody>
+      </p:sp>
+      <p:sp>
+        <p:nvSpPr>
+          <p:cNvPr id="11" name="Text 8"/>
+          <p:cNvSpPr/>
+          <p:nvPr/>
+        </p:nvSpPr>
+        <p:spPr>
+          <a:xfrm>
+            <a:off x="4114800" y="2743200"/>
+            <a:ext cx="3108960" cy="274320"/>
+          </a:xfrm>
+          <a:prstGeom prst="rect">
+            <a:avLst/>
+          </a:prstGeom>
+          <a:noFill/>
+          <a:ln/>
+        </p:spPr>
+        <p:txBody>
+          <a:bodyPr wrap="square" lIns="0" tIns="0" rIns="0" bIns="0" rtlCol="0" anchor="ctr"/>
+          <a:lstStyle/>
+          <a:p>
+            <a:pPr marL="0" indent="0">
+              <a:buNone/>
+            </a:pPr>
+            <a:r>
+              <a:rPr lang="en-US" sz="1100" b="1" kern="0" spc="100" dirty="0">
+                <a:solidFill>
+                  <a:srgbClr val="0C1726"/>
+                </a:solidFill>
+                <a:latin typeface="Arial" pitchFamily="34" charset="0"/>
+                <a:ea typeface="Arial" pitchFamily="34" charset="-122"/>
+                <a:cs typeface="Arial" pitchFamily="34" charset="-120"/>
+              </a:rPr>
+              <a:t>TIPS</a:t>
+            </a:r>
+            <a:endParaRPr lang="en-US" sz="1100" dirty="0"/>
+          </a:p>
+        </p:txBody>
+      </p:sp>
+      <p:sp>
+        <p:nvSpPr>
+          <p:cNvPr id="12" name="Text 9"/>
+          <p:cNvSpPr/>
+          <p:nvPr/>
+        </p:nvSpPr>
+        <p:spPr>
+          <a:xfrm>
+            <a:off x="4114800" y="3127248"/>
+            <a:ext cx="3108960" cy="4023360"/>
+          </a:xfrm>
+          <a:prstGeom prst="rect">
+            <a:avLst/>
+          </a:prstGeom>
+          <a:noFill/>
+          <a:ln/>
+        </p:spPr>
+        <p:txBody>
+          <a:bodyPr wrap="square" lIns="0" tIns="0" rIns="0" bIns="0" rtlCol="0" anchor="t"/>
+          <a:lstStyle/>
+          <a:p>
+            <a:pPr marL="342900" indent="-342900">
+              <a:spcAft>
+                <a:spcPts val="900"/>
               </a:spcAft>
               <a:buSzPct val="100000"/>
               <a:buChar char="•"/>
             </a:pPr>
             <a:r>
-              <a:rPr lang="en-US" sz="1100" dirty="0">
+              <a:rPr lang="en-US" sz="1050" dirty="0">
                 <a:solidFill>
                   <a:srgbClr val="44505F"/>
                 </a:solidFill>
@@ -7295,20 +7537,20 @@
                 <a:ea typeface="Arial" pitchFamily="34" charset="-122"/>
                 <a:cs typeface="Arial" pitchFamily="34" charset="-120"/>
               </a:rPr>
-              <a:t>Mon — build/refresh the prospect list</a:t>
-            </a:r>
-            <a:endParaRPr lang="en-US" sz="1100" dirty="0"/>
+              <a:t>Use the admin UI for all changes.</a:t>
+            </a:r>
+            <a:endParaRPr lang="en-US" sz="1050" dirty="0"/>
           </a:p>
           <a:p>
             <a:pPr marL="342900" indent="-342900">
               <a:spcAft>
-                <a:spcPts val="1000"/>
+                <a:spcPts val="900"/>
               </a:spcAft>
               <a:buSzPct val="100000"/>
               <a:buChar char="•"/>
             </a:pPr>
             <a:r>
-              <a:rPr lang="en-US" sz="1100" dirty="0">
+              <a:rPr lang="en-US" sz="1050" dirty="0">
                 <a:solidFill>
                   <a:srgbClr val="44505F"/>
                 </a:solidFill>
@@ -7316,20 +7558,20 @@
                 <a:ea typeface="Arial" pitchFamily="34" charset="-122"/>
                 <a:cs typeface="Arial" pitchFamily="34" charset="-120"/>
               </a:rPr>
-              <a:t>Tue-Thu — cold-call blocks (aim for volume)</a:t>
-            </a:r>
-            <a:endParaRPr lang="en-US" sz="1100" dirty="0"/>
+              <a:t>Phone numbers in E.164 format (+1…).</a:t>
+            </a:r>
+            <a:endParaRPr lang="en-US" sz="1050" dirty="0"/>
           </a:p>
           <a:p>
             <a:pPr marL="342900" indent="-342900">
               <a:spcAft>
-                <a:spcPts val="1000"/>
+                <a:spcPts val="900"/>
               </a:spcAft>
               <a:buSzPct val="100000"/>
               <a:buChar char="•"/>
             </a:pPr>
             <a:r>
-              <a:rPr lang="en-US" sz="1100" dirty="0">
+              <a:rPr lang="en-US" sz="1050" dirty="0">
                 <a:solidFill>
                   <a:srgbClr val="44505F"/>
                 </a:solidFill>
@@ -7337,20 +7579,20 @@
                 <a:ea typeface="Arial" pitchFamily="34" charset="-122"/>
                 <a:cs typeface="Arial" pitchFamily="34" charset="-120"/>
               </a:rPr>
-              <a:t>Daily — work the follow-up queue</a:t>
-            </a:r>
-            <a:endParaRPr lang="en-US" sz="1100" dirty="0"/>
+              <a:t>Their public number never changes; only forwarding does.</a:t>
+            </a:r>
+            <a:endParaRPr lang="en-US" sz="1050" dirty="0"/>
           </a:p>
           <a:p>
             <a:pPr marL="342900" indent="-342900">
               <a:spcAft>
-                <a:spcPts val="1000"/>
+                <a:spcPts val="900"/>
               </a:spcAft>
               <a:buSzPct val="100000"/>
               <a:buChar char="•"/>
             </a:pPr>
             <a:r>
-              <a:rPr lang="en-US" sz="1100" dirty="0">
+              <a:rPr lang="en-US" sz="1050" dirty="0">
                 <a:solidFill>
                   <a:srgbClr val="44505F"/>
                 </a:solidFill>
@@ -7358,20 +7600,20 @@
                 <a:ea typeface="Arial" pitchFamily="34" charset="-122"/>
                 <a:cs typeface="Arial" pitchFamily="34" charset="-120"/>
               </a:rPr>
-              <a:t>Wed-Fri — run booked demos</a:t>
-            </a:r>
-            <a:endParaRPr lang="en-US" sz="1100" dirty="0"/>
-          </a:p>
-          <a:p>
-            <a:pPr marL="342900" indent="-342900">
+              <a:t>Onboarding isn’t done until a real test call has worked end to end.</a:t>
+            </a:r>
+            <a:endParaRPr lang="en-US" sz="1050" dirty="0"/>
+          </a:p>
+          <a:p>
+            <a:pPr marL="0" indent="0">
               <a:spcAft>
-                <a:spcPts val="1000"/>
+                <a:spcPts val="900"/>
               </a:spcAft>
               <a:buSzPct val="100000"/>
-              <a:buChar char="•"/>
-            </a:pPr>
-            <a:r>
-              <a:rPr lang="en-US" sz="1100" dirty="0">
+              <a:buNone/>
+            </a:pPr>
+            <a:r>
+              <a:rPr lang="en-US" sz="1050" dirty="0">
                 <a:solidFill>
                   <a:srgbClr val="44505F"/>
                 </a:solidFill>
@@ -7379,7 +7621,99 @@
                 <a:ea typeface="Arial" pitchFamily="34" charset="-122"/>
                 <a:cs typeface="Arial" pitchFamily="34" charset="-120"/>
               </a:rPr>
-              <a:t>Fri — onboard closes, review the funnel</a:t>
+              <a:t>Stage done = live system verified with a test call, client knows their part and how to reach us, day 3-5 check-in booked.</a:t>
+            </a:r>
+            <a:endParaRPr lang="en-US" sz="1050" dirty="0"/>
+          </a:p>
+        </p:txBody>
+      </p:sp>
+      <p:sp>
+        <p:nvSpPr>
+          <p:cNvPr id="13" name="Shape 10"/>
+          <p:cNvSpPr/>
+          <p:nvPr/>
+        </p:nvSpPr>
+        <p:spPr>
+          <a:xfrm>
+            <a:off x="548640" y="7955280"/>
+            <a:ext cx="6675120" cy="1600200"/>
+          </a:xfrm>
+          <a:prstGeom prst="roundRect">
+            <a:avLst>
+              <a:gd name="adj" fmla="val 5714"/>
+            </a:avLst>
+          </a:prstGeom>
+          <a:solidFill>
+            <a:srgbClr val="0C1726"/>
+          </a:solidFill>
+          <a:ln/>
+        </p:spPr>
+        <p:txBody>
+          <a:bodyPr/>
+          <a:lstStyle/>
+          <a:p>
+            <a:endParaRPr lang="en-US"/>
+          </a:p>
+        </p:txBody>
+      </p:sp>
+      <p:pic>
+        <p:nvPicPr>
+          <p:cNvPr id="14" name="Image 1" descr="preencoded.png"/>
+          <p:cNvPicPr>
+            <a:picLocks noChangeAspect="1"/>
+          </p:cNvPicPr>
+          <p:nvPr/>
+        </p:nvPicPr>
+        <p:blipFill>
+          <a:blip r:embed="rId3"/>
+          <a:stretch>
+            <a:fillRect/>
+          </a:stretch>
+        </p:blipFill>
+        <p:spPr>
+          <a:xfrm>
+            <a:off x="822960" y="8156448"/>
+            <a:ext cx="237744" cy="237744"/>
+          </a:xfrm>
+          <a:prstGeom prst="rect">
+            <a:avLst/>
+          </a:prstGeom>
+        </p:spPr>
+      </p:pic>
+      <p:sp>
+        <p:nvSpPr>
+          <p:cNvPr id="15" name="Text 11"/>
+          <p:cNvSpPr/>
+          <p:nvPr/>
+        </p:nvSpPr>
+        <p:spPr>
+          <a:xfrm>
+            <a:off x="1152144" y="8138160"/>
+            <a:ext cx="5760720" cy="274320"/>
+          </a:xfrm>
+          <a:prstGeom prst="rect">
+            <a:avLst/>
+          </a:prstGeom>
+          <a:noFill/>
+          <a:ln/>
+        </p:spPr>
+        <p:txBody>
+          <a:bodyPr wrap="square" lIns="0" tIns="0" rIns="0" bIns="0" rtlCol="0" anchor="ctr"/>
+          <a:lstStyle/>
+          <a:p>
+            <a:pPr marL="0" indent="0">
+              <a:buNone/>
+            </a:pPr>
+            <a:r>
+              <a:rPr lang="en-US" sz="1100" b="1" dirty="0">
+                <a:solidFill>
+                  <a:srgbClr val="CADCFC"/>
+                </a:solidFill>
+                <a:latin typeface="Arial" pitchFamily="34" charset="0"/>
+                <a:ea typeface="Arial" pitchFamily="34" charset="-122"/>
+                <a:cs typeface="Arial" pitchFamily="34" charset="-120"/>
+              </a:rPr>
+              <a:t>Tool</a:t>
             </a:r>
             <a:endParaRPr lang="en-US" sz="1100" dirty="0"/>
           </a:p>
@@ -7387,14 +7721,262 @@
       </p:sp>
       <p:sp>
         <p:nvSpPr>
-          <p:cNvPr id="10" name="Shape 7"/>
-          <p:cNvSpPr/>
-          <p:nvPr/>
-        </p:nvSpPr>
-        <p:spPr>
-          <a:xfrm>
-            <a:off x="4069080" y="1783080"/>
-            <a:ext cx="3154680" cy="3108960"/>
+          <p:cNvPr id="16" name="Text 12"/>
+          <p:cNvSpPr/>
+          <p:nvPr/>
+        </p:nvSpPr>
+        <p:spPr>
+          <a:xfrm>
+            <a:off x="822960" y="8503920"/>
+            <a:ext cx="6126480" cy="960120"/>
+          </a:xfrm>
+          <a:prstGeom prst="rect">
+            <a:avLst/>
+          </a:prstGeom>
+          <a:noFill/>
+          <a:ln/>
+        </p:spPr>
+        <p:txBody>
+          <a:bodyPr wrap="square" lIns="0" tIns="0" rIns="0" bIns="0" rtlCol="0" anchor="ctr"/>
+          <a:lstStyle/>
+          <a:p>
+            <a:pPr marL="0" indent="0">
+              <a:lnSpc>
+                <a:spcPct val="120000"/>
+              </a:lnSpc>
+              <a:buNone/>
+            </a:pPr>
+            <a:r>
+              <a:rPr lang="en-US" sz="1050" dirty="0">
+                <a:solidFill>
+                  <a:srgbClr val="FFFFFF"/>
+                </a:solidFill>
+                <a:latin typeface="Arial" pitchFamily="34" charset="0"/>
+                <a:ea typeface="Arial" pitchFamily="34" charset="-122"/>
+                <a:cs typeface="Arial" pitchFamily="34" charset="-120"/>
+              </a:rPr>
+              <a:t>The admin tool (admin-ui page → admin API): create the client, send a test SMS, toggle active. Onboarding done = a correct clients row plus call forwarding set on their line.</a:t>
+            </a:r>
+            <a:endParaRPr lang="en-US" sz="1050" dirty="0"/>
+          </a:p>
+        </p:txBody>
+      </p:sp>
+    </p:spTree>
+    <p:extLst>
+      <p:ext uri="{BB962C8B-B14F-4D97-AF65-F5344CB8AC3E}">
+        <p14:creationId xmlns:p14="http://schemas.microsoft.com/office/powerpoint/2010/main" val="2653040928"/>
+      </p:ext>
+    </p:extLst>
+  </p:cSld>
+  <p:clrMapOvr>
+    <a:masterClrMapping/>
+  </p:clrMapOvr>
+</p:sld>
+</file>
+
+<file path=ppt/slides/slide9.xml><?xml version="1.0" encoding="utf-8"?>
+<p:sld xmlns:a="http://schemas.openxmlformats.org/drawingml/2006/main" xmlns:r="http://schemas.openxmlformats.org/officeDocument/2006/relationships" xmlns:p="http://schemas.openxmlformats.org/presentationml/2006/main">
+  <p:cSld name="Slide 8">
+    <p:bg>
+      <p:bgPr>
+        <a:solidFill>
+          <a:srgbClr val="FFFFFF"/>
+        </a:solidFill>
+        <a:effectLst/>
+      </p:bgPr>
+    </p:bg>
+    <p:spTree>
+      <p:nvGrpSpPr>
+        <p:cNvPr id="1" name=""/>
+        <p:cNvGrpSpPr/>
+        <p:nvPr/>
+      </p:nvGrpSpPr>
+      <p:grpSpPr>
+        <a:xfrm>
+          <a:off x="0" y="0"/>
+          <a:ext cx="0" cy="0"/>
+          <a:chOff x="0" y="0"/>
+          <a:chExt cx="0" cy="0"/>
+        </a:xfrm>
+      </p:grpSpPr>
+      <p:pic>
+        <p:nvPicPr>
+          <p:cNvPr id="2" name="Image 0" descr="preencoded.png"/>
+          <p:cNvPicPr>
+            <a:picLocks noChangeAspect="1"/>
+          </p:cNvPicPr>
+          <p:nvPr/>
+        </p:nvPicPr>
+        <p:blipFill>
+          <a:blip r:embed="rId3"/>
+          <a:stretch>
+            <a:fillRect/>
+          </a:stretch>
+        </p:blipFill>
+        <p:spPr>
+          <a:xfrm>
+            <a:off x="548640" y="457200"/>
+            <a:ext cx="292608" cy="292608"/>
+          </a:xfrm>
+          <a:prstGeom prst="rect">
+            <a:avLst/>
+          </a:prstGeom>
+        </p:spPr>
+      </p:pic>
+      <p:sp>
+        <p:nvSpPr>
+          <p:cNvPr id="3" name="Text 0"/>
+          <p:cNvSpPr/>
+          <p:nvPr/>
+        </p:nvSpPr>
+        <p:spPr>
+          <a:xfrm>
+            <a:off x="932688" y="438912"/>
+            <a:ext cx="4114800" cy="329184"/>
+          </a:xfrm>
+          <a:prstGeom prst="rect">
+            <a:avLst/>
+          </a:prstGeom>
+          <a:noFill/>
+          <a:ln/>
+        </p:spPr>
+        <p:txBody>
+          <a:bodyPr wrap="square" lIns="0" tIns="0" rIns="0" bIns="0" rtlCol="0" anchor="ctr"/>
+          <a:lstStyle/>
+          <a:p>
+            <a:pPr marL="0" indent="0">
+              <a:buNone/>
+            </a:pPr>
+            <a:r>
+              <a:rPr lang="en-US" sz="1100" b="1" dirty="0">
+                <a:solidFill>
+                  <a:srgbClr val="0C1726"/>
+                </a:solidFill>
+                <a:latin typeface="Arial" pitchFamily="34" charset="0"/>
+                <a:ea typeface="Arial" pitchFamily="34" charset="-122"/>
+                <a:cs typeface="Arial" pitchFamily="34" charset="-120"/>
+              </a:rPr>
+              <a:t>Dispango Sales Playbook</a:t>
+            </a:r>
+            <a:endParaRPr lang="en-US" sz="1100" dirty="0"/>
+          </a:p>
+        </p:txBody>
+      </p:sp>
+      <p:sp>
+        <p:nvSpPr>
+          <p:cNvPr id="4" name="Text 1"/>
+          <p:cNvSpPr/>
+          <p:nvPr/>
+        </p:nvSpPr>
+        <p:spPr>
+          <a:xfrm>
+            <a:off x="4846320" y="438912"/>
+            <a:ext cx="2377440" cy="329184"/>
+          </a:xfrm>
+          <a:prstGeom prst="rect">
+            <a:avLst/>
+          </a:prstGeom>
+          <a:noFill/>
+          <a:ln/>
+        </p:spPr>
+        <p:txBody>
+          <a:bodyPr wrap="square" lIns="0" tIns="0" rIns="0" bIns="0" rtlCol="0" anchor="ctr"/>
+          <a:lstStyle/>
+          <a:p>
+            <a:pPr marL="0" indent="0" algn="r">
+              <a:buNone/>
+            </a:pPr>
+            <a:r>
+              <a:rPr lang="en-US" sz="1000" dirty="0">
+                <a:solidFill>
+                  <a:srgbClr val="8A97A8"/>
+                </a:solidFill>
+                <a:latin typeface="Arial" pitchFamily="34" charset="0"/>
+                <a:ea typeface="Arial" pitchFamily="34" charset="-122"/>
+                <a:cs typeface="Arial" pitchFamily="34" charset="-120"/>
+              </a:rPr>
+              <a:t>Cadence &amp; metrics</a:t>
+            </a:r>
+            <a:endParaRPr lang="en-US" sz="1000" dirty="0"/>
+          </a:p>
+        </p:txBody>
+      </p:sp>
+      <p:sp>
+        <p:nvSpPr>
+          <p:cNvPr id="5" name="Shape 2"/>
+          <p:cNvSpPr/>
+          <p:nvPr/>
+        </p:nvSpPr>
+        <p:spPr>
+          <a:xfrm>
+            <a:off x="548640" y="868680"/>
+            <a:ext cx="6675120" cy="12802"/>
+          </a:xfrm>
+          <a:prstGeom prst="rect">
+            <a:avLst/>
+          </a:prstGeom>
+          <a:solidFill>
+            <a:srgbClr val="E7EDF6"/>
+          </a:solidFill>
+          <a:ln/>
+        </p:spPr>
+        <p:txBody>
+          <a:bodyPr/>
+          <a:lstStyle/>
+          <a:p>
+            <a:endParaRPr lang="en-US"/>
+          </a:p>
+        </p:txBody>
+      </p:sp>
+      <p:sp>
+        <p:nvSpPr>
+          <p:cNvPr id="6" name="Text 3"/>
+          <p:cNvSpPr/>
+          <p:nvPr/>
+        </p:nvSpPr>
+        <p:spPr>
+          <a:xfrm>
+            <a:off x="548640" y="1051560"/>
+            <a:ext cx="6675120" cy="548640"/>
+          </a:xfrm>
+          <a:prstGeom prst="rect">
+            <a:avLst/>
+          </a:prstGeom>
+          <a:noFill/>
+          <a:ln/>
+        </p:spPr>
+        <p:txBody>
+          <a:bodyPr wrap="square" lIns="0" tIns="0" rIns="0" bIns="0" rtlCol="0" anchor="ctr"/>
+          <a:lstStyle/>
+          <a:p>
+            <a:pPr marL="0" indent="0">
+              <a:buNone/>
+            </a:pPr>
+            <a:r>
+              <a:rPr lang="en-US" sz="2600" b="1" dirty="0">
+                <a:solidFill>
+                  <a:srgbClr val="0C1726"/>
+                </a:solidFill>
+                <a:latin typeface="Arial" pitchFamily="34" charset="0"/>
+                <a:ea typeface="Arial" pitchFamily="34" charset="-122"/>
+                <a:cs typeface="Arial" pitchFamily="34" charset="-120"/>
+              </a:rPr>
+              <a:t>Run it on a rhythm</a:t>
+            </a:r>
+            <a:endParaRPr lang="en-US" sz="2600" dirty="0"/>
+          </a:p>
+        </p:txBody>
+      </p:sp>
+      <p:sp>
+        <p:nvSpPr>
+          <p:cNvPr id="7" name="Shape 4"/>
+          <p:cNvSpPr/>
+          <p:nvPr/>
+        </p:nvSpPr>
+        <p:spPr>
+          <a:xfrm>
+            <a:off x="548640" y="1783080"/>
+            <a:ext cx="3246120" cy="3108960"/>
           </a:xfrm>
           <a:prstGeom prst="roundRect">
             <a:avLst>
@@ -7411,16 +7993,23 @@
             <a:prstDash val="solid"/>
           </a:ln>
         </p:spPr>
-      </p:sp>
-      <p:sp>
-        <p:nvSpPr>
-          <p:cNvPr id="11" name="Text 8"/>
-          <p:cNvSpPr/>
-          <p:nvPr/>
-        </p:nvSpPr>
-        <p:spPr>
-          <a:xfrm>
-            <a:off x="4343400" y="2011680"/>
+        <p:txBody>
+          <a:bodyPr/>
+          <a:lstStyle/>
+          <a:p>
+            <a:endParaRPr lang="en-US"/>
+          </a:p>
+        </p:txBody>
+      </p:sp>
+      <p:sp>
+        <p:nvSpPr>
+          <p:cNvPr id="8" name="Text 5"/>
+          <p:cNvSpPr/>
+          <p:nvPr/>
+        </p:nvSpPr>
+        <p:spPr>
+          <a:xfrm>
+            <a:off x="822960" y="2011680"/>
             <a:ext cx="2743200" cy="365760"/>
           </a:xfrm>
           <a:prstGeom prst="rect">
@@ -7433,7 +8022,7 @@
           <a:bodyPr wrap="square" lIns="0" tIns="0" rIns="0" bIns="0" rtlCol="0" anchor="ctr"/>
           <a:lstStyle/>
           <a:p>
-            <a:pPr indent="0" marL="0">
+            <a:pPr marL="0" indent="0">
               <a:buNone/>
             </a:pPr>
             <a:r>
@@ -7445,7 +8034,7 @@
                 <a:ea typeface="Arial" pitchFamily="34" charset="-122"/>
                 <a:cs typeface="Arial" pitchFamily="34" charset="-120"/>
               </a:rPr>
-              <a:t>Funnel to track</a:t>
+              <a:t>Weekly rhythm</a:t>
             </a:r>
             <a:endParaRPr lang="en-US" sz="1400" dirty="0"/>
           </a:p>
@@ -7453,14 +8042,14 @@
       </p:sp>
       <p:sp>
         <p:nvSpPr>
-          <p:cNvPr id="12" name="Text 9"/>
-          <p:cNvSpPr/>
-          <p:nvPr/>
-        </p:nvSpPr>
-        <p:spPr>
-          <a:xfrm>
-            <a:off x="4343400" y="2468880"/>
-            <a:ext cx="2651760" cy="2286000"/>
+          <p:cNvPr id="9" name="Text 6"/>
+          <p:cNvSpPr/>
+          <p:nvPr/>
+        </p:nvSpPr>
+        <p:spPr>
+          <a:xfrm>
+            <a:off x="822960" y="2468880"/>
+            <a:ext cx="2697480" cy="2286000"/>
           </a:xfrm>
           <a:prstGeom prst="rect">
             <a:avLst/>
@@ -7488,7 +8077,7 @@
                 <a:ea typeface="Arial" pitchFamily="34" charset="-122"/>
                 <a:cs typeface="Arial" pitchFamily="34" charset="-120"/>
               </a:rPr>
-              <a:t>Lists built  →  calls made</a:t>
+              <a:t>Mon: build/refresh the prospect list</a:t>
             </a:r>
             <a:endParaRPr lang="en-US" sz="1100" dirty="0"/>
           </a:p>
@@ -7509,7 +8098,7 @@
                 <a:ea typeface="Arial" pitchFamily="34" charset="-122"/>
                 <a:cs typeface="Arial" pitchFamily="34" charset="-120"/>
               </a:rPr>
-              <a:t>Calls  →  demos booked</a:t>
+              <a:t>Tue-Thu: cold-call blocks; book Zooms, same day when possible</a:t>
             </a:r>
             <a:endParaRPr lang="en-US" sz="1100" dirty="0"/>
           </a:p>
@@ -7530,7 +8119,7 @@
                 <a:ea typeface="Arial" pitchFamily="34" charset="-122"/>
                 <a:cs typeface="Arial" pitchFamily="34" charset="-120"/>
               </a:rPr>
-              <a:t>Booked  →  demos held</a:t>
+              <a:t>Daily: work the follow-up queue</a:t>
             </a:r>
             <a:endParaRPr lang="en-US" sz="1100" dirty="0"/>
           </a:p>
@@ -7551,7 +8140,7 @@
                 <a:ea typeface="Arial" pitchFamily="34" charset="-122"/>
                 <a:cs typeface="Arial" pitchFamily="34" charset="-120"/>
               </a:rPr>
-              <a:t>Held  →  closed</a:t>
+              <a:t>Wed-Fri: run Zoom demos; start trials before the call ends</a:t>
             </a:r>
             <a:endParaRPr lang="en-US" sz="1100" dirty="0"/>
           </a:p>
@@ -7572,7 +8161,228 @@
                 <a:ea typeface="Arial" pitchFamily="34" charset="-122"/>
                 <a:cs typeface="Arial" pitchFamily="34" charset="-120"/>
               </a:rPr>
-              <a:t>Closed  →  onboarded (time-to-live)</a:t>
+              <a:t>Daily: day 3-5 client check-ins as they come due</a:t>
+            </a:r>
+            <a:endParaRPr lang="en-US" sz="1100" dirty="0"/>
+          </a:p>
+          <a:p>
+            <a:pPr marL="342900" indent="-342900">
+              <a:spcAft>
+                <a:spcPts val="1000"/>
+              </a:spcAft>
+              <a:buSzPct val="100000"/>
+              <a:buChar char="•"/>
+            </a:pPr>
+            <a:r>
+              <a:rPr lang="en-US" sz="1100" dirty="0">
+                <a:solidFill>
+                  <a:srgbClr val="44505F"/>
+                </a:solidFill>
+                <a:latin typeface="Arial" pitchFamily="34" charset="0"/>
+                <a:ea typeface="Arial" pitchFamily="34" charset="-122"/>
+                <a:cs typeface="Arial" pitchFamily="34" charset="-120"/>
+              </a:rPr>
+              <a:t>Fri: close ending trials, onboard, review the funnel</a:t>
+            </a:r>
+            <a:endParaRPr lang="en-US" sz="1100" dirty="0"/>
+          </a:p>
+        </p:txBody>
+      </p:sp>
+      <p:sp>
+        <p:nvSpPr>
+          <p:cNvPr id="10" name="Shape 7"/>
+          <p:cNvSpPr/>
+          <p:nvPr/>
+        </p:nvSpPr>
+        <p:spPr>
+          <a:xfrm>
+            <a:off x="4069080" y="1783080"/>
+            <a:ext cx="3154680" cy="3108960"/>
+          </a:xfrm>
+          <a:prstGeom prst="roundRect">
+            <a:avLst>
+              <a:gd name="adj" fmla="val 3529"/>
+            </a:avLst>
+          </a:prstGeom>
+          <a:solidFill>
+            <a:srgbClr val="F4F8FD"/>
+          </a:solidFill>
+          <a:ln w="12700">
+            <a:solidFill>
+              <a:srgbClr val="E7EDF6"/>
+            </a:solidFill>
+            <a:prstDash val="solid"/>
+          </a:ln>
+        </p:spPr>
+        <p:txBody>
+          <a:bodyPr/>
+          <a:lstStyle/>
+          <a:p>
+            <a:endParaRPr lang="en-US"/>
+          </a:p>
+        </p:txBody>
+      </p:sp>
+      <p:sp>
+        <p:nvSpPr>
+          <p:cNvPr id="11" name="Text 8"/>
+          <p:cNvSpPr/>
+          <p:nvPr/>
+        </p:nvSpPr>
+        <p:spPr>
+          <a:xfrm>
+            <a:off x="4343400" y="2011680"/>
+            <a:ext cx="2743200" cy="365760"/>
+          </a:xfrm>
+          <a:prstGeom prst="rect">
+            <a:avLst/>
+          </a:prstGeom>
+          <a:noFill/>
+          <a:ln/>
+        </p:spPr>
+        <p:txBody>
+          <a:bodyPr wrap="square" lIns="0" tIns="0" rIns="0" bIns="0" rtlCol="0" anchor="ctr"/>
+          <a:lstStyle/>
+          <a:p>
+            <a:pPr marL="0" indent="0">
+              <a:buNone/>
+            </a:pPr>
+            <a:r>
+              <a:rPr lang="en-US" sz="1400" b="1" dirty="0">
+                <a:solidFill>
+                  <a:srgbClr val="0C1726"/>
+                </a:solidFill>
+                <a:latin typeface="Arial" pitchFamily="34" charset="0"/>
+                <a:ea typeface="Arial" pitchFamily="34" charset="-122"/>
+                <a:cs typeface="Arial" pitchFamily="34" charset="-120"/>
+              </a:rPr>
+              <a:t>Funnel to track</a:t>
+            </a:r>
+            <a:endParaRPr lang="en-US" sz="1400" dirty="0"/>
+          </a:p>
+        </p:txBody>
+      </p:sp>
+      <p:sp>
+        <p:nvSpPr>
+          <p:cNvPr id="12" name="Text 9"/>
+          <p:cNvSpPr/>
+          <p:nvPr/>
+        </p:nvSpPr>
+        <p:spPr>
+          <a:xfrm>
+            <a:off x="4343400" y="2468880"/>
+            <a:ext cx="2651760" cy="2286000"/>
+          </a:xfrm>
+          <a:prstGeom prst="rect">
+            <a:avLst/>
+          </a:prstGeom>
+          <a:noFill/>
+          <a:ln/>
+        </p:spPr>
+        <p:txBody>
+          <a:bodyPr wrap="square" lIns="0" tIns="0" rIns="0" bIns="0" rtlCol="0" anchor="t"/>
+          <a:lstStyle/>
+          <a:p>
+            <a:pPr marL="342900" indent="-342900">
+              <a:spcAft>
+                <a:spcPts val="1000"/>
+              </a:spcAft>
+              <a:buSzPct val="100000"/>
+              <a:buChar char="•"/>
+            </a:pPr>
+            <a:r>
+              <a:rPr lang="en-US" sz="1100" dirty="0">
+                <a:solidFill>
+                  <a:srgbClr val="44505F"/>
+                </a:solidFill>
+                <a:latin typeface="Arial" pitchFamily="34" charset="0"/>
+                <a:ea typeface="Arial" pitchFamily="34" charset="-122"/>
+                <a:cs typeface="Arial" pitchFamily="34" charset="-120"/>
+              </a:rPr>
+              <a:t>Lists built → calls made</a:t>
+            </a:r>
+            <a:endParaRPr lang="en-US" sz="1100" dirty="0"/>
+          </a:p>
+          <a:p>
+            <a:pPr marL="342900" indent="-342900">
+              <a:spcAft>
+                <a:spcPts val="1000"/>
+              </a:spcAft>
+              <a:buSzPct val="100000"/>
+              <a:buChar char="•"/>
+            </a:pPr>
+            <a:r>
+              <a:rPr lang="en-US" sz="1100" dirty="0">
+                <a:solidFill>
+                  <a:srgbClr val="44505F"/>
+                </a:solidFill>
+                <a:latin typeface="Arial" pitchFamily="34" charset="0"/>
+                <a:ea typeface="Arial" pitchFamily="34" charset="-122"/>
+                <a:cs typeface="Arial" pitchFamily="34" charset="-120"/>
+              </a:rPr>
+              <a:t>Calls → demos held</a:t>
+            </a:r>
+            <a:endParaRPr lang="en-US" sz="1100" dirty="0"/>
+          </a:p>
+          <a:p>
+            <a:pPr marL="342900" indent="-342900">
+              <a:spcAft>
+                <a:spcPts val="1000"/>
+              </a:spcAft>
+              <a:buSzPct val="100000"/>
+              <a:buChar char="•"/>
+            </a:pPr>
+            <a:r>
+              <a:rPr lang="en-US" sz="1100" dirty="0">
+                <a:solidFill>
+                  <a:srgbClr val="44505F"/>
+                </a:solidFill>
+                <a:latin typeface="Arial" pitchFamily="34" charset="0"/>
+                <a:ea typeface="Arial" pitchFamily="34" charset="-122"/>
+                <a:cs typeface="Arial" pitchFamily="34" charset="-120"/>
+              </a:rPr>
+              <a:t>Demos held → trials started</a:t>
+            </a:r>
+            <a:endParaRPr lang="en-US" sz="1100" dirty="0"/>
+          </a:p>
+          <a:p>
+            <a:pPr marL="342900" indent="-342900">
+              <a:spcAft>
+                <a:spcPts val="1000"/>
+              </a:spcAft>
+              <a:buSzPct val="100000"/>
+              <a:buChar char="•"/>
+            </a:pPr>
+            <a:r>
+              <a:rPr lang="en-US" sz="1100" dirty="0">
+                <a:solidFill>
+                  <a:srgbClr val="44505F"/>
+                </a:solidFill>
+                <a:latin typeface="Arial" pitchFamily="34" charset="0"/>
+                <a:ea typeface="Arial" pitchFamily="34" charset="-122"/>
+                <a:cs typeface="Arial" pitchFamily="34" charset="-120"/>
+              </a:rPr>
+              <a:t>Trials started → converted to paid</a:t>
+            </a:r>
+            <a:endParaRPr lang="en-US" sz="1100" dirty="0"/>
+          </a:p>
+          <a:p>
+            <a:pPr marL="342900" indent="-342900">
+              <a:spcAft>
+                <a:spcPts val="1000"/>
+              </a:spcAft>
+              <a:buSzPct val="100000"/>
+              <a:buChar char="•"/>
+            </a:pPr>
+            <a:r>
+              <a:rPr lang="en-US" sz="1100" dirty="0">
+                <a:solidFill>
+                  <a:srgbClr val="44505F"/>
+                </a:solidFill>
+                <a:latin typeface="Arial" pitchFamily="34" charset="0"/>
+                <a:ea typeface="Arial" pitchFamily="34" charset="-122"/>
+                <a:cs typeface="Arial" pitchFamily="34" charset="-120"/>
+              </a:rPr>
+              <a:t>Converted → onboarded</a:t>
             </a:r>
             <a:endParaRPr lang="en-US" sz="1100" dirty="0"/>
           </a:p>
@@ -7599,6 +8409,13 @@
           </a:solidFill>
           <a:ln/>
         </p:spPr>
+        <p:txBody>
+          <a:bodyPr/>
+          <a:lstStyle/>
+          <a:p>
+            <a:endParaRPr lang="en-US"/>
+          </a:p>
+        </p:txBody>
       </p:sp>
       <p:sp>
         <p:nvSpPr>
@@ -7621,7 +8438,7 @@
           <a:bodyPr wrap="square" lIns="0" tIns="0" rIns="0" bIns="0" rtlCol="0" anchor="ctr"/>
           <a:lstStyle/>
           <a:p>
-            <a:pPr indent="0" marL="0">
+            <a:pPr marL="0" indent="0">
               <a:buNone/>
             </a:pPr>
             <a:r>
@@ -7660,7 +8477,7 @@
           <a:bodyPr wrap="square" lIns="0" tIns="0" rIns="0" bIns="0" rtlCol="0" anchor="ctr"/>
           <a:lstStyle/>
           <a:p>
-            <a:pPr indent="0" marL="0">
+            <a:pPr marL="0" indent="0">
               <a:lnSpc>
                 <a:spcPct val="120000"/>
               </a:lnSpc>
@@ -7675,13 +8492,18 @@
                 <a:ea typeface="Arial" pitchFamily="34" charset="-122"/>
                 <a:cs typeface="Arial" pitchFamily="34" charset="-120"/>
               </a:rPr>
-              <a:t>Demos booked per week. Everything upstream (lists, calls, follow-ups) exists to grow it; everything downstream (close, onboard) converts it. Review it every Friday.</a:t>
+              <a:t>Trials started per week. Everything upstream (lists, calls, demos) exists to grow it; everything downstream (close, onboard) converts it. Review it every Friday.</a:t>
             </a:r>
             <a:endParaRPr lang="en-US" sz="1100" dirty="0"/>
           </a:p>
         </p:txBody>
       </p:sp>
     </p:spTree>
+    <p:extLst>
+      <p:ext uri="{BB962C8B-B14F-4D97-AF65-F5344CB8AC3E}">
+        <p14:creationId xmlns:p14="http://schemas.microsoft.com/office/powerpoint/2010/main" val="1976911492"/>
+      </p:ext>
+    </p:extLst>
   </p:cSld>
   <p:clrMapOvr>
     <a:masterClrMapping/>
@@ -7982,4 +8804,341 @@
     </a:ext>
   </a:extLst>
 </a:theme>
+</file>
+
+<file path=ppt/theme/theme2.xml><?xml version="1.0" encoding="utf-8"?>
+<a:theme xmlns:a="http://schemas.openxmlformats.org/drawingml/2006/main" name="Office Theme">
+  <a:themeElements>
+    <a:clrScheme name="Office">
+      <a:dk1>
+        <a:sysClr val="windowText" lastClr="000000"/>
+      </a:dk1>
+      <a:lt1>
+        <a:sysClr val="window" lastClr="FFFFFF"/>
+      </a:lt1>
+      <a:dk2>
+        <a:srgbClr val="0E2841"/>
+      </a:dk2>
+      <a:lt2>
+        <a:srgbClr val="E8E8E8"/>
+      </a:lt2>
+      <a:accent1>
+        <a:srgbClr val="156082"/>
+      </a:accent1>
+      <a:accent2>
+        <a:srgbClr val="E97132"/>
+      </a:accent2>
+      <a:accent3>
+        <a:srgbClr val="196B24"/>
+      </a:accent3>
+      <a:accent4>
+        <a:srgbClr val="0F9ED5"/>
+      </a:accent4>
+      <a:accent5>
+        <a:srgbClr val="A02B93"/>
+      </a:accent5>
+      <a:accent6>
+        <a:srgbClr val="4EA72E"/>
+      </a:accent6>
+      <a:hlink>
+        <a:srgbClr val="467886"/>
+      </a:hlink>
+      <a:folHlink>
+        <a:srgbClr val="96607D"/>
+      </a:folHlink>
+    </a:clrScheme>
+    <a:fontScheme name="Office">
+      <a:majorFont>
+        <a:latin typeface="Aptos Display" panose="02110004020202020204"/>
+        <a:ea typeface=""/>
+        <a:cs typeface=""/>
+        <a:font script="Jpan" typeface="游ゴシック Light"/>
+        <a:font script="Hang" typeface="맑은 고딕"/>
+        <a:font script="Hans" typeface="等线 Light"/>
+        <a:font script="Hant" typeface="新細明體"/>
+        <a:font script="Arab" typeface="Times New Roman"/>
+        <a:font script="Hebr" typeface="Times New Roman"/>
+        <a:font script="Thai" typeface="Angsana New"/>
+        <a:font script="Ethi" typeface="Nyala"/>
+        <a:font script="Beng" typeface="Vrinda"/>
+        <a:font script="Gujr" typeface="Shruti"/>
+        <a:font script="Khmr" typeface="MoolBoran"/>
+        <a:font script="Knda" typeface="Tunga"/>
+        <a:font script="Guru" typeface="Raavi"/>
+        <a:font script="Cans" typeface="Euphemia"/>
+        <a:font script="Cher" typeface="Plantagenet Cherokee"/>
+        <a:font script="Yiii" typeface="Microsoft Yi Baiti"/>
+        <a:font script="Tibt" typeface="Microsoft Himalaya"/>
+        <a:font script="Thaa" typeface="MV Boli"/>
+        <a:font script="Deva" typeface="Mangal"/>
+        <a:font script="Telu" typeface="Gautami"/>
+        <a:font script="Taml" typeface="Latha"/>
+        <a:font script="Syrc" typeface="Estrangelo Edessa"/>
+        <a:font script="Orya" typeface="Kalinga"/>
+        <a:font script="Mlym" typeface="Kartika"/>
+        <a:font script="Laoo" typeface="DokChampa"/>
+        <a:font script="Sinh" typeface="Iskoola Pota"/>
+        <a:font script="Mong" typeface="Mongolian Baiti"/>
+        <a:font script="Viet" typeface="Times New Roman"/>
+        <a:font script="Uigh" typeface="Microsoft Uighur"/>
+        <a:font script="Geor" typeface="Sylfaen"/>
+        <a:font script="Armn" typeface="Arial"/>
+        <a:font script="Bugi" typeface="Leelawadee UI"/>
+        <a:font script="Bopo" typeface="Microsoft JhengHei"/>
+        <a:font script="Java" typeface="Javanese Text"/>
+        <a:font script="Lisu" typeface="Segoe UI"/>
+        <a:font script="Mymr" typeface="Myanmar Text"/>
+        <a:font script="Nkoo" typeface="Ebrima"/>
+        <a:font script="Olck" typeface="Nirmala UI"/>
+        <a:font script="Osma" typeface="Ebrima"/>
+        <a:font script="Phag" typeface="Phagspa"/>
+        <a:font script="Syrn" typeface="Estrangelo Edessa"/>
+        <a:font script="Syrj" typeface="Estrangelo Edessa"/>
+        <a:font script="Syre" typeface="Estrangelo Edessa"/>
+        <a:font script="Sora" typeface="Nirmala UI"/>
+        <a:font script="Tale" typeface="Microsoft Tai Le"/>
+        <a:font script="Talu" typeface="Microsoft New Tai Lue"/>
+        <a:font script="Tfng" typeface="Ebrima"/>
+      </a:majorFont>
+      <a:minorFont>
+        <a:latin typeface="Aptos" panose="02110004020202020204"/>
+        <a:ea typeface=""/>
+        <a:cs typeface=""/>
+        <a:font script="Jpan" typeface="游ゴシック"/>
+        <a:font script="Hang" typeface="맑은 고딕"/>
+        <a:font script="Hans" typeface="等线"/>
+        <a:font script="Hant" typeface="新細明體"/>
+        <a:font script="Arab" typeface="Arial"/>
+        <a:font script="Hebr" typeface="Arial"/>
+        <a:font script="Thai" typeface="Cordia New"/>
+        <a:font script="Ethi" typeface="Nyala"/>
+        <a:font script="Beng" typeface="Vrinda"/>
+        <a:font script="Gujr" typeface="Shruti"/>
+        <a:font script="Khmr" typeface="DaunPenh"/>
+        <a:font script="Knda" typeface="Tunga"/>
+        <a:font script="Guru" typeface="Raavi"/>
+        <a:font script="Cans" typeface="Euphemia"/>
+        <a:font script="Cher" typeface="Plantagenet Cherokee"/>
+        <a:font script="Yiii" typeface="Microsoft Yi Baiti"/>
+        <a:font script="Tibt" typeface="Microsoft Himalaya"/>
+        <a:font script="Thaa" typeface="MV Boli"/>
+        <a:font script="Deva" typeface="Mangal"/>
+        <a:font script="Telu" typeface="Gautami"/>
+        <a:font script="Taml" typeface="Latha"/>
+        <a:font script="Syrc" typeface="Estrangelo Edessa"/>
+        <a:font script="Orya" typeface="Kalinga"/>
+        <a:font script="Mlym" typeface="Kartika"/>
+        <a:font script="Laoo" typeface="DokChampa"/>
+        <a:font script="Sinh" typeface="Iskoola Pota"/>
+        <a:font script="Mong" typeface="Mongolian Baiti"/>
+        <a:font script="Viet" typeface="Arial"/>
+        <a:font script="Uigh" typeface="Microsoft Uighur"/>
+        <a:font script="Geor" typeface="Sylfaen"/>
+        <a:font script="Armn" typeface="Arial"/>
+        <a:font script="Bugi" typeface="Leelawadee UI"/>
+        <a:font script="Bopo" typeface="Microsoft JhengHei"/>
+        <a:font script="Java" typeface="Javanese Text"/>
+        <a:font script="Lisu" typeface="Segoe UI"/>
+        <a:font script="Mymr" typeface="Myanmar Text"/>
+        <a:font script="Nkoo" typeface="Ebrima"/>
+        <a:font script="Olck" typeface="Nirmala UI"/>
+        <a:font script="Osma" typeface="Ebrima"/>
+        <a:font script="Phag" typeface="Phagspa"/>
+        <a:font script="Syrn" typeface="Estrangelo Edessa"/>
+        <a:font script="Syrj" typeface="Estrangelo Edessa"/>
+        <a:font script="Syre" typeface="Estrangelo Edessa"/>
+        <a:font script="Sora" typeface="Nirmala UI"/>
+        <a:font script="Tale" typeface="Microsoft Tai Le"/>
+        <a:font script="Talu" typeface="Microsoft New Tai Lue"/>
+        <a:font script="Tfng" typeface="Ebrima"/>
+      </a:minorFont>
+    </a:fontScheme>
+    <a:fmtScheme name="Office">
+      <a:fillStyleLst>
+        <a:solidFill>
+          <a:schemeClr val="phClr"/>
+        </a:solidFill>
+        <a:gradFill rotWithShape="1">
+          <a:gsLst>
+            <a:gs pos="0">
+              <a:schemeClr val="phClr">
+                <a:lumMod val="110000"/>
+                <a:satMod val="105000"/>
+                <a:tint val="67000"/>
+              </a:schemeClr>
+            </a:gs>
+            <a:gs pos="50000">
+              <a:schemeClr val="phClr">
+                <a:lumMod val="105000"/>
+                <a:satMod val="103000"/>
+                <a:tint val="73000"/>
+              </a:schemeClr>
+            </a:gs>
+            <a:gs pos="100000">
+              <a:schemeClr val="phClr">
+                <a:lumMod val="105000"/>
+                <a:satMod val="109000"/>
+                <a:tint val="81000"/>
+              </a:schemeClr>
+            </a:gs>
+          </a:gsLst>
+          <a:lin ang="5400000" scaled="0"/>
+        </a:gradFill>
+        <a:gradFill rotWithShape="1">
+          <a:gsLst>
+            <a:gs pos="0">
+              <a:schemeClr val="phClr">
+                <a:satMod val="103000"/>
+                <a:lumMod val="102000"/>
+                <a:tint val="94000"/>
+              </a:schemeClr>
+            </a:gs>
+            <a:gs pos="50000">
+              <a:schemeClr val="phClr">
+                <a:satMod val="110000"/>
+                <a:lumMod val="100000"/>
+                <a:shade val="100000"/>
+              </a:schemeClr>
+            </a:gs>
+            <a:gs pos="100000">
+              <a:schemeClr val="phClr">
+                <a:lumMod val="99000"/>
+                <a:satMod val="120000"/>
+                <a:shade val="78000"/>
+              </a:schemeClr>
+            </a:gs>
+          </a:gsLst>
+          <a:lin ang="5400000" scaled="0"/>
+        </a:gradFill>
+      </a:fillStyleLst>
+      <a:lnStyleLst>
+        <a:ln w="12700" cap="flat" cmpd="sng" algn="ctr">
+          <a:solidFill>
+            <a:schemeClr val="phClr"/>
+          </a:solidFill>
+          <a:prstDash val="solid"/>
+          <a:miter lim="800000"/>
+        </a:ln>
+        <a:ln w="19050" cap="flat" cmpd="sng" algn="ctr">
+          <a:solidFill>
+            <a:schemeClr val="phClr"/>
+          </a:solidFill>
+          <a:prstDash val="solid"/>
+          <a:miter lim="800000"/>
+        </a:ln>
+        <a:ln w="25400" cap="flat" cmpd="sng" algn="ctr">
+          <a:solidFill>
+            <a:schemeClr val="phClr"/>
+          </a:solidFill>
+          <a:prstDash val="solid"/>
+          <a:miter lim="800000"/>
+        </a:ln>
+      </a:lnStyleLst>
+      <a:effectStyleLst>
+        <a:effectStyle>
+          <a:effectLst/>
+        </a:effectStyle>
+        <a:effectStyle>
+          <a:effectLst/>
+        </a:effectStyle>
+        <a:effectStyle>
+          <a:effectLst>
+            <a:outerShdw blurRad="57150" dist="19050" dir="5400000" algn="ctr" rotWithShape="0">
+              <a:srgbClr val="000000">
+                <a:alpha val="63000"/>
+              </a:srgbClr>
+            </a:outerShdw>
+          </a:effectLst>
+        </a:effectStyle>
+      </a:effectStyleLst>
+      <a:bgFillStyleLst>
+        <a:solidFill>
+          <a:schemeClr val="phClr"/>
+        </a:solidFill>
+        <a:solidFill>
+          <a:schemeClr val="phClr">
+            <a:tint val="95000"/>
+            <a:satMod val="170000"/>
+          </a:schemeClr>
+        </a:solidFill>
+        <a:gradFill rotWithShape="1">
+          <a:gsLst>
+            <a:gs pos="0">
+              <a:schemeClr val="phClr">
+                <a:tint val="93000"/>
+                <a:satMod val="150000"/>
+                <a:shade val="98000"/>
+                <a:lumMod val="102000"/>
+              </a:schemeClr>
+            </a:gs>
+            <a:gs pos="50000">
+              <a:schemeClr val="phClr">
+                <a:tint val="98000"/>
+                <a:satMod val="130000"/>
+                <a:shade val="90000"/>
+                <a:lumMod val="103000"/>
+              </a:schemeClr>
+            </a:gs>
+            <a:gs pos="100000">
+              <a:schemeClr val="phClr">
+                <a:shade val="63000"/>
+                <a:satMod val="120000"/>
+              </a:schemeClr>
+            </a:gs>
+          </a:gsLst>
+          <a:lin ang="5400000" scaled="0"/>
+        </a:gradFill>
+      </a:bgFillStyleLst>
+    </a:fmtScheme>
+  </a:themeElements>
+  <a:objectDefaults>
+    <a:lnDef>
+      <a:spPr/>
+      <a:bodyPr/>
+      <a:lstStyle/>
+      <a:style>
+        <a:lnRef idx="2">
+          <a:schemeClr val="accent1"/>
+        </a:lnRef>
+        <a:fillRef idx="0">
+          <a:schemeClr val="accent1"/>
+        </a:fillRef>
+        <a:effectRef idx="1">
+          <a:schemeClr val="accent1"/>
+        </a:effectRef>
+        <a:fontRef idx="minor">
+          <a:schemeClr val="tx1"/>
+        </a:fontRef>
+      </a:style>
+    </a:lnDef>
+  </a:objectDefaults>
+  <a:extraClrSchemeLst/>
+  <a:extLst>
+    <a:ext uri="{05A4C25C-085E-4340-85A3-A5531E510DB2}">
+      <thm15:themeFamily xmlns:thm15="http://schemas.microsoft.com/office/thememl/2012/main" name="Office Theme" id="{2E142A2C-CD16-42D6-873A-C26D2A0506FA}" vid="{1BDDFF52-6CD6-40A5-AB3C-68EB2F1E4D0A}"/>
+    </a:ext>
+  </a:extLst>
+</a:theme>
+</file>
+
+<file path=ppt/webextensions/taskpanes.xml><?xml version="1.0" encoding="utf-8"?>
+<wetp:taskpanes xmlns:wetp="http://schemas.microsoft.com/office/webextensions/taskpanes/2010/11">
+  <wetp:taskpane dockstate="right" visibility="0" width="350" row="0">
+    <wetp:webextensionref xmlns:r="http://schemas.openxmlformats.org/officeDocument/2006/relationships" r:id="rId1"/>
+  </wetp:taskpane>
+</wetp:taskpanes>
+</file>
+
+<file path=ppt/webextensions/webextension1.xml><?xml version="1.0" encoding="utf-8"?>
+<we:webextension xmlns:we="http://schemas.microsoft.com/office/webextensions/webextension/2010/11" id="{A918515D-35E4-6243-AB12-24A4B7ED72EC}">
+  <we:reference id="WA200010001" version="1.0.0.1" store="Omex" storeType="OMEX"/>
+  <we:alternateReferences>
+    <we:reference id="WA200010001" version="1.0.0.1" store="WA200010001" storeType="OMEX"/>
+  </we:alternateReferences>
+  <we:properties>
+    <we:property name="claude.fileId" value="&quot;b199a446-0478-4c74-90bd-f49d0888198f&quot;"/>
+  </we:properties>
+  <we:bindings/>
+  <we:snapshot xmlns:r="http://schemas.openxmlformats.org/officeDocument/2006/relationships"/>
+</we:webextension>
 </file>
</xml_diff>